<commit_message>
Ep4 / Week 3: Monday line pull (Houston-Tech total + ML posted, score call Tech 33-20), deck text synced to the moves (Tech -7.5, LSU -3, MSST total 59.5), superdogs +27.5 / +28.5, notes synced slide by slide + full-slate machine board appendix (57 games), deck pushed to the Ep4 Slides file
Co-Authored-By: Claude Fable 5.1 <noreply@anthropic.com>
</commit_message>
<xml_diff>
--- a/decks/2026_Week3_Episode4.pptx
+++ b/decks/2026_Week3_Episode4.pptx
@@ -12246,7 +12246,7 @@
                 </a:solidFill>
                 <a:latin typeface="Arial"/>
               </a:rPr>
-              <a:t>1.4 to South Carolina — no play · Monster Under 58.5</a:t>
+              <a:t>1.4 to South Carolina — no play · Monster Under 59.5</a:t>
             </a:r>
           </a:p>
         </p:txBody>
@@ -12465,7 +12465,7 @@
                 </a:solidFill>
                 <a:latin typeface="Arial"/>
               </a:rPr>
-              <a:t>–3.5</a:t>
+              <a:t>–3.5 / –3.5</a:t>
             </a:r>
           </a:p>
         </p:txBody>
@@ -12500,7 +12500,7 @@
                 </a:solidFill>
                 <a:latin typeface="Arial"/>
               </a:rPr>
-              <a:t>market (DK / Bovada) · DK South Carolina -175 / Mississippi State +145</a:t>
+              <a:t>market (DK / Bovada) · DK South Carolina -162 / Mississippi State +136 · Bov South Carolina -165 / Mississippi State +140</a:t>
             </a:r>
           </a:p>
         </p:txBody>
@@ -15111,7 +15111,7 @@
                 </a:solidFill>
                 <a:latin typeface="Arial"/>
               </a:rPr>
-              <a:t>+2.5</a:t>
+              <a:t>+2.5 / +2.5</a:t>
             </a:r>
           </a:p>
         </p:txBody>
@@ -15146,7 +15146,7 @@
                 </a:solidFill>
                 <a:latin typeface="Arial"/>
               </a:rPr>
-              <a:t>market (DK / Bovada) · DK Auburn +114 / Florida -135</a:t>
+              <a:t>market (DK / Bovada) · DK Auburn +120 / Florida -142 · Bov Auburn +115 / Florida -135</a:t>
             </a:r>
           </a:p>
         </p:txBody>
@@ -17538,7 +17538,7 @@
                 </a:solidFill>
                 <a:latin typeface="Arial"/>
               </a:rPr>
-              <a:t>2.7 to LSU — quibble · Monster Under 58.5</a:t>
+              <a:t>2.2 to LSU — quibble · Monster Under 58.5</a:t>
             </a:r>
           </a:p>
         </p:txBody>
@@ -17757,7 +17757,7 @@
                 </a:solidFill>
                 <a:latin typeface="Arial"/>
               </a:rPr>
-              <a:t>+2.5</a:t>
+              <a:t>+3 / +3</a:t>
             </a:r>
           </a:p>
         </p:txBody>
@@ -17792,7 +17792,7 @@
                 </a:solidFill>
                 <a:latin typeface="Arial"/>
               </a:rPr>
-              <a:t>market (DK / Bovada) · DK Ole Miss +120 / LSU -142</a:t>
+              <a:t>market (DK / Bovada) · DK Ole Miss +130 / LSU -155 · Bov Ole Miss +130 / LSU -165</a:t>
             </a:r>
           </a:p>
         </p:txBody>
@@ -18090,7 +18090,7 @@
                 </a:solidFill>
                 <a:latin typeface="Arial"/>
               </a:rPr>
-              <a:t>LINE MOVE  –1.5 → +2.5 · CLV +4</a:t>
+              <a:t>LINE MOVE  –1.5 → +3 · CLV +4.5</a:t>
             </a:r>
           </a:p>
         </p:txBody>
@@ -18125,7 +18125,7 @@
                 </a:solidFill>
                 <a:latin typeface="Arial"/>
               </a:rPr>
-              <a:t>Line movement: first-seen –1.5 (Aug 23) → now +2.5 · CLV +4</a:t>
+              <a:t>Line movement: first-seen –1.5 (Aug 23) → now +3 · CLV +4.5</a:t>
             </a:r>
           </a:p>
         </p:txBody>
@@ -24881,7 +24881,7 @@
                 </a:solidFill>
                 <a:latin typeface="Arial"/>
               </a:rPr>
-              <a:t>total not posted yet</a:t>
+              <a:t>Texas Tech 33 – Houston 20</a:t>
             </a:r>
           </a:p>
         </p:txBody>
@@ -24916,7 +24916,7 @@
                 </a:solidFill>
                 <a:latin typeface="Arial"/>
               </a:rPr>
-              <a:t>market –9.5</a:t>
+              <a:t>market –7.5</a:t>
             </a:r>
           </a:p>
         </p:txBody>
@@ -26056,7 +26056,7 @@
                 </a:solidFill>
                 <a:latin typeface="Arial"/>
               </a:rPr>
-              <a:t>market +2.5</a:t>
+              <a:t>market +3</a:t>
             </a:r>
           </a:p>
         </p:txBody>
@@ -26170,7 +26170,7 @@
                 </a:solidFill>
                 <a:latin typeface="Arial"/>
               </a:rPr>
-              <a:t>Sacramento State +26.5 vs North Dakota State · ML +2000</a:t>
+              <a:t>Sacramento State +27.5 vs North Dakota State · ML +2500</a:t>
             </a:r>
           </a:p>
         </p:txBody>
@@ -26240,7 +26240,7 @@
                 </a:solidFill>
                 <a:latin typeface="Arial"/>
               </a:rPr>
-              <a:t>Utah State +27.5 at #17 Utah · ML +2000</a:t>
+              <a:t>Utah State +28.5 at #17 Utah · ML +2000</a:t>
             </a:r>
           </a:p>
         </p:txBody>
@@ -29718,7 +29718,7 @@
                 </a:solidFill>
                 <a:latin typeface="Arial"/>
               </a:rPr>
-              <a:t>Texas Tech –13   ·   –9.5</a:t>
+              <a:t>Texas Tech –13   ·   –7.5 / –7.5</a:t>
             </a:r>
           </a:p>
         </p:txBody>
@@ -30038,7 +30038,7 @@
                 </a:solidFill>
                 <a:latin typeface="Arial"/>
               </a:rPr>
-              <a:t>Louisville –1   ·   –1.5</a:t>
+              <a:t>Louisville –1   ·   –1.5 / –1</a:t>
             </a:r>
           </a:p>
         </p:txBody>
@@ -30358,7 +30358,7 @@
                 </a:solidFill>
                 <a:latin typeface="Arial"/>
               </a:rPr>
-              <a:t>South Carolina –5   ·   –3.5</a:t>
+              <a:t>South Carolina –5   ·   –3.5 / –3.5</a:t>
             </a:r>
           </a:p>
         </p:txBody>
@@ -30678,7 +30678,7 @@
                 </a:solidFill>
                 <a:latin typeface="Arial"/>
               </a:rPr>
-              <a:t>Auburn –0.5   ·   +2.5</a:t>
+              <a:t>Auburn –0.5   ·   +2.5 / +2.5</a:t>
             </a:r>
           </a:p>
         </p:txBody>
@@ -30998,7 +30998,7 @@
                 </a:solidFill>
                 <a:latin typeface="Arial"/>
               </a:rPr>
-              <a:t>LSU –5   ·   +2.5</a:t>
+              <a:t>LSU –5   ·   +3 / +3</a:t>
             </a:r>
           </a:p>
         </p:txBody>
@@ -31068,7 +31068,7 @@
                 </a:solidFill>
                 <a:latin typeface="Arial"/>
               </a:rPr>
-              <a:t>Machine = our in-season rating + 2.5 home field · lines as of Sep 13</a:t>
+              <a:t>Machine = our in-season rating + 2.5 home field · lines as of Sep 14</a:t>
             </a:r>
           </a:p>
         </p:txBody>
@@ -32968,7 +32968,7 @@
                 </a:solidFill>
                 <a:latin typeface="Arial"/>
               </a:rPr>
-              <a:t>Four points to Houston since August</a:t>
+              <a:t>Six points to Houston since August</a:t>
             </a:r>
           </a:p>
         </p:txBody>
@@ -33047,7 +33047,7 @@
                 </a:solidFill>
                 <a:latin typeface="Arial"/>
               </a:rPr>
-              <a:t>3.5 to Tech — a small lean</a:t>
+              <a:t>5.5 to Tech — a small lean</a:t>
             </a:r>
           </a:p>
         </p:txBody>
@@ -33266,7 +33266,7 @@
                 </a:solidFill>
                 <a:latin typeface="Arial"/>
               </a:rPr>
-              <a:t>–9.5</a:t>
+              <a:t>–7.5 / –7.5</a:t>
             </a:r>
           </a:p>
         </p:txBody>
@@ -33301,7 +33301,7 @@
                 </a:solidFill>
                 <a:latin typeface="Arial"/>
               </a:rPr>
-              <a:t>market (DK / Bovada) · ML not posted</a:t>
+              <a:t>market (DK / Bovada) · Bov Texas Tech -300 / Houston +270</a:t>
             </a:r>
           </a:p>
         </p:txBody>
@@ -33330,13 +33330,13 @@
           <a:p>
             <a:pPr algn="l"/>
             <a:r>
-              <a:rPr sz="1500" b="1" i="0">
-                <a:solidFill>
-                  <a:srgbClr val="CADCFC"/>
-                </a:solidFill>
-                <a:latin typeface="Arial"/>
-              </a:rPr>
-              <a:t>total not posted yet</a:t>
+              <a:rPr sz="1300" b="1" i="0">
+                <a:solidFill>
+                  <a:srgbClr val="F47321"/>
+                </a:solidFill>
+                <a:latin typeface="Arial"/>
+              </a:rPr>
+              <a:t>Texas Tech 33 – Houston 20</a:t>
             </a:r>
           </a:p>
         </p:txBody>
@@ -33599,7 +33599,7 @@
                 </a:solidFill>
                 <a:latin typeface="Arial"/>
               </a:rPr>
-              <a:t>LINE MOVE  –13.5 → –9.5 · CLV +4</a:t>
+              <a:t>LINE MOVE  –13.5 → –7.5 · CLV +6</a:t>
             </a:r>
           </a:p>
         </p:txBody>
@@ -33634,7 +33634,7 @@
                 </a:solidFill>
                 <a:latin typeface="Arial"/>
               </a:rPr>
-              <a:t>Line movement: first-seen –13.5 (Aug 23) → now –9.5 · CLV +4</a:t>
+              <a:t>Line movement: first-seen –13.5 (Aug 23) → now –7.5 · CLV +6</a:t>
             </a:r>
           </a:p>
         </p:txBody>
@@ -35912,7 +35912,7 @@
                 </a:solidFill>
                 <a:latin typeface="Arial"/>
               </a:rPr>
-              <a:t>–1.5</a:t>
+              <a:t>–1.5 / –1</a:t>
             </a:r>
           </a:p>
         </p:txBody>
@@ -35947,7 +35947,7 @@
                 </a:solidFill>
                 <a:latin typeface="Arial"/>
               </a:rPr>
-              <a:t>market (DK / Bovada) · DK Louisville -120 / SMU +100</a:t>
+              <a:t>market (DK / Bovada) · DK Louisville -115 / SMU -105 · Bov Louisville -115 / SMU -105</a:t>
             </a:r>
           </a:p>
         </p:txBody>

</xml_diff>

<commit_message>
Deck template: LUCK column (actual minus deserved margin per rated game) on the Top 25 slide and deserved margins on the receipts rows + summary bar; Ep4 deck rebuilt
Co-Authored-By: Claude Fable 5.1 <noreply@anthropic.com>
</commit_message>
<xml_diff>
--- a/decks/2026_Week3_Episode4.pptx
+++ b/decks/2026_Week3_Episode4.pptx
@@ -3216,7 +3216,7 @@
                 </a:solidFill>
                 <a:latin typeface="Arial"/>
               </a:rPr>
-              <a:t>Machine rating · Δ vs preseason · AP week 3 poll</a:t>
+              <a:t>Machine rating · Δ vs preseason · luck = actual minus deserved margin per game · AP week 3 poll</a:t>
             </a:r>
           </a:p>
         </p:txBody>
@@ -3229,8 +3229,8 @@
         </p:nvSpPr>
         <p:spPr>
           <a:xfrm>
-            <a:off x="3840480" y="1591056"/>
-            <a:ext cx="685800" cy="201168"/>
+            <a:off x="3611879" y="1591056"/>
+            <a:ext cx="548640" cy="201168"/>
           </a:xfrm>
           <a:prstGeom prst="rect">
             <a:avLst/>
@@ -3264,8 +3264,8 @@
         </p:nvSpPr>
         <p:spPr>
           <a:xfrm>
-            <a:off x="4526280" y="1591056"/>
-            <a:ext cx="685800" cy="201168"/>
+            <a:off x="4160520" y="1591056"/>
+            <a:ext cx="548640" cy="201168"/>
           </a:xfrm>
           <a:prstGeom prst="rect">
             <a:avLst/>
@@ -3299,8 +3299,8 @@
         </p:nvSpPr>
         <p:spPr>
           <a:xfrm>
-            <a:off x="5212080" y="1591056"/>
-            <a:ext cx="594360" cy="201168"/>
+            <a:off x="4709160" y="1591056"/>
+            <a:ext cx="548640" cy="201168"/>
           </a:xfrm>
           <a:prstGeom prst="rect">
             <a:avLst/>
@@ -3321,6 +3321,41 @@
                 </a:solidFill>
                 <a:latin typeface="Arial"/>
               </a:rPr>
+              <a:t>LUCK</a:t>
+            </a:r>
+          </a:p>
+        </p:txBody>
+      </p:sp>
+      <p:sp>
+        <p:nvSpPr>
+          <p:cNvPr id="8" name="TextBox 7"/>
+          <p:cNvSpPr txBox="1"/>
+          <p:nvPr/>
+        </p:nvSpPr>
+        <p:spPr>
+          <a:xfrm>
+            <a:off x="5257800" y="1591056"/>
+            <a:ext cx="548640" cy="201168"/>
+          </a:xfrm>
+          <a:prstGeom prst="rect">
+            <a:avLst/>
+          </a:prstGeom>
+          <a:noFill/>
+        </p:spPr>
+        <p:txBody>
+          <a:bodyPr wrap="square" lIns="0" rIns="0" tIns="0" bIns="0">
+            <a:spAutoFit/>
+          </a:bodyPr>
+          <a:lstStyle/>
+          <a:p>
+            <a:pPr algn="r"/>
+            <a:r>
+              <a:rPr sz="800" b="1" i="0">
+                <a:solidFill>
+                  <a:srgbClr val="CADCFC"/>
+                </a:solidFill>
+                <a:latin typeface="Arial"/>
+              </a:rPr>
               <a:t>VOTERS</a:t>
             </a:r>
           </a:p>
@@ -3328,14 +3363,14 @@
       </p:sp>
       <p:sp>
         <p:nvSpPr>
-          <p:cNvPr id="8" name="TextBox 7"/>
-          <p:cNvSpPr txBox="1"/>
-          <p:nvPr/>
-        </p:nvSpPr>
-        <p:spPr>
-          <a:xfrm>
-            <a:off x="9372600" y="1591056"/>
-            <a:ext cx="685800" cy="201168"/>
+          <p:cNvPr id="9" name="TextBox 8"/>
+          <p:cNvSpPr txBox="1"/>
+          <p:nvPr/>
+        </p:nvSpPr>
+        <p:spPr>
+          <a:xfrm>
+            <a:off x="9144000" y="1591056"/>
+            <a:ext cx="548640" cy="201168"/>
           </a:xfrm>
           <a:prstGeom prst="rect">
             <a:avLst/>
@@ -3363,14 +3398,14 @@
       </p:sp>
       <p:sp>
         <p:nvSpPr>
-          <p:cNvPr id="9" name="TextBox 8"/>
-          <p:cNvSpPr txBox="1"/>
-          <p:nvPr/>
-        </p:nvSpPr>
-        <p:spPr>
-          <a:xfrm>
-            <a:off x="10058400" y="1591056"/>
-            <a:ext cx="685800" cy="201168"/>
+          <p:cNvPr id="10" name="TextBox 9"/>
+          <p:cNvSpPr txBox="1"/>
+          <p:nvPr/>
+        </p:nvSpPr>
+        <p:spPr>
+          <a:xfrm>
+            <a:off x="9692640" y="1591056"/>
+            <a:ext cx="548640" cy="201168"/>
           </a:xfrm>
           <a:prstGeom prst="rect">
             <a:avLst/>
@@ -3398,14 +3433,14 @@
       </p:sp>
       <p:sp>
         <p:nvSpPr>
-          <p:cNvPr id="10" name="TextBox 9"/>
-          <p:cNvSpPr txBox="1"/>
-          <p:nvPr/>
-        </p:nvSpPr>
-        <p:spPr>
-          <a:xfrm>
-            <a:off x="10744200" y="1591056"/>
-            <a:ext cx="594360" cy="201168"/>
+          <p:cNvPr id="11" name="TextBox 10"/>
+          <p:cNvSpPr txBox="1"/>
+          <p:nvPr/>
+        </p:nvSpPr>
+        <p:spPr>
+          <a:xfrm>
+            <a:off x="10241280" y="1591056"/>
+            <a:ext cx="548640" cy="201168"/>
           </a:xfrm>
           <a:prstGeom prst="rect">
             <a:avLst/>
@@ -3426,6 +3461,41 @@
                 </a:solidFill>
                 <a:latin typeface="Arial"/>
               </a:rPr>
+              <a:t>LUCK</a:t>
+            </a:r>
+          </a:p>
+        </p:txBody>
+      </p:sp>
+      <p:sp>
+        <p:nvSpPr>
+          <p:cNvPr id="12" name="TextBox 11"/>
+          <p:cNvSpPr txBox="1"/>
+          <p:nvPr/>
+        </p:nvSpPr>
+        <p:spPr>
+          <a:xfrm>
+            <a:off x="10789920" y="1591056"/>
+            <a:ext cx="548640" cy="201168"/>
+          </a:xfrm>
+          <a:prstGeom prst="rect">
+            <a:avLst/>
+          </a:prstGeom>
+          <a:noFill/>
+        </p:spPr>
+        <p:txBody>
+          <a:bodyPr wrap="square" lIns="0" rIns="0" tIns="0" bIns="0">
+            <a:spAutoFit/>
+          </a:bodyPr>
+          <a:lstStyle/>
+          <a:p>
+            <a:pPr algn="r"/>
+            <a:r>
+              <a:rPr sz="800" b="1" i="0">
+                <a:solidFill>
+                  <a:srgbClr val="CADCFC"/>
+                </a:solidFill>
+                <a:latin typeface="Arial"/>
+              </a:rPr>
               <a:t>VOTERS</a:t>
             </a:r>
           </a:p>
@@ -3433,7 +3503,7 @@
       </p:sp>
       <p:sp>
         <p:nvSpPr>
-          <p:cNvPr id="11" name="Rectangle 10"/>
+          <p:cNvPr id="13" name="Rectangle 12"/>
           <p:cNvSpPr/>
           <p:nvPr/>
         </p:nvSpPr>
@@ -3477,7 +3547,7 @@
       </p:sp>
       <p:sp>
         <p:nvSpPr>
-          <p:cNvPr id="12" name="TextBox 11"/>
+          <p:cNvPr id="14" name="TextBox 13"/>
           <p:cNvSpPr txBox="1"/>
           <p:nvPr/>
         </p:nvSpPr>
@@ -3512,7 +3582,7 @@
       </p:sp>
       <p:sp>
         <p:nvSpPr>
-          <p:cNvPr id="13" name="Oval 12"/>
+          <p:cNvPr id="15" name="Oval 14"/>
           <p:cNvSpPr/>
           <p:nvPr/>
         </p:nvSpPr>
@@ -3556,7 +3626,7 @@
       </p:sp>
       <p:pic>
         <p:nvPicPr>
-          <p:cNvPr id="14" name="Picture 13" descr="ohiostate.png"/>
+          <p:cNvPr id="16" name="Picture 15" descr="ohiostate.png"/>
           <p:cNvPicPr>
             <a:picLocks noChangeAspect="1"/>
           </p:cNvPicPr>
@@ -3580,14 +3650,14 @@
       </p:pic>
       <p:sp>
         <p:nvSpPr>
-          <p:cNvPr id="15" name="TextBox 14"/>
-          <p:cNvSpPr txBox="1"/>
-          <p:nvPr/>
-        </p:nvSpPr>
-        <p:spPr>
-          <a:xfrm>
-            <a:off x="1737360" y="1842516"/>
-            <a:ext cx="2103120" cy="274320"/>
+          <p:cNvPr id="17" name="TextBox 16"/>
+          <p:cNvSpPr txBox="1"/>
+          <p:nvPr/>
+        </p:nvSpPr>
+        <p:spPr>
+          <a:xfrm>
+            <a:off x="1737360" y="1851660"/>
+            <a:ext cx="1874519" cy="274320"/>
           </a:xfrm>
           <a:prstGeom prst="rect">
             <a:avLst/>
@@ -3602,7 +3672,7 @@
           <a:p>
             <a:pPr algn="l"/>
             <a:r>
-              <a:rPr sz="1250" b="1" i="0">
+              <a:rPr sz="1200" b="1" i="0">
                 <a:solidFill>
                   <a:srgbClr val="FFFFFF"/>
                 </a:solidFill>
@@ -3615,14 +3685,14 @@
       </p:sp>
       <p:sp>
         <p:nvSpPr>
-          <p:cNvPr id="16" name="TextBox 15"/>
-          <p:cNvSpPr txBox="1"/>
-          <p:nvPr/>
-        </p:nvSpPr>
-        <p:spPr>
-          <a:xfrm>
-            <a:off x="3840480" y="1842516"/>
-            <a:ext cx="685800" cy="274320"/>
+          <p:cNvPr id="18" name="TextBox 17"/>
+          <p:cNvSpPr txBox="1"/>
+          <p:nvPr/>
+        </p:nvSpPr>
+        <p:spPr>
+          <a:xfrm>
+            <a:off x="3611879" y="1842516"/>
+            <a:ext cx="548640" cy="274320"/>
           </a:xfrm>
           <a:prstGeom prst="rect">
             <a:avLst/>
@@ -3650,14 +3720,14 @@
       </p:sp>
       <p:sp>
         <p:nvSpPr>
-          <p:cNvPr id="17" name="TextBox 16"/>
-          <p:cNvSpPr txBox="1"/>
-          <p:nvPr/>
-        </p:nvSpPr>
-        <p:spPr>
-          <a:xfrm>
-            <a:off x="4526280" y="1856231"/>
-            <a:ext cx="685800" cy="274320"/>
+          <p:cNvPr id="19" name="TextBox 18"/>
+          <p:cNvSpPr txBox="1"/>
+          <p:nvPr/>
+        </p:nvSpPr>
+        <p:spPr>
+          <a:xfrm>
+            <a:off x="4160520" y="1856231"/>
+            <a:ext cx="548640" cy="274320"/>
           </a:xfrm>
           <a:prstGeom prst="rect">
             <a:avLst/>
@@ -3685,14 +3755,14 @@
       </p:sp>
       <p:sp>
         <p:nvSpPr>
-          <p:cNvPr id="18" name="TextBox 17"/>
-          <p:cNvSpPr txBox="1"/>
-          <p:nvPr/>
-        </p:nvSpPr>
-        <p:spPr>
-          <a:xfrm>
-            <a:off x="5212080" y="1856231"/>
-            <a:ext cx="594360" cy="274320"/>
+          <p:cNvPr id="20" name="TextBox 19"/>
+          <p:cNvSpPr txBox="1"/>
+          <p:nvPr/>
+        </p:nvSpPr>
+        <p:spPr>
+          <a:xfrm>
+            <a:off x="4709160" y="1856231"/>
+            <a:ext cx="548640" cy="274320"/>
           </a:xfrm>
           <a:prstGeom prst="rect">
             <a:avLst/>
@@ -3707,6 +3777,41 @@
           <a:p>
             <a:pPr algn="r"/>
             <a:r>
+              <a:rPr sz="1100" b="0" i="0">
+                <a:solidFill>
+                  <a:srgbClr val="CADCFC"/>
+                </a:solidFill>
+                <a:latin typeface="Arial"/>
+              </a:rPr>
+              <a:t>-3.6</a:t>
+            </a:r>
+          </a:p>
+        </p:txBody>
+      </p:sp>
+      <p:sp>
+        <p:nvSpPr>
+          <p:cNvPr id="21" name="TextBox 20"/>
+          <p:cNvSpPr txBox="1"/>
+          <p:nvPr/>
+        </p:nvSpPr>
+        <p:spPr>
+          <a:xfrm>
+            <a:off x="5257800" y="1856231"/>
+            <a:ext cx="548640" cy="274320"/>
+          </a:xfrm>
+          <a:prstGeom prst="rect">
+            <a:avLst/>
+          </a:prstGeom>
+          <a:noFill/>
+        </p:spPr>
+        <p:txBody>
+          <a:bodyPr wrap="square" lIns="0" rIns="0" tIns="0" bIns="0">
+            <a:spAutoFit/>
+          </a:bodyPr>
+          <a:lstStyle/>
+          <a:p>
+            <a:pPr algn="r"/>
+            <a:r>
               <a:rPr sz="1000" b="0" i="0">
                 <a:solidFill>
                   <a:srgbClr val="CADCFC"/>
@@ -3720,7 +3825,7 @@
       </p:sp>
       <p:sp>
         <p:nvSpPr>
-          <p:cNvPr id="19" name="TextBox 18"/>
+          <p:cNvPr id="22" name="TextBox 21"/>
           <p:cNvSpPr txBox="1"/>
           <p:nvPr/>
         </p:nvSpPr>
@@ -3755,7 +3860,7 @@
       </p:sp>
       <p:sp>
         <p:nvSpPr>
-          <p:cNvPr id="20" name="Oval 19"/>
+          <p:cNvPr id="23" name="Oval 22"/>
           <p:cNvSpPr/>
           <p:nvPr/>
         </p:nvSpPr>
@@ -3799,7 +3904,7 @@
       </p:sp>
       <p:pic>
         <p:nvPicPr>
-          <p:cNvPr id="21" name="Picture 20" descr="texas.png"/>
+          <p:cNvPr id="24" name="Picture 23" descr="texas.png"/>
           <p:cNvPicPr>
             <a:picLocks noChangeAspect="1"/>
           </p:cNvPicPr>
@@ -3823,14 +3928,14 @@
       </p:pic>
       <p:sp>
         <p:nvSpPr>
-          <p:cNvPr id="22" name="TextBox 21"/>
-          <p:cNvSpPr txBox="1"/>
-          <p:nvPr/>
-        </p:nvSpPr>
-        <p:spPr>
-          <a:xfrm>
-            <a:off x="1737360" y="2171700"/>
-            <a:ext cx="2103120" cy="274320"/>
+          <p:cNvPr id="25" name="TextBox 24"/>
+          <p:cNvSpPr txBox="1"/>
+          <p:nvPr/>
+        </p:nvSpPr>
+        <p:spPr>
+          <a:xfrm>
+            <a:off x="1737360" y="2180844"/>
+            <a:ext cx="1874519" cy="274320"/>
           </a:xfrm>
           <a:prstGeom prst="rect">
             <a:avLst/>
@@ -3845,7 +3950,7 @@
           <a:p>
             <a:pPr algn="l"/>
             <a:r>
-              <a:rPr sz="1250" b="1" i="0">
+              <a:rPr sz="1200" b="1" i="0">
                 <a:solidFill>
                   <a:srgbClr val="FFFFFF"/>
                 </a:solidFill>
@@ -3858,14 +3963,14 @@
       </p:sp>
       <p:sp>
         <p:nvSpPr>
-          <p:cNvPr id="23" name="TextBox 22"/>
-          <p:cNvSpPr txBox="1"/>
-          <p:nvPr/>
-        </p:nvSpPr>
-        <p:spPr>
-          <a:xfrm>
-            <a:off x="3840480" y="2171700"/>
-            <a:ext cx="685800" cy="274320"/>
+          <p:cNvPr id="26" name="TextBox 25"/>
+          <p:cNvSpPr txBox="1"/>
+          <p:nvPr/>
+        </p:nvSpPr>
+        <p:spPr>
+          <a:xfrm>
+            <a:off x="3611879" y="2171700"/>
+            <a:ext cx="548640" cy="274320"/>
           </a:xfrm>
           <a:prstGeom prst="rect">
             <a:avLst/>
@@ -3893,14 +3998,14 @@
       </p:sp>
       <p:sp>
         <p:nvSpPr>
-          <p:cNvPr id="24" name="TextBox 23"/>
-          <p:cNvSpPr txBox="1"/>
-          <p:nvPr/>
-        </p:nvSpPr>
-        <p:spPr>
-          <a:xfrm>
-            <a:off x="4526280" y="2185415"/>
-            <a:ext cx="685800" cy="274320"/>
+          <p:cNvPr id="27" name="TextBox 26"/>
+          <p:cNvSpPr txBox="1"/>
+          <p:nvPr/>
+        </p:nvSpPr>
+        <p:spPr>
+          <a:xfrm>
+            <a:off x="4160520" y="2185415"/>
+            <a:ext cx="548640" cy="274320"/>
           </a:xfrm>
           <a:prstGeom prst="rect">
             <a:avLst/>
@@ -3928,14 +4033,14 @@
       </p:sp>
       <p:sp>
         <p:nvSpPr>
-          <p:cNvPr id="25" name="TextBox 24"/>
-          <p:cNvSpPr txBox="1"/>
-          <p:nvPr/>
-        </p:nvSpPr>
-        <p:spPr>
-          <a:xfrm>
-            <a:off x="5212080" y="2185415"/>
-            <a:ext cx="594360" cy="274320"/>
+          <p:cNvPr id="28" name="TextBox 27"/>
+          <p:cNvSpPr txBox="1"/>
+          <p:nvPr/>
+        </p:nvSpPr>
+        <p:spPr>
+          <a:xfrm>
+            <a:off x="4709160" y="2185415"/>
+            <a:ext cx="548640" cy="274320"/>
           </a:xfrm>
           <a:prstGeom prst="rect">
             <a:avLst/>
@@ -3950,6 +4055,41 @@
           <a:p>
             <a:pPr algn="r"/>
             <a:r>
+              <a:rPr sz="1100" b="1" i="0">
+                <a:solidFill>
+                  <a:srgbClr val="F47321"/>
+                </a:solidFill>
+                <a:latin typeface="Arial"/>
+              </a:rPr>
+              <a:t>+12.6</a:t>
+            </a:r>
+          </a:p>
+        </p:txBody>
+      </p:sp>
+      <p:sp>
+        <p:nvSpPr>
+          <p:cNvPr id="29" name="TextBox 28"/>
+          <p:cNvSpPr txBox="1"/>
+          <p:nvPr/>
+        </p:nvSpPr>
+        <p:spPr>
+          <a:xfrm>
+            <a:off x="5257800" y="2185415"/>
+            <a:ext cx="548640" cy="274320"/>
+          </a:xfrm>
+          <a:prstGeom prst="rect">
+            <a:avLst/>
+          </a:prstGeom>
+          <a:noFill/>
+        </p:spPr>
+        <p:txBody>
+          <a:bodyPr wrap="square" lIns="0" rIns="0" tIns="0" bIns="0">
+            <a:spAutoFit/>
+          </a:bodyPr>
+          <a:lstStyle/>
+          <a:p>
+            <a:pPr algn="r"/>
+            <a:r>
               <a:rPr sz="1000" b="0" i="0">
                 <a:solidFill>
                   <a:srgbClr val="CADCFC"/>
@@ -3963,7 +4103,7 @@
       </p:sp>
       <p:sp>
         <p:nvSpPr>
-          <p:cNvPr id="26" name="Rectangle 25"/>
+          <p:cNvPr id="30" name="Rectangle 29"/>
           <p:cNvSpPr/>
           <p:nvPr/>
         </p:nvSpPr>
@@ -4007,7 +4147,7 @@
       </p:sp>
       <p:sp>
         <p:nvSpPr>
-          <p:cNvPr id="27" name="TextBox 26"/>
+          <p:cNvPr id="31" name="TextBox 30"/>
           <p:cNvSpPr txBox="1"/>
           <p:nvPr/>
         </p:nvSpPr>
@@ -4042,7 +4182,7 @@
       </p:sp>
       <p:sp>
         <p:nvSpPr>
-          <p:cNvPr id="28" name="Oval 27"/>
+          <p:cNvPr id="32" name="Oval 31"/>
           <p:cNvSpPr/>
           <p:nvPr/>
         </p:nvSpPr>
@@ -4086,7 +4226,7 @@
       </p:sp>
       <p:pic>
         <p:nvPicPr>
-          <p:cNvPr id="29" name="Picture 28" descr="notredame.png"/>
+          <p:cNvPr id="33" name="Picture 32" descr="notredame.png"/>
           <p:cNvPicPr>
             <a:picLocks noChangeAspect="1"/>
           </p:cNvPicPr>
@@ -4110,14 +4250,14 @@
       </p:pic>
       <p:sp>
         <p:nvSpPr>
-          <p:cNvPr id="30" name="TextBox 29"/>
-          <p:cNvSpPr txBox="1"/>
-          <p:nvPr/>
-        </p:nvSpPr>
-        <p:spPr>
-          <a:xfrm>
-            <a:off x="1737360" y="2500884"/>
-            <a:ext cx="2103120" cy="274320"/>
+          <p:cNvPr id="34" name="TextBox 33"/>
+          <p:cNvSpPr txBox="1"/>
+          <p:nvPr/>
+        </p:nvSpPr>
+        <p:spPr>
+          <a:xfrm>
+            <a:off x="1737360" y="2510028"/>
+            <a:ext cx="1874519" cy="274320"/>
           </a:xfrm>
           <a:prstGeom prst="rect">
             <a:avLst/>
@@ -4132,7 +4272,7 @@
           <a:p>
             <a:pPr algn="l"/>
             <a:r>
-              <a:rPr sz="1250" b="1" i="0">
+              <a:rPr sz="1200" b="1" i="0">
                 <a:solidFill>
                   <a:srgbClr val="FFFFFF"/>
                 </a:solidFill>
@@ -4145,14 +4285,14 @@
       </p:sp>
       <p:sp>
         <p:nvSpPr>
-          <p:cNvPr id="31" name="TextBox 30"/>
-          <p:cNvSpPr txBox="1"/>
-          <p:nvPr/>
-        </p:nvSpPr>
-        <p:spPr>
-          <a:xfrm>
-            <a:off x="3840480" y="2500884"/>
-            <a:ext cx="685800" cy="274320"/>
+          <p:cNvPr id="35" name="TextBox 34"/>
+          <p:cNvSpPr txBox="1"/>
+          <p:nvPr/>
+        </p:nvSpPr>
+        <p:spPr>
+          <a:xfrm>
+            <a:off x="3611879" y="2500884"/>
+            <a:ext cx="548640" cy="274320"/>
           </a:xfrm>
           <a:prstGeom prst="rect">
             <a:avLst/>
@@ -4180,14 +4320,14 @@
       </p:sp>
       <p:sp>
         <p:nvSpPr>
-          <p:cNvPr id="32" name="TextBox 31"/>
-          <p:cNvSpPr txBox="1"/>
-          <p:nvPr/>
-        </p:nvSpPr>
-        <p:spPr>
-          <a:xfrm>
-            <a:off x="4526280" y="2514600"/>
-            <a:ext cx="685800" cy="274320"/>
+          <p:cNvPr id="36" name="TextBox 35"/>
+          <p:cNvSpPr txBox="1"/>
+          <p:nvPr/>
+        </p:nvSpPr>
+        <p:spPr>
+          <a:xfrm>
+            <a:off x="4160520" y="2514600"/>
+            <a:ext cx="548640" cy="274320"/>
           </a:xfrm>
           <a:prstGeom prst="rect">
             <a:avLst/>
@@ -4215,14 +4355,14 @@
       </p:sp>
       <p:sp>
         <p:nvSpPr>
-          <p:cNvPr id="33" name="TextBox 32"/>
-          <p:cNvSpPr txBox="1"/>
-          <p:nvPr/>
-        </p:nvSpPr>
-        <p:spPr>
-          <a:xfrm>
-            <a:off x="5212080" y="2514600"/>
-            <a:ext cx="594360" cy="274320"/>
+          <p:cNvPr id="37" name="TextBox 36"/>
+          <p:cNvSpPr txBox="1"/>
+          <p:nvPr/>
+        </p:nvSpPr>
+        <p:spPr>
+          <a:xfrm>
+            <a:off x="4709160" y="2514600"/>
+            <a:ext cx="548640" cy="274320"/>
           </a:xfrm>
           <a:prstGeom prst="rect">
             <a:avLst/>
@@ -4237,6 +4377,41 @@
           <a:p>
             <a:pPr algn="r"/>
             <a:r>
+              <a:rPr sz="1100" b="1" i="0">
+                <a:solidFill>
+                  <a:srgbClr val="F47321"/>
+                </a:solidFill>
+                <a:latin typeface="Arial"/>
+              </a:rPr>
+              <a:t>+6.6</a:t>
+            </a:r>
+          </a:p>
+        </p:txBody>
+      </p:sp>
+      <p:sp>
+        <p:nvSpPr>
+          <p:cNvPr id="38" name="TextBox 37"/>
+          <p:cNvSpPr txBox="1"/>
+          <p:nvPr/>
+        </p:nvSpPr>
+        <p:spPr>
+          <a:xfrm>
+            <a:off x="5257800" y="2514600"/>
+            <a:ext cx="548640" cy="274320"/>
+          </a:xfrm>
+          <a:prstGeom prst="rect">
+            <a:avLst/>
+          </a:prstGeom>
+          <a:noFill/>
+        </p:spPr>
+        <p:txBody>
+          <a:bodyPr wrap="square" lIns="0" rIns="0" tIns="0" bIns="0">
+            <a:spAutoFit/>
+          </a:bodyPr>
+          <a:lstStyle/>
+          <a:p>
+            <a:pPr algn="r"/>
+            <a:r>
               <a:rPr sz="1000" b="0" i="0">
                 <a:solidFill>
                   <a:srgbClr val="CADCFC"/>
@@ -4250,7 +4425,7 @@
       </p:sp>
       <p:sp>
         <p:nvSpPr>
-          <p:cNvPr id="34" name="TextBox 33"/>
+          <p:cNvPr id="39" name="TextBox 38"/>
           <p:cNvSpPr txBox="1"/>
           <p:nvPr/>
         </p:nvSpPr>
@@ -4285,7 +4460,7 @@
       </p:sp>
       <p:sp>
         <p:nvSpPr>
-          <p:cNvPr id="35" name="Oval 34"/>
+          <p:cNvPr id="40" name="Oval 39"/>
           <p:cNvSpPr/>
           <p:nvPr/>
         </p:nvSpPr>
@@ -4329,7 +4504,7 @@
       </p:sp>
       <p:pic>
         <p:nvPicPr>
-          <p:cNvPr id="36" name="Picture 35" descr="indiana.png"/>
+          <p:cNvPr id="41" name="Picture 40" descr="indiana.png"/>
           <p:cNvPicPr>
             <a:picLocks noChangeAspect="1"/>
           </p:cNvPicPr>
@@ -4353,14 +4528,14 @@
       </p:pic>
       <p:sp>
         <p:nvSpPr>
-          <p:cNvPr id="37" name="TextBox 36"/>
-          <p:cNvSpPr txBox="1"/>
-          <p:nvPr/>
-        </p:nvSpPr>
-        <p:spPr>
-          <a:xfrm>
-            <a:off x="1737360" y="2830068"/>
-            <a:ext cx="2103120" cy="274320"/>
+          <p:cNvPr id="42" name="TextBox 41"/>
+          <p:cNvSpPr txBox="1"/>
+          <p:nvPr/>
+        </p:nvSpPr>
+        <p:spPr>
+          <a:xfrm>
+            <a:off x="1737360" y="2839212"/>
+            <a:ext cx="1874519" cy="274320"/>
           </a:xfrm>
           <a:prstGeom prst="rect">
             <a:avLst/>
@@ -4375,7 +4550,7 @@
           <a:p>
             <a:pPr algn="l"/>
             <a:r>
-              <a:rPr sz="1250" b="1" i="0">
+              <a:rPr sz="1200" b="1" i="0">
                 <a:solidFill>
                   <a:srgbClr val="FFFFFF"/>
                 </a:solidFill>
@@ -4388,14 +4563,14 @@
       </p:sp>
       <p:sp>
         <p:nvSpPr>
-          <p:cNvPr id="38" name="TextBox 37"/>
-          <p:cNvSpPr txBox="1"/>
-          <p:nvPr/>
-        </p:nvSpPr>
-        <p:spPr>
-          <a:xfrm>
-            <a:off x="3840480" y="2830068"/>
-            <a:ext cx="685800" cy="274320"/>
+          <p:cNvPr id="43" name="TextBox 42"/>
+          <p:cNvSpPr txBox="1"/>
+          <p:nvPr/>
+        </p:nvSpPr>
+        <p:spPr>
+          <a:xfrm>
+            <a:off x="3611879" y="2830068"/>
+            <a:ext cx="548640" cy="274320"/>
           </a:xfrm>
           <a:prstGeom prst="rect">
             <a:avLst/>
@@ -4423,14 +4598,14 @@
       </p:sp>
       <p:sp>
         <p:nvSpPr>
-          <p:cNvPr id="39" name="TextBox 38"/>
-          <p:cNvSpPr txBox="1"/>
-          <p:nvPr/>
-        </p:nvSpPr>
-        <p:spPr>
-          <a:xfrm>
-            <a:off x="4526280" y="2843784"/>
-            <a:ext cx="685800" cy="274320"/>
+          <p:cNvPr id="44" name="TextBox 43"/>
+          <p:cNvSpPr txBox="1"/>
+          <p:nvPr/>
+        </p:nvSpPr>
+        <p:spPr>
+          <a:xfrm>
+            <a:off x="4160520" y="2843784"/>
+            <a:ext cx="548640" cy="274320"/>
           </a:xfrm>
           <a:prstGeom prst="rect">
             <a:avLst/>
@@ -4458,14 +4633,14 @@
       </p:sp>
       <p:sp>
         <p:nvSpPr>
-          <p:cNvPr id="40" name="TextBox 39"/>
-          <p:cNvSpPr txBox="1"/>
-          <p:nvPr/>
-        </p:nvSpPr>
-        <p:spPr>
-          <a:xfrm>
-            <a:off x="5212080" y="2843784"/>
-            <a:ext cx="594360" cy="274320"/>
+          <p:cNvPr id="45" name="TextBox 44"/>
+          <p:cNvSpPr txBox="1"/>
+          <p:nvPr/>
+        </p:nvSpPr>
+        <p:spPr>
+          <a:xfrm>
+            <a:off x="4709160" y="2843784"/>
+            <a:ext cx="548640" cy="274320"/>
           </a:xfrm>
           <a:prstGeom prst="rect">
             <a:avLst/>
@@ -4480,6 +4655,41 @@
           <a:p>
             <a:pPr algn="r"/>
             <a:r>
+              <a:rPr sz="1100" b="1" i="0">
+                <a:solidFill>
+                  <a:srgbClr val="F47321"/>
+                </a:solidFill>
+                <a:latin typeface="Arial"/>
+              </a:rPr>
+              <a:t>+13.0</a:t>
+            </a:r>
+          </a:p>
+        </p:txBody>
+      </p:sp>
+      <p:sp>
+        <p:nvSpPr>
+          <p:cNvPr id="46" name="TextBox 45"/>
+          <p:cNvSpPr txBox="1"/>
+          <p:nvPr/>
+        </p:nvSpPr>
+        <p:spPr>
+          <a:xfrm>
+            <a:off x="5257800" y="2843784"/>
+            <a:ext cx="548640" cy="274320"/>
+          </a:xfrm>
+          <a:prstGeom prst="rect">
+            <a:avLst/>
+          </a:prstGeom>
+          <a:noFill/>
+        </p:spPr>
+        <p:txBody>
+          <a:bodyPr wrap="square" lIns="0" rIns="0" tIns="0" bIns="0">
+            <a:spAutoFit/>
+          </a:bodyPr>
+          <a:lstStyle/>
+          <a:p>
+            <a:pPr algn="r"/>
+            <a:r>
               <a:rPr sz="1000" b="0" i="0">
                 <a:solidFill>
                   <a:srgbClr val="CADCFC"/>
@@ -4493,7 +4703,7 @@
       </p:sp>
       <p:sp>
         <p:nvSpPr>
-          <p:cNvPr id="41" name="Rectangle 40"/>
+          <p:cNvPr id="47" name="Rectangle 46"/>
           <p:cNvSpPr/>
           <p:nvPr/>
         </p:nvSpPr>
@@ -4537,7 +4747,7 @@
       </p:sp>
       <p:sp>
         <p:nvSpPr>
-          <p:cNvPr id="42" name="TextBox 41"/>
+          <p:cNvPr id="48" name="TextBox 47"/>
           <p:cNvSpPr txBox="1"/>
           <p:nvPr/>
         </p:nvSpPr>
@@ -4572,7 +4782,7 @@
       </p:sp>
       <p:sp>
         <p:nvSpPr>
-          <p:cNvPr id="43" name="Oval 42"/>
+          <p:cNvPr id="49" name="Oval 48"/>
           <p:cNvSpPr/>
           <p:nvPr/>
         </p:nvSpPr>
@@ -4616,7 +4826,7 @@
       </p:sp>
       <p:pic>
         <p:nvPicPr>
-          <p:cNvPr id="44" name="Picture 43" descr="miami.png"/>
+          <p:cNvPr id="50" name="Picture 49" descr="miami.png"/>
           <p:cNvPicPr>
             <a:picLocks noChangeAspect="1"/>
           </p:cNvPicPr>
@@ -4640,14 +4850,14 @@
       </p:pic>
       <p:sp>
         <p:nvSpPr>
-          <p:cNvPr id="45" name="TextBox 44"/>
-          <p:cNvSpPr txBox="1"/>
-          <p:nvPr/>
-        </p:nvSpPr>
-        <p:spPr>
-          <a:xfrm>
-            <a:off x="1737360" y="3159252"/>
-            <a:ext cx="2103120" cy="274320"/>
+          <p:cNvPr id="51" name="TextBox 50"/>
+          <p:cNvSpPr txBox="1"/>
+          <p:nvPr/>
+        </p:nvSpPr>
+        <p:spPr>
+          <a:xfrm>
+            <a:off x="1737360" y="3168396"/>
+            <a:ext cx="1874519" cy="274320"/>
           </a:xfrm>
           <a:prstGeom prst="rect">
             <a:avLst/>
@@ -4662,7 +4872,7 @@
           <a:p>
             <a:pPr algn="l"/>
             <a:r>
-              <a:rPr sz="1250" b="1" i="0">
+              <a:rPr sz="1200" b="1" i="0">
                 <a:solidFill>
                   <a:srgbClr val="FFFFFF"/>
                 </a:solidFill>
@@ -4675,14 +4885,14 @@
       </p:sp>
       <p:sp>
         <p:nvSpPr>
-          <p:cNvPr id="46" name="TextBox 45"/>
-          <p:cNvSpPr txBox="1"/>
-          <p:nvPr/>
-        </p:nvSpPr>
-        <p:spPr>
-          <a:xfrm>
-            <a:off x="3840480" y="3159252"/>
-            <a:ext cx="685800" cy="274320"/>
+          <p:cNvPr id="52" name="TextBox 51"/>
+          <p:cNvSpPr txBox="1"/>
+          <p:nvPr/>
+        </p:nvSpPr>
+        <p:spPr>
+          <a:xfrm>
+            <a:off x="3611879" y="3159252"/>
+            <a:ext cx="548640" cy="274320"/>
           </a:xfrm>
           <a:prstGeom prst="rect">
             <a:avLst/>
@@ -4710,14 +4920,14 @@
       </p:sp>
       <p:sp>
         <p:nvSpPr>
-          <p:cNvPr id="47" name="TextBox 46"/>
-          <p:cNvSpPr txBox="1"/>
-          <p:nvPr/>
-        </p:nvSpPr>
-        <p:spPr>
-          <a:xfrm>
-            <a:off x="4526280" y="3172968"/>
-            <a:ext cx="685800" cy="274320"/>
+          <p:cNvPr id="53" name="TextBox 52"/>
+          <p:cNvSpPr txBox="1"/>
+          <p:nvPr/>
+        </p:nvSpPr>
+        <p:spPr>
+          <a:xfrm>
+            <a:off x="4160520" y="3172968"/>
+            <a:ext cx="548640" cy="274320"/>
           </a:xfrm>
           <a:prstGeom prst="rect">
             <a:avLst/>
@@ -4745,14 +4955,14 @@
       </p:sp>
       <p:sp>
         <p:nvSpPr>
-          <p:cNvPr id="48" name="TextBox 47"/>
-          <p:cNvSpPr txBox="1"/>
-          <p:nvPr/>
-        </p:nvSpPr>
-        <p:spPr>
-          <a:xfrm>
-            <a:off x="5212080" y="3172968"/>
-            <a:ext cx="594360" cy="274320"/>
+          <p:cNvPr id="54" name="TextBox 53"/>
+          <p:cNvSpPr txBox="1"/>
+          <p:nvPr/>
+        </p:nvSpPr>
+        <p:spPr>
+          <a:xfrm>
+            <a:off x="4709160" y="3172968"/>
+            <a:ext cx="548640" cy="274320"/>
           </a:xfrm>
           <a:prstGeom prst="rect">
             <a:avLst/>
@@ -4767,6 +4977,41 @@
           <a:p>
             <a:pPr algn="r"/>
             <a:r>
+              <a:rPr sz="1100" b="1" i="0">
+                <a:solidFill>
+                  <a:srgbClr val="F47321"/>
+                </a:solidFill>
+                <a:latin typeface="Arial"/>
+              </a:rPr>
+              <a:t>+8.4</a:t>
+            </a:r>
+          </a:p>
+        </p:txBody>
+      </p:sp>
+      <p:sp>
+        <p:nvSpPr>
+          <p:cNvPr id="55" name="TextBox 54"/>
+          <p:cNvSpPr txBox="1"/>
+          <p:nvPr/>
+        </p:nvSpPr>
+        <p:spPr>
+          <a:xfrm>
+            <a:off x="5257800" y="3172968"/>
+            <a:ext cx="548640" cy="274320"/>
+          </a:xfrm>
+          <a:prstGeom prst="rect">
+            <a:avLst/>
+          </a:prstGeom>
+          <a:noFill/>
+        </p:spPr>
+        <p:txBody>
+          <a:bodyPr wrap="square" lIns="0" rIns="0" tIns="0" bIns="0">
+            <a:spAutoFit/>
+          </a:bodyPr>
+          <a:lstStyle/>
+          <a:p>
+            <a:pPr algn="r"/>
+            <a:r>
               <a:rPr sz="1000" b="0" i="0">
                 <a:solidFill>
                   <a:srgbClr val="CADCFC"/>
@@ -4780,7 +5025,7 @@
       </p:sp>
       <p:sp>
         <p:nvSpPr>
-          <p:cNvPr id="49" name="TextBox 48"/>
+          <p:cNvPr id="56" name="TextBox 55"/>
           <p:cNvSpPr txBox="1"/>
           <p:nvPr/>
         </p:nvSpPr>
@@ -4815,7 +5060,7 @@
       </p:sp>
       <p:sp>
         <p:nvSpPr>
-          <p:cNvPr id="50" name="Oval 49"/>
+          <p:cNvPr id="57" name="Oval 56"/>
           <p:cNvSpPr/>
           <p:nvPr/>
         </p:nvSpPr>
@@ -4859,7 +5104,7 @@
       </p:sp>
       <p:pic>
         <p:nvPicPr>
-          <p:cNvPr id="51" name="Picture 50" descr="alabama.png"/>
+          <p:cNvPr id="58" name="Picture 57" descr="alabama.png"/>
           <p:cNvPicPr>
             <a:picLocks noChangeAspect="1"/>
           </p:cNvPicPr>
@@ -4883,14 +5128,14 @@
       </p:pic>
       <p:sp>
         <p:nvSpPr>
-          <p:cNvPr id="52" name="TextBox 51"/>
-          <p:cNvSpPr txBox="1"/>
-          <p:nvPr/>
-        </p:nvSpPr>
-        <p:spPr>
-          <a:xfrm>
-            <a:off x="1737360" y="3488436"/>
-            <a:ext cx="2103120" cy="274320"/>
+          <p:cNvPr id="59" name="TextBox 58"/>
+          <p:cNvSpPr txBox="1"/>
+          <p:nvPr/>
+        </p:nvSpPr>
+        <p:spPr>
+          <a:xfrm>
+            <a:off x="1737360" y="3497579"/>
+            <a:ext cx="1874519" cy="274320"/>
           </a:xfrm>
           <a:prstGeom prst="rect">
             <a:avLst/>
@@ -4905,7 +5150,7 @@
           <a:p>
             <a:pPr algn="l"/>
             <a:r>
-              <a:rPr sz="1250" b="1" i="0">
+              <a:rPr sz="1200" b="1" i="0">
                 <a:solidFill>
                   <a:srgbClr val="FFFFFF"/>
                 </a:solidFill>
@@ -4918,14 +5163,14 @@
       </p:sp>
       <p:sp>
         <p:nvSpPr>
-          <p:cNvPr id="53" name="TextBox 52"/>
-          <p:cNvSpPr txBox="1"/>
-          <p:nvPr/>
-        </p:nvSpPr>
-        <p:spPr>
-          <a:xfrm>
-            <a:off x="3840480" y="3488436"/>
-            <a:ext cx="685800" cy="274320"/>
+          <p:cNvPr id="60" name="TextBox 59"/>
+          <p:cNvSpPr txBox="1"/>
+          <p:nvPr/>
+        </p:nvSpPr>
+        <p:spPr>
+          <a:xfrm>
+            <a:off x="3611879" y="3488436"/>
+            <a:ext cx="548640" cy="274320"/>
           </a:xfrm>
           <a:prstGeom prst="rect">
             <a:avLst/>
@@ -4953,14 +5198,14 @@
       </p:sp>
       <p:sp>
         <p:nvSpPr>
-          <p:cNvPr id="54" name="TextBox 53"/>
-          <p:cNvSpPr txBox="1"/>
-          <p:nvPr/>
-        </p:nvSpPr>
-        <p:spPr>
-          <a:xfrm>
-            <a:off x="4526280" y="3502151"/>
-            <a:ext cx="685800" cy="274320"/>
+          <p:cNvPr id="61" name="TextBox 60"/>
+          <p:cNvSpPr txBox="1"/>
+          <p:nvPr/>
+        </p:nvSpPr>
+        <p:spPr>
+          <a:xfrm>
+            <a:off x="4160520" y="3502151"/>
+            <a:ext cx="548640" cy="274320"/>
           </a:xfrm>
           <a:prstGeom prst="rect">
             <a:avLst/>
@@ -4988,14 +5233,14 @@
       </p:sp>
       <p:sp>
         <p:nvSpPr>
-          <p:cNvPr id="55" name="TextBox 54"/>
-          <p:cNvSpPr txBox="1"/>
-          <p:nvPr/>
-        </p:nvSpPr>
-        <p:spPr>
-          <a:xfrm>
-            <a:off x="5212080" y="3502151"/>
-            <a:ext cx="594360" cy="274320"/>
+          <p:cNvPr id="62" name="TextBox 61"/>
+          <p:cNvSpPr txBox="1"/>
+          <p:nvPr/>
+        </p:nvSpPr>
+        <p:spPr>
+          <a:xfrm>
+            <a:off x="4709160" y="3502151"/>
+            <a:ext cx="548640" cy="274320"/>
           </a:xfrm>
           <a:prstGeom prst="rect">
             <a:avLst/>
@@ -5010,6 +5255,41 @@
           <a:p>
             <a:pPr algn="r"/>
             <a:r>
+              <a:rPr sz="1100" b="0" i="0">
+                <a:solidFill>
+                  <a:srgbClr val="CADCFC"/>
+                </a:solidFill>
+                <a:latin typeface="Arial"/>
+              </a:rPr>
+              <a:t>+4.2</a:t>
+            </a:r>
+          </a:p>
+        </p:txBody>
+      </p:sp>
+      <p:sp>
+        <p:nvSpPr>
+          <p:cNvPr id="63" name="TextBox 62"/>
+          <p:cNvSpPr txBox="1"/>
+          <p:nvPr/>
+        </p:nvSpPr>
+        <p:spPr>
+          <a:xfrm>
+            <a:off x="5257800" y="3502151"/>
+            <a:ext cx="548640" cy="274320"/>
+          </a:xfrm>
+          <a:prstGeom prst="rect">
+            <a:avLst/>
+          </a:prstGeom>
+          <a:noFill/>
+        </p:spPr>
+        <p:txBody>
+          <a:bodyPr wrap="square" lIns="0" rIns="0" tIns="0" bIns="0">
+            <a:spAutoFit/>
+          </a:bodyPr>
+          <a:lstStyle/>
+          <a:p>
+            <a:pPr algn="r"/>
+            <a:r>
               <a:rPr sz="1000" b="0" i="0">
                 <a:solidFill>
                   <a:srgbClr val="CADCFC"/>
@@ -5023,7 +5303,7 @@
       </p:sp>
       <p:sp>
         <p:nvSpPr>
-          <p:cNvPr id="56" name="Rectangle 55"/>
+          <p:cNvPr id="64" name="Rectangle 63"/>
           <p:cNvSpPr/>
           <p:nvPr/>
         </p:nvSpPr>
@@ -5067,7 +5347,7 @@
       </p:sp>
       <p:sp>
         <p:nvSpPr>
-          <p:cNvPr id="57" name="TextBox 56"/>
+          <p:cNvPr id="65" name="TextBox 64"/>
           <p:cNvSpPr txBox="1"/>
           <p:nvPr/>
         </p:nvSpPr>
@@ -5102,7 +5382,7 @@
       </p:sp>
       <p:sp>
         <p:nvSpPr>
-          <p:cNvPr id="58" name="Oval 57"/>
+          <p:cNvPr id="66" name="Oval 65"/>
           <p:cNvSpPr/>
           <p:nvPr/>
         </p:nvSpPr>
@@ -5146,7 +5426,7 @@
       </p:sp>
       <p:pic>
         <p:nvPicPr>
-          <p:cNvPr id="59" name="Picture 58" descr="georgia.png"/>
+          <p:cNvPr id="67" name="Picture 66" descr="georgia.png"/>
           <p:cNvPicPr>
             <a:picLocks noChangeAspect="1"/>
           </p:cNvPicPr>
@@ -5170,14 +5450,14 @@
       </p:pic>
       <p:sp>
         <p:nvSpPr>
-          <p:cNvPr id="60" name="TextBox 59"/>
-          <p:cNvSpPr txBox="1"/>
-          <p:nvPr/>
-        </p:nvSpPr>
-        <p:spPr>
-          <a:xfrm>
-            <a:off x="1737360" y="3817620"/>
-            <a:ext cx="2103120" cy="274320"/>
+          <p:cNvPr id="68" name="TextBox 67"/>
+          <p:cNvSpPr txBox="1"/>
+          <p:nvPr/>
+        </p:nvSpPr>
+        <p:spPr>
+          <a:xfrm>
+            <a:off x="1737360" y="3826764"/>
+            <a:ext cx="1874519" cy="274320"/>
           </a:xfrm>
           <a:prstGeom prst="rect">
             <a:avLst/>
@@ -5192,7 +5472,7 @@
           <a:p>
             <a:pPr algn="l"/>
             <a:r>
-              <a:rPr sz="1250" b="1" i="0">
+              <a:rPr sz="1200" b="1" i="0">
                 <a:solidFill>
                   <a:srgbClr val="FFFFFF"/>
                 </a:solidFill>
@@ -5205,14 +5485,14 @@
       </p:sp>
       <p:sp>
         <p:nvSpPr>
-          <p:cNvPr id="61" name="TextBox 60"/>
-          <p:cNvSpPr txBox="1"/>
-          <p:nvPr/>
-        </p:nvSpPr>
-        <p:spPr>
-          <a:xfrm>
-            <a:off x="3840480" y="3817620"/>
-            <a:ext cx="685800" cy="274320"/>
+          <p:cNvPr id="69" name="TextBox 68"/>
+          <p:cNvSpPr txBox="1"/>
+          <p:nvPr/>
+        </p:nvSpPr>
+        <p:spPr>
+          <a:xfrm>
+            <a:off x="3611879" y="3817620"/>
+            <a:ext cx="548640" cy="274320"/>
           </a:xfrm>
           <a:prstGeom prst="rect">
             <a:avLst/>
@@ -5240,14 +5520,14 @@
       </p:sp>
       <p:sp>
         <p:nvSpPr>
-          <p:cNvPr id="62" name="TextBox 61"/>
-          <p:cNvSpPr txBox="1"/>
-          <p:nvPr/>
-        </p:nvSpPr>
-        <p:spPr>
-          <a:xfrm>
-            <a:off x="4526280" y="3831336"/>
-            <a:ext cx="685800" cy="274320"/>
+          <p:cNvPr id="70" name="TextBox 69"/>
+          <p:cNvSpPr txBox="1"/>
+          <p:nvPr/>
+        </p:nvSpPr>
+        <p:spPr>
+          <a:xfrm>
+            <a:off x="4160520" y="3831336"/>
+            <a:ext cx="548640" cy="274320"/>
           </a:xfrm>
           <a:prstGeom prst="rect">
             <a:avLst/>
@@ -5275,14 +5555,14 @@
       </p:sp>
       <p:sp>
         <p:nvSpPr>
-          <p:cNvPr id="63" name="TextBox 62"/>
-          <p:cNvSpPr txBox="1"/>
-          <p:nvPr/>
-        </p:nvSpPr>
-        <p:spPr>
-          <a:xfrm>
-            <a:off x="5212080" y="3831336"/>
-            <a:ext cx="594360" cy="274320"/>
+          <p:cNvPr id="71" name="TextBox 70"/>
+          <p:cNvSpPr txBox="1"/>
+          <p:nvPr/>
+        </p:nvSpPr>
+        <p:spPr>
+          <a:xfrm>
+            <a:off x="4709160" y="3831336"/>
+            <a:ext cx="548640" cy="274320"/>
           </a:xfrm>
           <a:prstGeom prst="rect">
             <a:avLst/>
@@ -5297,6 +5577,41 @@
           <a:p>
             <a:pPr algn="r"/>
             <a:r>
+              <a:rPr sz="1100" b="0" i="0">
+                <a:solidFill>
+                  <a:srgbClr val="CADCFC"/>
+                </a:solidFill>
+                <a:latin typeface="Arial"/>
+              </a:rPr>
+              <a:t>+1.2</a:t>
+            </a:r>
+          </a:p>
+        </p:txBody>
+      </p:sp>
+      <p:sp>
+        <p:nvSpPr>
+          <p:cNvPr id="72" name="TextBox 71"/>
+          <p:cNvSpPr txBox="1"/>
+          <p:nvPr/>
+        </p:nvSpPr>
+        <p:spPr>
+          <a:xfrm>
+            <a:off x="5257800" y="3831336"/>
+            <a:ext cx="548640" cy="274320"/>
+          </a:xfrm>
+          <a:prstGeom prst="rect">
+            <a:avLst/>
+          </a:prstGeom>
+          <a:noFill/>
+        </p:spPr>
+        <p:txBody>
+          <a:bodyPr wrap="square" lIns="0" rIns="0" tIns="0" bIns="0">
+            <a:spAutoFit/>
+          </a:bodyPr>
+          <a:lstStyle/>
+          <a:p>
+            <a:pPr algn="r"/>
+            <a:r>
               <a:rPr sz="1000" b="0" i="0">
                 <a:solidFill>
                   <a:srgbClr val="CADCFC"/>
@@ -5310,7 +5625,7 @@
       </p:sp>
       <p:sp>
         <p:nvSpPr>
-          <p:cNvPr id="64" name="TextBox 63"/>
+          <p:cNvPr id="73" name="TextBox 72"/>
           <p:cNvSpPr txBox="1"/>
           <p:nvPr/>
         </p:nvSpPr>
@@ -5345,7 +5660,7 @@
       </p:sp>
       <p:sp>
         <p:nvSpPr>
-          <p:cNvPr id="65" name="Oval 64"/>
+          <p:cNvPr id="74" name="Oval 73"/>
           <p:cNvSpPr/>
           <p:nvPr/>
         </p:nvSpPr>
@@ -5389,7 +5704,7 @@
       </p:sp>
       <p:pic>
         <p:nvPicPr>
-          <p:cNvPr id="66" name="Picture 65" descr="lsu.png"/>
+          <p:cNvPr id="75" name="Picture 74" descr="lsu.png"/>
           <p:cNvPicPr>
             <a:picLocks noChangeAspect="1"/>
           </p:cNvPicPr>
@@ -5413,14 +5728,14 @@
       </p:pic>
       <p:sp>
         <p:nvSpPr>
-          <p:cNvPr id="67" name="TextBox 66"/>
-          <p:cNvSpPr txBox="1"/>
-          <p:nvPr/>
-        </p:nvSpPr>
-        <p:spPr>
-          <a:xfrm>
-            <a:off x="1737360" y="4146804"/>
-            <a:ext cx="2103120" cy="274320"/>
+          <p:cNvPr id="76" name="TextBox 75"/>
+          <p:cNvSpPr txBox="1"/>
+          <p:nvPr/>
+        </p:nvSpPr>
+        <p:spPr>
+          <a:xfrm>
+            <a:off x="1737360" y="4155948"/>
+            <a:ext cx="1874519" cy="274320"/>
           </a:xfrm>
           <a:prstGeom prst="rect">
             <a:avLst/>
@@ -5435,7 +5750,7 @@
           <a:p>
             <a:pPr algn="l"/>
             <a:r>
-              <a:rPr sz="1250" b="1" i="0">
+              <a:rPr sz="1200" b="1" i="0">
                 <a:solidFill>
                   <a:srgbClr val="FFFFFF"/>
                 </a:solidFill>
@@ -5448,14 +5763,14 @@
       </p:sp>
       <p:sp>
         <p:nvSpPr>
-          <p:cNvPr id="68" name="TextBox 67"/>
-          <p:cNvSpPr txBox="1"/>
-          <p:nvPr/>
-        </p:nvSpPr>
-        <p:spPr>
-          <a:xfrm>
-            <a:off x="3840480" y="4146804"/>
-            <a:ext cx="685800" cy="274320"/>
+          <p:cNvPr id="77" name="TextBox 76"/>
+          <p:cNvSpPr txBox="1"/>
+          <p:nvPr/>
+        </p:nvSpPr>
+        <p:spPr>
+          <a:xfrm>
+            <a:off x="3611879" y="4146804"/>
+            <a:ext cx="548640" cy="274320"/>
           </a:xfrm>
           <a:prstGeom prst="rect">
             <a:avLst/>
@@ -5483,14 +5798,14 @@
       </p:sp>
       <p:sp>
         <p:nvSpPr>
-          <p:cNvPr id="69" name="TextBox 68"/>
-          <p:cNvSpPr txBox="1"/>
-          <p:nvPr/>
-        </p:nvSpPr>
-        <p:spPr>
-          <a:xfrm>
-            <a:off x="4526280" y="4160520"/>
-            <a:ext cx="685800" cy="274320"/>
+          <p:cNvPr id="78" name="TextBox 77"/>
+          <p:cNvSpPr txBox="1"/>
+          <p:nvPr/>
+        </p:nvSpPr>
+        <p:spPr>
+          <a:xfrm>
+            <a:off x="4160520" y="4160520"/>
+            <a:ext cx="548640" cy="274320"/>
           </a:xfrm>
           <a:prstGeom prst="rect">
             <a:avLst/>
@@ -5518,14 +5833,14 @@
       </p:sp>
       <p:sp>
         <p:nvSpPr>
-          <p:cNvPr id="70" name="TextBox 69"/>
-          <p:cNvSpPr txBox="1"/>
-          <p:nvPr/>
-        </p:nvSpPr>
-        <p:spPr>
-          <a:xfrm>
-            <a:off x="5212080" y="4160520"/>
-            <a:ext cx="594360" cy="274320"/>
+          <p:cNvPr id="79" name="TextBox 78"/>
+          <p:cNvSpPr txBox="1"/>
+          <p:nvPr/>
+        </p:nvSpPr>
+        <p:spPr>
+          <a:xfrm>
+            <a:off x="4709160" y="4160520"/>
+            <a:ext cx="548640" cy="274320"/>
           </a:xfrm>
           <a:prstGeom prst="rect">
             <a:avLst/>
@@ -5540,6 +5855,41 @@
           <a:p>
             <a:pPr algn="r"/>
             <a:r>
+              <a:rPr sz="1100" b="0" i="0">
+                <a:solidFill>
+                  <a:srgbClr val="CADCFC"/>
+                </a:solidFill>
+                <a:latin typeface="Arial"/>
+              </a:rPr>
+              <a:t>-4.3</a:t>
+            </a:r>
+          </a:p>
+        </p:txBody>
+      </p:sp>
+      <p:sp>
+        <p:nvSpPr>
+          <p:cNvPr id="80" name="TextBox 79"/>
+          <p:cNvSpPr txBox="1"/>
+          <p:nvPr/>
+        </p:nvSpPr>
+        <p:spPr>
+          <a:xfrm>
+            <a:off x="5257800" y="4160520"/>
+            <a:ext cx="548640" cy="274320"/>
+          </a:xfrm>
+          <a:prstGeom prst="rect">
+            <a:avLst/>
+          </a:prstGeom>
+          <a:noFill/>
+        </p:spPr>
+        <p:txBody>
+          <a:bodyPr wrap="square" lIns="0" rIns="0" tIns="0" bIns="0">
+            <a:spAutoFit/>
+          </a:bodyPr>
+          <a:lstStyle/>
+          <a:p>
+            <a:pPr algn="r"/>
+            <a:r>
               <a:rPr sz="1000" b="0" i="0">
                 <a:solidFill>
                   <a:srgbClr val="CADCFC"/>
@@ -5553,7 +5903,7 @@
       </p:sp>
       <p:sp>
         <p:nvSpPr>
-          <p:cNvPr id="71" name="Rectangle 70"/>
+          <p:cNvPr id="81" name="Rectangle 80"/>
           <p:cNvSpPr/>
           <p:nvPr/>
         </p:nvSpPr>
@@ -5597,7 +5947,7 @@
       </p:sp>
       <p:sp>
         <p:nvSpPr>
-          <p:cNvPr id="72" name="TextBox 71"/>
+          <p:cNvPr id="82" name="TextBox 81"/>
           <p:cNvSpPr txBox="1"/>
           <p:nvPr/>
         </p:nvSpPr>
@@ -5632,7 +5982,7 @@
       </p:sp>
       <p:sp>
         <p:nvSpPr>
-          <p:cNvPr id="73" name="Oval 72"/>
+          <p:cNvPr id="83" name="Oval 82"/>
           <p:cNvSpPr/>
           <p:nvPr/>
         </p:nvSpPr>
@@ -5676,7 +6026,7 @@
       </p:sp>
       <p:pic>
         <p:nvPicPr>
-          <p:cNvPr id="74" name="Picture 73" descr="texasam.png"/>
+          <p:cNvPr id="84" name="Picture 83" descr="texasam.png"/>
           <p:cNvPicPr>
             <a:picLocks noChangeAspect="1"/>
           </p:cNvPicPr>
@@ -5700,14 +6050,14 @@
       </p:pic>
       <p:sp>
         <p:nvSpPr>
-          <p:cNvPr id="75" name="TextBox 74"/>
-          <p:cNvSpPr txBox="1"/>
-          <p:nvPr/>
-        </p:nvSpPr>
-        <p:spPr>
-          <a:xfrm>
-            <a:off x="1737360" y="4475988"/>
-            <a:ext cx="2103120" cy="274320"/>
+          <p:cNvPr id="85" name="TextBox 84"/>
+          <p:cNvSpPr txBox="1"/>
+          <p:nvPr/>
+        </p:nvSpPr>
+        <p:spPr>
+          <a:xfrm>
+            <a:off x="1737360" y="4485131"/>
+            <a:ext cx="1874519" cy="274320"/>
           </a:xfrm>
           <a:prstGeom prst="rect">
             <a:avLst/>
@@ -5722,7 +6072,7 @@
           <a:p>
             <a:pPr algn="l"/>
             <a:r>
-              <a:rPr sz="1250" b="1" i="0">
+              <a:rPr sz="1200" b="1" i="0">
                 <a:solidFill>
                   <a:srgbClr val="FFFFFF"/>
                 </a:solidFill>
@@ -5735,14 +6085,14 @@
       </p:sp>
       <p:sp>
         <p:nvSpPr>
-          <p:cNvPr id="76" name="TextBox 75"/>
-          <p:cNvSpPr txBox="1"/>
-          <p:nvPr/>
-        </p:nvSpPr>
-        <p:spPr>
-          <a:xfrm>
-            <a:off x="3840480" y="4475988"/>
-            <a:ext cx="685800" cy="274320"/>
+          <p:cNvPr id="86" name="TextBox 85"/>
+          <p:cNvSpPr txBox="1"/>
+          <p:nvPr/>
+        </p:nvSpPr>
+        <p:spPr>
+          <a:xfrm>
+            <a:off x="3611879" y="4475988"/>
+            <a:ext cx="548640" cy="274320"/>
           </a:xfrm>
           <a:prstGeom prst="rect">
             <a:avLst/>
@@ -5770,14 +6120,14 @@
       </p:sp>
       <p:sp>
         <p:nvSpPr>
-          <p:cNvPr id="77" name="TextBox 76"/>
-          <p:cNvSpPr txBox="1"/>
-          <p:nvPr/>
-        </p:nvSpPr>
-        <p:spPr>
-          <a:xfrm>
-            <a:off x="4526280" y="4489703"/>
-            <a:ext cx="685800" cy="274320"/>
+          <p:cNvPr id="87" name="TextBox 86"/>
+          <p:cNvSpPr txBox="1"/>
+          <p:nvPr/>
+        </p:nvSpPr>
+        <p:spPr>
+          <a:xfrm>
+            <a:off x="4160520" y="4489703"/>
+            <a:ext cx="548640" cy="274320"/>
           </a:xfrm>
           <a:prstGeom prst="rect">
             <a:avLst/>
@@ -5805,14 +6155,14 @@
       </p:sp>
       <p:sp>
         <p:nvSpPr>
-          <p:cNvPr id="78" name="TextBox 77"/>
-          <p:cNvSpPr txBox="1"/>
-          <p:nvPr/>
-        </p:nvSpPr>
-        <p:spPr>
-          <a:xfrm>
-            <a:off x="5212080" y="4489703"/>
-            <a:ext cx="594360" cy="274320"/>
+          <p:cNvPr id="88" name="TextBox 87"/>
+          <p:cNvSpPr txBox="1"/>
+          <p:nvPr/>
+        </p:nvSpPr>
+        <p:spPr>
+          <a:xfrm>
+            <a:off x="4709160" y="4489703"/>
+            <a:ext cx="548640" cy="274320"/>
           </a:xfrm>
           <a:prstGeom prst="rect">
             <a:avLst/>
@@ -5827,6 +6177,41 @@
           <a:p>
             <a:pPr algn="r"/>
             <a:r>
+              <a:rPr sz="1100" b="1" i="0">
+                <a:solidFill>
+                  <a:srgbClr val="F47321"/>
+                </a:solidFill>
+                <a:latin typeface="Arial"/>
+              </a:rPr>
+              <a:t>+8.3</a:t>
+            </a:r>
+          </a:p>
+        </p:txBody>
+      </p:sp>
+      <p:sp>
+        <p:nvSpPr>
+          <p:cNvPr id="89" name="TextBox 88"/>
+          <p:cNvSpPr txBox="1"/>
+          <p:nvPr/>
+        </p:nvSpPr>
+        <p:spPr>
+          <a:xfrm>
+            <a:off x="5257800" y="4489703"/>
+            <a:ext cx="548640" cy="274320"/>
+          </a:xfrm>
+          <a:prstGeom prst="rect">
+            <a:avLst/>
+          </a:prstGeom>
+          <a:noFill/>
+        </p:spPr>
+        <p:txBody>
+          <a:bodyPr wrap="square" lIns="0" rIns="0" tIns="0" bIns="0">
+            <a:spAutoFit/>
+          </a:bodyPr>
+          <a:lstStyle/>
+          <a:p>
+            <a:pPr algn="r"/>
+            <a:r>
               <a:rPr sz="1000" b="0" i="0">
                 <a:solidFill>
                   <a:srgbClr val="CADCFC"/>
@@ -5840,7 +6225,7 @@
       </p:sp>
       <p:sp>
         <p:nvSpPr>
-          <p:cNvPr id="79" name="TextBox 78"/>
+          <p:cNvPr id="90" name="TextBox 89"/>
           <p:cNvSpPr txBox="1"/>
           <p:nvPr/>
         </p:nvSpPr>
@@ -5875,7 +6260,7 @@
       </p:sp>
       <p:sp>
         <p:nvSpPr>
-          <p:cNvPr id="80" name="Oval 79"/>
+          <p:cNvPr id="91" name="Oval 90"/>
           <p:cNvSpPr/>
           <p:nvPr/>
         </p:nvSpPr>
@@ -5919,7 +6304,7 @@
       </p:sp>
       <p:pic>
         <p:nvPicPr>
-          <p:cNvPr id="81" name="Picture 80" descr="tennessee.png"/>
+          <p:cNvPr id="92" name="Picture 91" descr="tennessee.png"/>
           <p:cNvPicPr>
             <a:picLocks noChangeAspect="1"/>
           </p:cNvPicPr>
@@ -5943,14 +6328,14 @@
       </p:pic>
       <p:sp>
         <p:nvSpPr>
-          <p:cNvPr id="82" name="TextBox 81"/>
-          <p:cNvSpPr txBox="1"/>
-          <p:nvPr/>
-        </p:nvSpPr>
-        <p:spPr>
-          <a:xfrm>
-            <a:off x="1737360" y="4805172"/>
-            <a:ext cx="2103120" cy="274320"/>
+          <p:cNvPr id="93" name="TextBox 92"/>
+          <p:cNvSpPr txBox="1"/>
+          <p:nvPr/>
+        </p:nvSpPr>
+        <p:spPr>
+          <a:xfrm>
+            <a:off x="1737360" y="4814316"/>
+            <a:ext cx="1874519" cy="274320"/>
           </a:xfrm>
           <a:prstGeom prst="rect">
             <a:avLst/>
@@ -5965,7 +6350,7 @@
           <a:p>
             <a:pPr algn="l"/>
             <a:r>
-              <a:rPr sz="1250" b="1" i="0">
+              <a:rPr sz="1200" b="1" i="0">
                 <a:solidFill>
                   <a:srgbClr val="FFFFFF"/>
                 </a:solidFill>
@@ -5978,14 +6363,14 @@
       </p:sp>
       <p:sp>
         <p:nvSpPr>
-          <p:cNvPr id="83" name="TextBox 82"/>
-          <p:cNvSpPr txBox="1"/>
-          <p:nvPr/>
-        </p:nvSpPr>
-        <p:spPr>
-          <a:xfrm>
-            <a:off x="3840480" y="4805172"/>
-            <a:ext cx="685800" cy="274320"/>
+          <p:cNvPr id="94" name="TextBox 93"/>
+          <p:cNvSpPr txBox="1"/>
+          <p:nvPr/>
+        </p:nvSpPr>
+        <p:spPr>
+          <a:xfrm>
+            <a:off x="3611879" y="4805172"/>
+            <a:ext cx="548640" cy="274320"/>
           </a:xfrm>
           <a:prstGeom prst="rect">
             <a:avLst/>
@@ -6013,14 +6398,14 @@
       </p:sp>
       <p:sp>
         <p:nvSpPr>
-          <p:cNvPr id="84" name="TextBox 83"/>
-          <p:cNvSpPr txBox="1"/>
-          <p:nvPr/>
-        </p:nvSpPr>
-        <p:spPr>
-          <a:xfrm>
-            <a:off x="4526280" y="4818888"/>
-            <a:ext cx="685800" cy="274320"/>
+          <p:cNvPr id="95" name="TextBox 94"/>
+          <p:cNvSpPr txBox="1"/>
+          <p:nvPr/>
+        </p:nvSpPr>
+        <p:spPr>
+          <a:xfrm>
+            <a:off x="4160520" y="4818888"/>
+            <a:ext cx="548640" cy="274320"/>
           </a:xfrm>
           <a:prstGeom prst="rect">
             <a:avLst/>
@@ -6048,14 +6433,14 @@
       </p:sp>
       <p:sp>
         <p:nvSpPr>
-          <p:cNvPr id="85" name="TextBox 84"/>
-          <p:cNvSpPr txBox="1"/>
-          <p:nvPr/>
-        </p:nvSpPr>
-        <p:spPr>
-          <a:xfrm>
-            <a:off x="5212080" y="4818888"/>
-            <a:ext cx="594360" cy="274320"/>
+          <p:cNvPr id="96" name="TextBox 95"/>
+          <p:cNvSpPr txBox="1"/>
+          <p:nvPr/>
+        </p:nvSpPr>
+        <p:spPr>
+          <a:xfrm>
+            <a:off x="4709160" y="4818888"/>
+            <a:ext cx="548640" cy="274320"/>
           </a:xfrm>
           <a:prstGeom prst="rect">
             <a:avLst/>
@@ -6070,6 +6455,41 @@
           <a:p>
             <a:pPr algn="r"/>
             <a:r>
+              <a:rPr sz="1100" b="1" i="0">
+                <a:solidFill>
+                  <a:srgbClr val="F47321"/>
+                </a:solidFill>
+                <a:latin typeface="Arial"/>
+              </a:rPr>
+              <a:t>+8.8</a:t>
+            </a:r>
+          </a:p>
+        </p:txBody>
+      </p:sp>
+      <p:sp>
+        <p:nvSpPr>
+          <p:cNvPr id="97" name="TextBox 96"/>
+          <p:cNvSpPr txBox="1"/>
+          <p:nvPr/>
+        </p:nvSpPr>
+        <p:spPr>
+          <a:xfrm>
+            <a:off x="5257800" y="4818888"/>
+            <a:ext cx="548640" cy="274320"/>
+          </a:xfrm>
+          <a:prstGeom prst="rect">
+            <a:avLst/>
+          </a:prstGeom>
+          <a:noFill/>
+        </p:spPr>
+        <p:txBody>
+          <a:bodyPr wrap="square" lIns="0" rIns="0" tIns="0" bIns="0">
+            <a:spAutoFit/>
+          </a:bodyPr>
+          <a:lstStyle/>
+          <a:p>
+            <a:pPr algn="r"/>
+            <a:r>
               <a:rPr sz="1000" b="0" i="0">
                 <a:solidFill>
                   <a:srgbClr val="CADCFC"/>
@@ -6083,7 +6503,7 @@
       </p:sp>
       <p:sp>
         <p:nvSpPr>
-          <p:cNvPr id="86" name="Rectangle 85"/>
+          <p:cNvPr id="98" name="Rectangle 97"/>
           <p:cNvSpPr/>
           <p:nvPr/>
         </p:nvSpPr>
@@ -6127,7 +6547,7 @@
       </p:sp>
       <p:sp>
         <p:nvSpPr>
-          <p:cNvPr id="87" name="TextBox 86"/>
+          <p:cNvPr id="99" name="TextBox 98"/>
           <p:cNvSpPr txBox="1"/>
           <p:nvPr/>
         </p:nvSpPr>
@@ -6162,7 +6582,7 @@
       </p:sp>
       <p:sp>
         <p:nvSpPr>
-          <p:cNvPr id="88" name="Oval 87"/>
+          <p:cNvPr id="100" name="Oval 99"/>
           <p:cNvSpPr/>
           <p:nvPr/>
         </p:nvSpPr>
@@ -6206,7 +6626,7 @@
       </p:sp>
       <p:pic>
         <p:nvPicPr>
-          <p:cNvPr id="89" name="Picture 88" descr="oregon.png"/>
+          <p:cNvPr id="101" name="Picture 100" descr="oregon.png"/>
           <p:cNvPicPr>
             <a:picLocks noChangeAspect="1"/>
           </p:cNvPicPr>
@@ -6230,14 +6650,14 @@
       </p:pic>
       <p:sp>
         <p:nvSpPr>
-          <p:cNvPr id="90" name="TextBox 89"/>
-          <p:cNvSpPr txBox="1"/>
-          <p:nvPr/>
-        </p:nvSpPr>
-        <p:spPr>
-          <a:xfrm>
-            <a:off x="1737360" y="5134356"/>
-            <a:ext cx="2103120" cy="274320"/>
+          <p:cNvPr id="102" name="TextBox 101"/>
+          <p:cNvSpPr txBox="1"/>
+          <p:nvPr/>
+        </p:nvSpPr>
+        <p:spPr>
+          <a:xfrm>
+            <a:off x="1737360" y="5143500"/>
+            <a:ext cx="1874519" cy="274320"/>
           </a:xfrm>
           <a:prstGeom prst="rect">
             <a:avLst/>
@@ -6252,7 +6672,7 @@
           <a:p>
             <a:pPr algn="l"/>
             <a:r>
-              <a:rPr sz="1250" b="1" i="0">
+              <a:rPr sz="1200" b="1" i="0">
                 <a:solidFill>
                   <a:srgbClr val="FFFFFF"/>
                 </a:solidFill>
@@ -6265,14 +6685,14 @@
       </p:sp>
       <p:sp>
         <p:nvSpPr>
-          <p:cNvPr id="91" name="TextBox 90"/>
-          <p:cNvSpPr txBox="1"/>
-          <p:nvPr/>
-        </p:nvSpPr>
-        <p:spPr>
-          <a:xfrm>
-            <a:off x="3840480" y="5134356"/>
-            <a:ext cx="685800" cy="274320"/>
+          <p:cNvPr id="103" name="TextBox 102"/>
+          <p:cNvSpPr txBox="1"/>
+          <p:nvPr/>
+        </p:nvSpPr>
+        <p:spPr>
+          <a:xfrm>
+            <a:off x="3611879" y="5134356"/>
+            <a:ext cx="548640" cy="274320"/>
           </a:xfrm>
           <a:prstGeom prst="rect">
             <a:avLst/>
@@ -6300,14 +6720,14 @@
       </p:sp>
       <p:sp>
         <p:nvSpPr>
-          <p:cNvPr id="92" name="TextBox 91"/>
-          <p:cNvSpPr txBox="1"/>
-          <p:nvPr/>
-        </p:nvSpPr>
-        <p:spPr>
-          <a:xfrm>
-            <a:off x="4526280" y="5148072"/>
-            <a:ext cx="685800" cy="274320"/>
+          <p:cNvPr id="104" name="TextBox 103"/>
+          <p:cNvSpPr txBox="1"/>
+          <p:nvPr/>
+        </p:nvSpPr>
+        <p:spPr>
+          <a:xfrm>
+            <a:off x="4160520" y="5148072"/>
+            <a:ext cx="548640" cy="274320"/>
           </a:xfrm>
           <a:prstGeom prst="rect">
             <a:avLst/>
@@ -6335,14 +6755,14 @@
       </p:sp>
       <p:sp>
         <p:nvSpPr>
-          <p:cNvPr id="93" name="TextBox 92"/>
-          <p:cNvSpPr txBox="1"/>
-          <p:nvPr/>
-        </p:nvSpPr>
-        <p:spPr>
-          <a:xfrm>
-            <a:off x="5212080" y="5148072"/>
-            <a:ext cx="594360" cy="274320"/>
+          <p:cNvPr id="105" name="TextBox 104"/>
+          <p:cNvSpPr txBox="1"/>
+          <p:nvPr/>
+        </p:nvSpPr>
+        <p:spPr>
+          <a:xfrm>
+            <a:off x="4709160" y="5148072"/>
+            <a:ext cx="548640" cy="274320"/>
           </a:xfrm>
           <a:prstGeom prst="rect">
             <a:avLst/>
@@ -6357,6 +6777,41 @@
           <a:p>
             <a:pPr algn="r"/>
             <a:r>
+              <a:rPr sz="1100" b="1" i="0">
+                <a:solidFill>
+                  <a:srgbClr val="F47321"/>
+                </a:solidFill>
+                <a:latin typeface="Arial"/>
+              </a:rPr>
+              <a:t>-7.5</a:t>
+            </a:r>
+          </a:p>
+        </p:txBody>
+      </p:sp>
+      <p:sp>
+        <p:nvSpPr>
+          <p:cNvPr id="106" name="TextBox 105"/>
+          <p:cNvSpPr txBox="1"/>
+          <p:nvPr/>
+        </p:nvSpPr>
+        <p:spPr>
+          <a:xfrm>
+            <a:off x="5257800" y="5148072"/>
+            <a:ext cx="548640" cy="274320"/>
+          </a:xfrm>
+          <a:prstGeom prst="rect">
+            <a:avLst/>
+          </a:prstGeom>
+          <a:noFill/>
+        </p:spPr>
+        <p:txBody>
+          <a:bodyPr wrap="square" lIns="0" rIns="0" tIns="0" bIns="0">
+            <a:spAutoFit/>
+          </a:bodyPr>
+          <a:lstStyle/>
+          <a:p>
+            <a:pPr algn="r"/>
+            <a:r>
               <a:rPr sz="1000" b="0" i="0">
                 <a:solidFill>
                   <a:srgbClr val="CADCFC"/>
@@ -6370,7 +6825,7 @@
       </p:sp>
       <p:sp>
         <p:nvSpPr>
-          <p:cNvPr id="94" name="TextBox 93"/>
+          <p:cNvPr id="107" name="TextBox 106"/>
           <p:cNvSpPr txBox="1"/>
           <p:nvPr/>
         </p:nvSpPr>
@@ -6405,7 +6860,7 @@
       </p:sp>
       <p:sp>
         <p:nvSpPr>
-          <p:cNvPr id="95" name="Oval 94"/>
+          <p:cNvPr id="108" name="Oval 107"/>
           <p:cNvSpPr/>
           <p:nvPr/>
         </p:nvSpPr>
@@ -6449,7 +6904,7 @@
       </p:sp>
       <p:pic>
         <p:nvPicPr>
-          <p:cNvPr id="96" name="Picture 95" descr="texastech.png"/>
+          <p:cNvPr id="109" name="Picture 108" descr="texastech.png"/>
           <p:cNvPicPr>
             <a:picLocks noChangeAspect="1"/>
           </p:cNvPicPr>
@@ -6473,14 +6928,14 @@
       </p:pic>
       <p:sp>
         <p:nvSpPr>
-          <p:cNvPr id="97" name="TextBox 96"/>
-          <p:cNvSpPr txBox="1"/>
-          <p:nvPr/>
-        </p:nvSpPr>
-        <p:spPr>
-          <a:xfrm>
-            <a:off x="1737360" y="5463540"/>
-            <a:ext cx="2103120" cy="274320"/>
+          <p:cNvPr id="110" name="TextBox 109"/>
+          <p:cNvSpPr txBox="1"/>
+          <p:nvPr/>
+        </p:nvSpPr>
+        <p:spPr>
+          <a:xfrm>
+            <a:off x="1737360" y="5472683"/>
+            <a:ext cx="1874519" cy="274320"/>
           </a:xfrm>
           <a:prstGeom prst="rect">
             <a:avLst/>
@@ -6495,7 +6950,7 @@
           <a:p>
             <a:pPr algn="l"/>
             <a:r>
-              <a:rPr sz="1250" b="1" i="0">
+              <a:rPr sz="1200" b="1" i="0">
                 <a:solidFill>
                   <a:srgbClr val="FFFFFF"/>
                 </a:solidFill>
@@ -6508,14 +6963,14 @@
       </p:sp>
       <p:sp>
         <p:nvSpPr>
-          <p:cNvPr id="98" name="TextBox 97"/>
-          <p:cNvSpPr txBox="1"/>
-          <p:nvPr/>
-        </p:nvSpPr>
-        <p:spPr>
-          <a:xfrm>
-            <a:off x="3840480" y="5463540"/>
-            <a:ext cx="685800" cy="274320"/>
+          <p:cNvPr id="111" name="TextBox 110"/>
+          <p:cNvSpPr txBox="1"/>
+          <p:nvPr/>
+        </p:nvSpPr>
+        <p:spPr>
+          <a:xfrm>
+            <a:off x="3611879" y="5463540"/>
+            <a:ext cx="548640" cy="274320"/>
           </a:xfrm>
           <a:prstGeom prst="rect">
             <a:avLst/>
@@ -6543,14 +6998,14 @@
       </p:sp>
       <p:sp>
         <p:nvSpPr>
-          <p:cNvPr id="99" name="TextBox 98"/>
-          <p:cNvSpPr txBox="1"/>
-          <p:nvPr/>
-        </p:nvSpPr>
-        <p:spPr>
-          <a:xfrm>
-            <a:off x="4526280" y="5477255"/>
-            <a:ext cx="685800" cy="274320"/>
+          <p:cNvPr id="112" name="TextBox 111"/>
+          <p:cNvSpPr txBox="1"/>
+          <p:nvPr/>
+        </p:nvSpPr>
+        <p:spPr>
+          <a:xfrm>
+            <a:off x="4160520" y="5477255"/>
+            <a:ext cx="548640" cy="274320"/>
           </a:xfrm>
           <a:prstGeom prst="rect">
             <a:avLst/>
@@ -6578,14 +7033,14 @@
       </p:sp>
       <p:sp>
         <p:nvSpPr>
-          <p:cNvPr id="100" name="TextBox 99"/>
-          <p:cNvSpPr txBox="1"/>
-          <p:nvPr/>
-        </p:nvSpPr>
-        <p:spPr>
-          <a:xfrm>
-            <a:off x="5212080" y="5477255"/>
-            <a:ext cx="594360" cy="274320"/>
+          <p:cNvPr id="113" name="TextBox 112"/>
+          <p:cNvSpPr txBox="1"/>
+          <p:nvPr/>
+        </p:nvSpPr>
+        <p:spPr>
+          <a:xfrm>
+            <a:off x="4709160" y="5477255"/>
+            <a:ext cx="548640" cy="274320"/>
           </a:xfrm>
           <a:prstGeom prst="rect">
             <a:avLst/>
@@ -6600,6 +7055,41 @@
           <a:p>
             <a:pPr algn="r"/>
             <a:r>
+              <a:rPr sz="1100" b="1" i="0">
+                <a:solidFill>
+                  <a:srgbClr val="F47321"/>
+                </a:solidFill>
+                <a:latin typeface="Arial"/>
+              </a:rPr>
+              <a:t>+14.1</a:t>
+            </a:r>
+          </a:p>
+        </p:txBody>
+      </p:sp>
+      <p:sp>
+        <p:nvSpPr>
+          <p:cNvPr id="114" name="TextBox 113"/>
+          <p:cNvSpPr txBox="1"/>
+          <p:nvPr/>
+        </p:nvSpPr>
+        <p:spPr>
+          <a:xfrm>
+            <a:off x="5257800" y="5477255"/>
+            <a:ext cx="548640" cy="274320"/>
+          </a:xfrm>
+          <a:prstGeom prst="rect">
+            <a:avLst/>
+          </a:prstGeom>
+          <a:noFill/>
+        </p:spPr>
+        <p:txBody>
+          <a:bodyPr wrap="square" lIns="0" rIns="0" tIns="0" bIns="0">
+            <a:spAutoFit/>
+          </a:bodyPr>
+          <a:lstStyle/>
+          <a:p>
+            <a:pPr algn="r"/>
+            <a:r>
               <a:rPr sz="1000" b="0" i="0">
                 <a:solidFill>
                   <a:srgbClr val="CADCFC"/>
@@ -6613,7 +7103,7 @@
       </p:sp>
       <p:sp>
         <p:nvSpPr>
-          <p:cNvPr id="101" name="Rectangle 100"/>
+          <p:cNvPr id="115" name="Rectangle 114"/>
           <p:cNvSpPr/>
           <p:nvPr/>
         </p:nvSpPr>
@@ -6657,7 +7147,7 @@
       </p:sp>
       <p:sp>
         <p:nvSpPr>
-          <p:cNvPr id="102" name="TextBox 101"/>
+          <p:cNvPr id="116" name="TextBox 115"/>
           <p:cNvSpPr txBox="1"/>
           <p:nvPr/>
         </p:nvSpPr>
@@ -6692,7 +7182,7 @@
       </p:sp>
       <p:sp>
         <p:nvSpPr>
-          <p:cNvPr id="103" name="Oval 102"/>
+          <p:cNvPr id="117" name="Oval 116"/>
           <p:cNvSpPr/>
           <p:nvPr/>
         </p:nvSpPr>
@@ -6736,7 +7226,7 @@
       </p:sp>
       <p:pic>
         <p:nvPicPr>
-          <p:cNvPr id="104" name="Picture 103" descr="usc.png"/>
+          <p:cNvPr id="118" name="Picture 117" descr="usc.png"/>
           <p:cNvPicPr>
             <a:picLocks noChangeAspect="1"/>
           </p:cNvPicPr>
@@ -6760,14 +7250,14 @@
       </p:pic>
       <p:sp>
         <p:nvSpPr>
-          <p:cNvPr id="105" name="TextBox 104"/>
-          <p:cNvSpPr txBox="1"/>
-          <p:nvPr/>
-        </p:nvSpPr>
-        <p:spPr>
-          <a:xfrm>
-            <a:off x="1737360" y="5792724"/>
-            <a:ext cx="2103120" cy="274320"/>
+          <p:cNvPr id="119" name="TextBox 118"/>
+          <p:cNvSpPr txBox="1"/>
+          <p:nvPr/>
+        </p:nvSpPr>
+        <p:spPr>
+          <a:xfrm>
+            <a:off x="1737360" y="5801868"/>
+            <a:ext cx="1874519" cy="274320"/>
           </a:xfrm>
           <a:prstGeom prst="rect">
             <a:avLst/>
@@ -6782,7 +7272,7 @@
           <a:p>
             <a:pPr algn="l"/>
             <a:r>
-              <a:rPr sz="1250" b="1" i="0">
+              <a:rPr sz="1200" b="1" i="0">
                 <a:solidFill>
                   <a:srgbClr val="FFFFFF"/>
                 </a:solidFill>
@@ -6795,14 +7285,14 @@
       </p:sp>
       <p:sp>
         <p:nvSpPr>
-          <p:cNvPr id="106" name="TextBox 105"/>
-          <p:cNvSpPr txBox="1"/>
-          <p:nvPr/>
-        </p:nvSpPr>
-        <p:spPr>
-          <a:xfrm>
-            <a:off x="3840480" y="5792724"/>
-            <a:ext cx="685800" cy="274320"/>
+          <p:cNvPr id="120" name="TextBox 119"/>
+          <p:cNvSpPr txBox="1"/>
+          <p:nvPr/>
+        </p:nvSpPr>
+        <p:spPr>
+          <a:xfrm>
+            <a:off x="3611879" y="5792724"/>
+            <a:ext cx="548640" cy="274320"/>
           </a:xfrm>
           <a:prstGeom prst="rect">
             <a:avLst/>
@@ -6830,14 +7320,14 @@
       </p:sp>
       <p:sp>
         <p:nvSpPr>
-          <p:cNvPr id="107" name="TextBox 106"/>
-          <p:cNvSpPr txBox="1"/>
-          <p:nvPr/>
-        </p:nvSpPr>
-        <p:spPr>
-          <a:xfrm>
-            <a:off x="4526280" y="5806440"/>
-            <a:ext cx="685800" cy="274320"/>
+          <p:cNvPr id="121" name="TextBox 120"/>
+          <p:cNvSpPr txBox="1"/>
+          <p:nvPr/>
+        </p:nvSpPr>
+        <p:spPr>
+          <a:xfrm>
+            <a:off x="4160520" y="5806440"/>
+            <a:ext cx="548640" cy="274320"/>
           </a:xfrm>
           <a:prstGeom prst="rect">
             <a:avLst/>
@@ -6865,14 +7355,14 @@
       </p:sp>
       <p:sp>
         <p:nvSpPr>
-          <p:cNvPr id="108" name="TextBox 107"/>
-          <p:cNvSpPr txBox="1"/>
-          <p:nvPr/>
-        </p:nvSpPr>
-        <p:spPr>
-          <a:xfrm>
-            <a:off x="5212080" y="5806440"/>
-            <a:ext cx="594360" cy="274320"/>
+          <p:cNvPr id="122" name="TextBox 121"/>
+          <p:cNvSpPr txBox="1"/>
+          <p:nvPr/>
+        </p:nvSpPr>
+        <p:spPr>
+          <a:xfrm>
+            <a:off x="4709160" y="5806440"/>
+            <a:ext cx="548640" cy="274320"/>
           </a:xfrm>
           <a:prstGeom prst="rect">
             <a:avLst/>
@@ -6887,6 +7377,41 @@
           <a:p>
             <a:pPr algn="r"/>
             <a:r>
+              <a:rPr sz="1100" b="0" i="0">
+                <a:solidFill>
+                  <a:srgbClr val="CADCFC"/>
+                </a:solidFill>
+                <a:latin typeface="Arial"/>
+              </a:rPr>
+              <a:t>-1.0</a:t>
+            </a:r>
+          </a:p>
+        </p:txBody>
+      </p:sp>
+      <p:sp>
+        <p:nvSpPr>
+          <p:cNvPr id="123" name="TextBox 122"/>
+          <p:cNvSpPr txBox="1"/>
+          <p:nvPr/>
+        </p:nvSpPr>
+        <p:spPr>
+          <a:xfrm>
+            <a:off x="5257800" y="5806440"/>
+            <a:ext cx="548640" cy="274320"/>
+          </a:xfrm>
+          <a:prstGeom prst="rect">
+            <a:avLst/>
+          </a:prstGeom>
+          <a:noFill/>
+        </p:spPr>
+        <p:txBody>
+          <a:bodyPr wrap="square" lIns="0" rIns="0" tIns="0" bIns="0">
+            <a:spAutoFit/>
+          </a:bodyPr>
+          <a:lstStyle/>
+          <a:p>
+            <a:pPr algn="r"/>
+            <a:r>
               <a:rPr sz="1000" b="0" i="0">
                 <a:solidFill>
                   <a:srgbClr val="CADCFC"/>
@@ -6900,7 +7425,7 @@
       </p:sp>
       <p:sp>
         <p:nvSpPr>
-          <p:cNvPr id="109" name="Rectangle 108"/>
+          <p:cNvPr id="124" name="Rectangle 123"/>
           <p:cNvSpPr/>
           <p:nvPr/>
         </p:nvSpPr>
@@ -6944,7 +7469,7 @@
       </p:sp>
       <p:sp>
         <p:nvSpPr>
-          <p:cNvPr id="110" name="TextBox 109"/>
+          <p:cNvPr id="125" name="TextBox 124"/>
           <p:cNvSpPr txBox="1"/>
           <p:nvPr/>
         </p:nvSpPr>
@@ -6979,7 +7504,7 @@
       </p:sp>
       <p:sp>
         <p:nvSpPr>
-          <p:cNvPr id="111" name="Oval 110"/>
+          <p:cNvPr id="126" name="Oval 125"/>
           <p:cNvSpPr/>
           <p:nvPr/>
         </p:nvSpPr>
@@ -7023,7 +7548,7 @@
       </p:sp>
       <p:pic>
         <p:nvPicPr>
-          <p:cNvPr id="112" name="Picture 111" descr="olemiss.png"/>
+          <p:cNvPr id="127" name="Picture 126" descr="olemiss.png"/>
           <p:cNvPicPr>
             <a:picLocks noChangeAspect="1"/>
           </p:cNvPicPr>
@@ -7047,14 +7572,14 @@
       </p:pic>
       <p:sp>
         <p:nvSpPr>
-          <p:cNvPr id="113" name="TextBox 112"/>
-          <p:cNvSpPr txBox="1"/>
-          <p:nvPr/>
-        </p:nvSpPr>
-        <p:spPr>
-          <a:xfrm>
-            <a:off x="7269480" y="1842516"/>
-            <a:ext cx="2103120" cy="274320"/>
+          <p:cNvPr id="128" name="TextBox 127"/>
+          <p:cNvSpPr txBox="1"/>
+          <p:nvPr/>
+        </p:nvSpPr>
+        <p:spPr>
+          <a:xfrm>
+            <a:off x="7269480" y="1851660"/>
+            <a:ext cx="1874519" cy="274320"/>
           </a:xfrm>
           <a:prstGeom prst="rect">
             <a:avLst/>
@@ -7069,7 +7594,7 @@
           <a:p>
             <a:pPr algn="l"/>
             <a:r>
-              <a:rPr sz="1250" b="1" i="0">
+              <a:rPr sz="1200" b="1" i="0">
                 <a:solidFill>
                   <a:srgbClr val="FFFFFF"/>
                 </a:solidFill>
@@ -7082,14 +7607,14 @@
       </p:sp>
       <p:sp>
         <p:nvSpPr>
-          <p:cNvPr id="114" name="TextBox 113"/>
-          <p:cNvSpPr txBox="1"/>
-          <p:nvPr/>
-        </p:nvSpPr>
-        <p:spPr>
-          <a:xfrm>
-            <a:off x="9372600" y="1842516"/>
-            <a:ext cx="685800" cy="274320"/>
+          <p:cNvPr id="129" name="TextBox 128"/>
+          <p:cNvSpPr txBox="1"/>
+          <p:nvPr/>
+        </p:nvSpPr>
+        <p:spPr>
+          <a:xfrm>
+            <a:off x="9144000" y="1842516"/>
+            <a:ext cx="548640" cy="274320"/>
           </a:xfrm>
           <a:prstGeom prst="rect">
             <a:avLst/>
@@ -7117,14 +7642,14 @@
       </p:sp>
       <p:sp>
         <p:nvSpPr>
-          <p:cNvPr id="115" name="TextBox 114"/>
-          <p:cNvSpPr txBox="1"/>
-          <p:nvPr/>
-        </p:nvSpPr>
-        <p:spPr>
-          <a:xfrm>
-            <a:off x="10058400" y="1856231"/>
-            <a:ext cx="685800" cy="274320"/>
+          <p:cNvPr id="130" name="TextBox 129"/>
+          <p:cNvSpPr txBox="1"/>
+          <p:nvPr/>
+        </p:nvSpPr>
+        <p:spPr>
+          <a:xfrm>
+            <a:off x="9692640" y="1856231"/>
+            <a:ext cx="548640" cy="274320"/>
           </a:xfrm>
           <a:prstGeom prst="rect">
             <a:avLst/>
@@ -7152,14 +7677,14 @@
       </p:sp>
       <p:sp>
         <p:nvSpPr>
-          <p:cNvPr id="116" name="TextBox 115"/>
-          <p:cNvSpPr txBox="1"/>
-          <p:nvPr/>
-        </p:nvSpPr>
-        <p:spPr>
-          <a:xfrm>
-            <a:off x="10744200" y="1856231"/>
-            <a:ext cx="594360" cy="274320"/>
+          <p:cNvPr id="131" name="TextBox 130"/>
+          <p:cNvSpPr txBox="1"/>
+          <p:nvPr/>
+        </p:nvSpPr>
+        <p:spPr>
+          <a:xfrm>
+            <a:off x="10241280" y="1856231"/>
+            <a:ext cx="548640" cy="274320"/>
           </a:xfrm>
           <a:prstGeom prst="rect">
             <a:avLst/>
@@ -7174,6 +7699,41 @@
           <a:p>
             <a:pPr algn="r"/>
             <a:r>
+              <a:rPr sz="1100" b="0" i="0">
+                <a:solidFill>
+                  <a:srgbClr val="CADCFC"/>
+                </a:solidFill>
+                <a:latin typeface="Arial"/>
+              </a:rPr>
+              <a:t>+4.3</a:t>
+            </a:r>
+          </a:p>
+        </p:txBody>
+      </p:sp>
+      <p:sp>
+        <p:nvSpPr>
+          <p:cNvPr id="132" name="TextBox 131"/>
+          <p:cNvSpPr txBox="1"/>
+          <p:nvPr/>
+        </p:nvSpPr>
+        <p:spPr>
+          <a:xfrm>
+            <a:off x="10789920" y="1856231"/>
+            <a:ext cx="548640" cy="274320"/>
+          </a:xfrm>
+          <a:prstGeom prst="rect">
+            <a:avLst/>
+          </a:prstGeom>
+          <a:noFill/>
+        </p:spPr>
+        <p:txBody>
+          <a:bodyPr wrap="square" lIns="0" rIns="0" tIns="0" bIns="0">
+            <a:spAutoFit/>
+          </a:bodyPr>
+          <a:lstStyle/>
+          <a:p>
+            <a:pPr algn="r"/>
+            <a:r>
               <a:rPr sz="1000" b="0" i="0">
                 <a:solidFill>
                   <a:srgbClr val="CADCFC"/>
@@ -7187,7 +7747,7 @@
       </p:sp>
       <p:sp>
         <p:nvSpPr>
-          <p:cNvPr id="117" name="TextBox 116"/>
+          <p:cNvPr id="133" name="TextBox 132"/>
           <p:cNvSpPr txBox="1"/>
           <p:nvPr/>
         </p:nvSpPr>
@@ -7222,7 +7782,7 @@
       </p:sp>
       <p:sp>
         <p:nvSpPr>
-          <p:cNvPr id="118" name="Oval 117"/>
+          <p:cNvPr id="134" name="Oval 133"/>
           <p:cNvSpPr/>
           <p:nvPr/>
         </p:nvSpPr>
@@ -7266,7 +7826,7 @@
       </p:sp>
       <p:pic>
         <p:nvPicPr>
-          <p:cNvPr id="119" name="Picture 118" descr="oklahoma.png"/>
+          <p:cNvPr id="135" name="Picture 134" descr="oklahoma.png"/>
           <p:cNvPicPr>
             <a:picLocks noChangeAspect="1"/>
           </p:cNvPicPr>
@@ -7290,14 +7850,14 @@
       </p:pic>
       <p:sp>
         <p:nvSpPr>
-          <p:cNvPr id="120" name="TextBox 119"/>
-          <p:cNvSpPr txBox="1"/>
-          <p:nvPr/>
-        </p:nvSpPr>
-        <p:spPr>
-          <a:xfrm>
-            <a:off x="7269480" y="2171700"/>
-            <a:ext cx="2103120" cy="274320"/>
+          <p:cNvPr id="136" name="TextBox 135"/>
+          <p:cNvSpPr txBox="1"/>
+          <p:nvPr/>
+        </p:nvSpPr>
+        <p:spPr>
+          <a:xfrm>
+            <a:off x="7269480" y="2180844"/>
+            <a:ext cx="1874519" cy="274320"/>
           </a:xfrm>
           <a:prstGeom prst="rect">
             <a:avLst/>
@@ -7312,7 +7872,7 @@
           <a:p>
             <a:pPr algn="l"/>
             <a:r>
-              <a:rPr sz="1250" b="1" i="0">
+              <a:rPr sz="1200" b="1" i="0">
                 <a:solidFill>
                   <a:srgbClr val="FFFFFF"/>
                 </a:solidFill>
@@ -7325,14 +7885,14 @@
       </p:sp>
       <p:sp>
         <p:nvSpPr>
-          <p:cNvPr id="121" name="TextBox 120"/>
-          <p:cNvSpPr txBox="1"/>
-          <p:nvPr/>
-        </p:nvSpPr>
-        <p:spPr>
-          <a:xfrm>
-            <a:off x="9372600" y="2171700"/>
-            <a:ext cx="685800" cy="274320"/>
+          <p:cNvPr id="137" name="TextBox 136"/>
+          <p:cNvSpPr txBox="1"/>
+          <p:nvPr/>
+        </p:nvSpPr>
+        <p:spPr>
+          <a:xfrm>
+            <a:off x="9144000" y="2171700"/>
+            <a:ext cx="548640" cy="274320"/>
           </a:xfrm>
           <a:prstGeom prst="rect">
             <a:avLst/>
@@ -7360,14 +7920,14 @@
       </p:sp>
       <p:sp>
         <p:nvSpPr>
-          <p:cNvPr id="122" name="TextBox 121"/>
-          <p:cNvSpPr txBox="1"/>
-          <p:nvPr/>
-        </p:nvSpPr>
-        <p:spPr>
-          <a:xfrm>
-            <a:off x="10058400" y="2185415"/>
-            <a:ext cx="685800" cy="274320"/>
+          <p:cNvPr id="138" name="TextBox 137"/>
+          <p:cNvSpPr txBox="1"/>
+          <p:nvPr/>
+        </p:nvSpPr>
+        <p:spPr>
+          <a:xfrm>
+            <a:off x="9692640" y="2185415"/>
+            <a:ext cx="548640" cy="274320"/>
           </a:xfrm>
           <a:prstGeom prst="rect">
             <a:avLst/>
@@ -7395,14 +7955,14 @@
       </p:sp>
       <p:sp>
         <p:nvSpPr>
-          <p:cNvPr id="123" name="TextBox 122"/>
-          <p:cNvSpPr txBox="1"/>
-          <p:nvPr/>
-        </p:nvSpPr>
-        <p:spPr>
-          <a:xfrm>
-            <a:off x="10744200" y="2185415"/>
-            <a:ext cx="594360" cy="274320"/>
+          <p:cNvPr id="139" name="TextBox 138"/>
+          <p:cNvSpPr txBox="1"/>
+          <p:nvPr/>
+        </p:nvSpPr>
+        <p:spPr>
+          <a:xfrm>
+            <a:off x="10241280" y="2185415"/>
+            <a:ext cx="548640" cy="274320"/>
           </a:xfrm>
           <a:prstGeom prst="rect">
             <a:avLst/>
@@ -7417,6 +7977,41 @@
           <a:p>
             <a:pPr algn="r"/>
             <a:r>
+              <a:rPr sz="1100" b="0" i="0">
+                <a:solidFill>
+                  <a:srgbClr val="CADCFC"/>
+                </a:solidFill>
+                <a:latin typeface="Arial"/>
+              </a:rPr>
+              <a:t>+2.8</a:t>
+            </a:r>
+          </a:p>
+        </p:txBody>
+      </p:sp>
+      <p:sp>
+        <p:nvSpPr>
+          <p:cNvPr id="140" name="TextBox 139"/>
+          <p:cNvSpPr txBox="1"/>
+          <p:nvPr/>
+        </p:nvSpPr>
+        <p:spPr>
+          <a:xfrm>
+            <a:off x="10789920" y="2185415"/>
+            <a:ext cx="548640" cy="274320"/>
+          </a:xfrm>
+          <a:prstGeom prst="rect">
+            <a:avLst/>
+          </a:prstGeom>
+          <a:noFill/>
+        </p:spPr>
+        <p:txBody>
+          <a:bodyPr wrap="square" lIns="0" rIns="0" tIns="0" bIns="0">
+            <a:spAutoFit/>
+          </a:bodyPr>
+          <a:lstStyle/>
+          <a:p>
+            <a:pPr algn="r"/>
+            <a:r>
               <a:rPr sz="1000" b="0" i="0">
                 <a:solidFill>
                   <a:srgbClr val="CADCFC"/>
@@ -7430,7 +8025,7 @@
       </p:sp>
       <p:sp>
         <p:nvSpPr>
-          <p:cNvPr id="124" name="Rectangle 123"/>
+          <p:cNvPr id="141" name="Rectangle 140"/>
           <p:cNvSpPr/>
           <p:nvPr/>
         </p:nvSpPr>
@@ -7474,7 +8069,7 @@
       </p:sp>
       <p:sp>
         <p:nvSpPr>
-          <p:cNvPr id="125" name="TextBox 124"/>
+          <p:cNvPr id="142" name="TextBox 141"/>
           <p:cNvSpPr txBox="1"/>
           <p:nvPr/>
         </p:nvSpPr>
@@ -7509,7 +8104,7 @@
       </p:sp>
       <p:sp>
         <p:nvSpPr>
-          <p:cNvPr id="126" name="Oval 125"/>
+          <p:cNvPr id="143" name="Oval 142"/>
           <p:cNvSpPr/>
           <p:nvPr/>
         </p:nvSpPr>
@@ -7553,7 +8148,7 @@
       </p:sp>
       <p:pic>
         <p:nvPicPr>
-          <p:cNvPr id="127" name="Picture 126" descr="florida.png"/>
+          <p:cNvPr id="144" name="Picture 143" descr="florida.png"/>
           <p:cNvPicPr>
             <a:picLocks noChangeAspect="1"/>
           </p:cNvPicPr>
@@ -7577,14 +8172,14 @@
       </p:pic>
       <p:sp>
         <p:nvSpPr>
-          <p:cNvPr id="128" name="TextBox 127"/>
-          <p:cNvSpPr txBox="1"/>
-          <p:nvPr/>
-        </p:nvSpPr>
-        <p:spPr>
-          <a:xfrm>
-            <a:off x="7269480" y="2500884"/>
-            <a:ext cx="2103120" cy="274320"/>
+          <p:cNvPr id="145" name="TextBox 144"/>
+          <p:cNvSpPr txBox="1"/>
+          <p:nvPr/>
+        </p:nvSpPr>
+        <p:spPr>
+          <a:xfrm>
+            <a:off x="7269480" y="2510028"/>
+            <a:ext cx="1874519" cy="274320"/>
           </a:xfrm>
           <a:prstGeom prst="rect">
             <a:avLst/>
@@ -7599,7 +8194,7 @@
           <a:p>
             <a:pPr algn="l"/>
             <a:r>
-              <a:rPr sz="1250" b="1" i="0">
+              <a:rPr sz="1200" b="1" i="0">
                 <a:solidFill>
                   <a:srgbClr val="FFFFFF"/>
                 </a:solidFill>
@@ -7612,14 +8207,14 @@
       </p:sp>
       <p:sp>
         <p:nvSpPr>
-          <p:cNvPr id="129" name="TextBox 128"/>
-          <p:cNvSpPr txBox="1"/>
-          <p:nvPr/>
-        </p:nvSpPr>
-        <p:spPr>
-          <a:xfrm>
-            <a:off x="9372600" y="2500884"/>
-            <a:ext cx="685800" cy="274320"/>
+          <p:cNvPr id="146" name="TextBox 145"/>
+          <p:cNvSpPr txBox="1"/>
+          <p:nvPr/>
+        </p:nvSpPr>
+        <p:spPr>
+          <a:xfrm>
+            <a:off x="9144000" y="2500884"/>
+            <a:ext cx="548640" cy="274320"/>
           </a:xfrm>
           <a:prstGeom prst="rect">
             <a:avLst/>
@@ -7647,14 +8242,14 @@
       </p:sp>
       <p:sp>
         <p:nvSpPr>
-          <p:cNvPr id="130" name="TextBox 129"/>
-          <p:cNvSpPr txBox="1"/>
-          <p:nvPr/>
-        </p:nvSpPr>
-        <p:spPr>
-          <a:xfrm>
-            <a:off x="10058400" y="2514600"/>
-            <a:ext cx="685800" cy="274320"/>
+          <p:cNvPr id="147" name="TextBox 146"/>
+          <p:cNvSpPr txBox="1"/>
+          <p:nvPr/>
+        </p:nvSpPr>
+        <p:spPr>
+          <a:xfrm>
+            <a:off x="9692640" y="2514600"/>
+            <a:ext cx="548640" cy="274320"/>
           </a:xfrm>
           <a:prstGeom prst="rect">
             <a:avLst/>
@@ -7682,14 +8277,14 @@
       </p:sp>
       <p:sp>
         <p:nvSpPr>
-          <p:cNvPr id="131" name="TextBox 130"/>
-          <p:cNvSpPr txBox="1"/>
-          <p:nvPr/>
-        </p:nvSpPr>
-        <p:spPr>
-          <a:xfrm>
-            <a:off x="10744200" y="2514600"/>
-            <a:ext cx="594360" cy="274320"/>
+          <p:cNvPr id="148" name="TextBox 147"/>
+          <p:cNvSpPr txBox="1"/>
+          <p:nvPr/>
+        </p:nvSpPr>
+        <p:spPr>
+          <a:xfrm>
+            <a:off x="10241280" y="2514600"/>
+            <a:ext cx="548640" cy="274320"/>
           </a:xfrm>
           <a:prstGeom prst="rect">
             <a:avLst/>
@@ -7704,6 +8299,41 @@
           <a:p>
             <a:pPr algn="r"/>
             <a:r>
+              <a:rPr sz="1100" b="1" i="0">
+                <a:solidFill>
+                  <a:srgbClr val="F47321"/>
+                </a:solidFill>
+                <a:latin typeface="Arial"/>
+              </a:rPr>
+              <a:t>+12.4</a:t>
+            </a:r>
+          </a:p>
+        </p:txBody>
+      </p:sp>
+      <p:sp>
+        <p:nvSpPr>
+          <p:cNvPr id="149" name="TextBox 148"/>
+          <p:cNvSpPr txBox="1"/>
+          <p:nvPr/>
+        </p:nvSpPr>
+        <p:spPr>
+          <a:xfrm>
+            <a:off x="10789920" y="2514600"/>
+            <a:ext cx="548640" cy="274320"/>
+          </a:xfrm>
+          <a:prstGeom prst="rect">
+            <a:avLst/>
+          </a:prstGeom>
+          <a:noFill/>
+        </p:spPr>
+        <p:txBody>
+          <a:bodyPr wrap="square" lIns="0" rIns="0" tIns="0" bIns="0">
+            <a:spAutoFit/>
+          </a:bodyPr>
+          <a:lstStyle/>
+          <a:p>
+            <a:pPr algn="r"/>
+            <a:r>
               <a:rPr sz="1000" b="0" i="0">
                 <a:solidFill>
                   <a:srgbClr val="CADCFC"/>
@@ -7717,7 +8347,7 @@
       </p:sp>
       <p:sp>
         <p:nvSpPr>
-          <p:cNvPr id="132" name="TextBox 131"/>
+          <p:cNvPr id="150" name="TextBox 149"/>
           <p:cNvSpPr txBox="1"/>
           <p:nvPr/>
         </p:nvSpPr>
@@ -7752,7 +8382,7 @@
       </p:sp>
       <p:sp>
         <p:nvSpPr>
-          <p:cNvPr id="133" name="Oval 132"/>
+          <p:cNvPr id="151" name="Oval 150"/>
           <p:cNvSpPr/>
           <p:nvPr/>
         </p:nvSpPr>
@@ -7796,7 +8426,7 @@
       </p:sp>
       <p:pic>
         <p:nvPicPr>
-          <p:cNvPr id="134" name="Picture 133" descr="missouri.png"/>
+          <p:cNvPr id="152" name="Picture 151" descr="missouri.png"/>
           <p:cNvPicPr>
             <a:picLocks noChangeAspect="1"/>
           </p:cNvPicPr>
@@ -7820,14 +8450,14 @@
       </p:pic>
       <p:sp>
         <p:nvSpPr>
-          <p:cNvPr id="135" name="TextBox 134"/>
-          <p:cNvSpPr txBox="1"/>
-          <p:nvPr/>
-        </p:nvSpPr>
-        <p:spPr>
-          <a:xfrm>
-            <a:off x="7269480" y="2830068"/>
-            <a:ext cx="2103120" cy="274320"/>
+          <p:cNvPr id="153" name="TextBox 152"/>
+          <p:cNvSpPr txBox="1"/>
+          <p:nvPr/>
+        </p:nvSpPr>
+        <p:spPr>
+          <a:xfrm>
+            <a:off x="7269480" y="2839212"/>
+            <a:ext cx="1874519" cy="274320"/>
           </a:xfrm>
           <a:prstGeom prst="rect">
             <a:avLst/>
@@ -7842,7 +8472,7 @@
           <a:p>
             <a:pPr algn="l"/>
             <a:r>
-              <a:rPr sz="1250" b="1" i="0">
+              <a:rPr sz="1200" b="1" i="0">
                 <a:solidFill>
                   <a:srgbClr val="FFFFFF"/>
                 </a:solidFill>
@@ -7855,14 +8485,14 @@
       </p:sp>
       <p:sp>
         <p:nvSpPr>
-          <p:cNvPr id="136" name="TextBox 135"/>
-          <p:cNvSpPr txBox="1"/>
-          <p:nvPr/>
-        </p:nvSpPr>
-        <p:spPr>
-          <a:xfrm>
-            <a:off x="9372600" y="2830068"/>
-            <a:ext cx="685800" cy="274320"/>
+          <p:cNvPr id="154" name="TextBox 153"/>
+          <p:cNvSpPr txBox="1"/>
+          <p:nvPr/>
+        </p:nvSpPr>
+        <p:spPr>
+          <a:xfrm>
+            <a:off x="9144000" y="2830068"/>
+            <a:ext cx="548640" cy="274320"/>
           </a:xfrm>
           <a:prstGeom prst="rect">
             <a:avLst/>
@@ -7890,14 +8520,14 @@
       </p:sp>
       <p:sp>
         <p:nvSpPr>
-          <p:cNvPr id="137" name="TextBox 136"/>
-          <p:cNvSpPr txBox="1"/>
-          <p:nvPr/>
-        </p:nvSpPr>
-        <p:spPr>
-          <a:xfrm>
-            <a:off x="10058400" y="2843784"/>
-            <a:ext cx="685800" cy="274320"/>
+          <p:cNvPr id="155" name="TextBox 154"/>
+          <p:cNvSpPr txBox="1"/>
+          <p:nvPr/>
+        </p:nvSpPr>
+        <p:spPr>
+          <a:xfrm>
+            <a:off x="9692640" y="2843784"/>
+            <a:ext cx="548640" cy="274320"/>
           </a:xfrm>
           <a:prstGeom prst="rect">
             <a:avLst/>
@@ -7925,14 +8555,14 @@
       </p:sp>
       <p:sp>
         <p:nvSpPr>
-          <p:cNvPr id="138" name="TextBox 137"/>
-          <p:cNvSpPr txBox="1"/>
-          <p:nvPr/>
-        </p:nvSpPr>
-        <p:spPr>
-          <a:xfrm>
-            <a:off x="10744200" y="2843784"/>
-            <a:ext cx="594360" cy="274320"/>
+          <p:cNvPr id="156" name="TextBox 155"/>
+          <p:cNvSpPr txBox="1"/>
+          <p:nvPr/>
+        </p:nvSpPr>
+        <p:spPr>
+          <a:xfrm>
+            <a:off x="10241280" y="2843784"/>
+            <a:ext cx="548640" cy="274320"/>
           </a:xfrm>
           <a:prstGeom prst="rect">
             <a:avLst/>
@@ -7947,6 +8577,41 @@
           <a:p>
             <a:pPr algn="r"/>
             <a:r>
+              <a:rPr sz="1100" b="1" i="0">
+                <a:solidFill>
+                  <a:srgbClr val="F47321"/>
+                </a:solidFill>
+                <a:latin typeface="Arial"/>
+              </a:rPr>
+              <a:t>+12.1</a:t>
+            </a:r>
+          </a:p>
+        </p:txBody>
+      </p:sp>
+      <p:sp>
+        <p:nvSpPr>
+          <p:cNvPr id="157" name="TextBox 156"/>
+          <p:cNvSpPr txBox="1"/>
+          <p:nvPr/>
+        </p:nvSpPr>
+        <p:spPr>
+          <a:xfrm>
+            <a:off x="10789920" y="2843784"/>
+            <a:ext cx="548640" cy="274320"/>
+          </a:xfrm>
+          <a:prstGeom prst="rect">
+            <a:avLst/>
+          </a:prstGeom>
+          <a:noFill/>
+        </p:spPr>
+        <p:txBody>
+          <a:bodyPr wrap="square" lIns="0" rIns="0" tIns="0" bIns="0">
+            <a:spAutoFit/>
+          </a:bodyPr>
+          <a:lstStyle/>
+          <a:p>
+            <a:pPr algn="r"/>
+            <a:r>
               <a:rPr sz="1000" b="0" i="0">
                 <a:solidFill>
                   <a:srgbClr val="CADCFC"/>
@@ -7960,7 +8625,7 @@
       </p:sp>
       <p:sp>
         <p:nvSpPr>
-          <p:cNvPr id="139" name="Rectangle 138"/>
+          <p:cNvPr id="158" name="Rectangle 157"/>
           <p:cNvSpPr/>
           <p:nvPr/>
         </p:nvSpPr>
@@ -8004,7 +8669,7 @@
       </p:sp>
       <p:sp>
         <p:nvSpPr>
-          <p:cNvPr id="140" name="TextBox 139"/>
+          <p:cNvPr id="159" name="TextBox 158"/>
           <p:cNvSpPr txBox="1"/>
           <p:nvPr/>
         </p:nvSpPr>
@@ -8039,7 +8704,7 @@
       </p:sp>
       <p:sp>
         <p:nvSpPr>
-          <p:cNvPr id="141" name="Oval 140"/>
+          <p:cNvPr id="160" name="Oval 159"/>
           <p:cNvSpPr/>
           <p:nvPr/>
         </p:nvSpPr>
@@ -8083,7 +8748,7 @@
       </p:sp>
       <p:pic>
         <p:nvPicPr>
-          <p:cNvPr id="142" name="Picture 141" descr="pennstate.png"/>
+          <p:cNvPr id="161" name="Picture 160" descr="pennstate.png"/>
           <p:cNvPicPr>
             <a:picLocks noChangeAspect="1"/>
           </p:cNvPicPr>
@@ -8107,14 +8772,14 @@
       </p:pic>
       <p:sp>
         <p:nvSpPr>
-          <p:cNvPr id="143" name="TextBox 142"/>
-          <p:cNvSpPr txBox="1"/>
-          <p:nvPr/>
-        </p:nvSpPr>
-        <p:spPr>
-          <a:xfrm>
-            <a:off x="7269480" y="3159252"/>
-            <a:ext cx="2103120" cy="274320"/>
+          <p:cNvPr id="162" name="TextBox 161"/>
+          <p:cNvSpPr txBox="1"/>
+          <p:nvPr/>
+        </p:nvSpPr>
+        <p:spPr>
+          <a:xfrm>
+            <a:off x="7269480" y="3168396"/>
+            <a:ext cx="1874519" cy="274320"/>
           </a:xfrm>
           <a:prstGeom prst="rect">
             <a:avLst/>
@@ -8129,7 +8794,7 @@
           <a:p>
             <a:pPr algn="l"/>
             <a:r>
-              <a:rPr sz="1250" b="1" i="0">
+              <a:rPr sz="1200" b="1" i="0">
                 <a:solidFill>
                   <a:srgbClr val="FFFFFF"/>
                 </a:solidFill>
@@ -8142,14 +8807,14 @@
       </p:sp>
       <p:sp>
         <p:nvSpPr>
-          <p:cNvPr id="144" name="TextBox 143"/>
-          <p:cNvSpPr txBox="1"/>
-          <p:nvPr/>
-        </p:nvSpPr>
-        <p:spPr>
-          <a:xfrm>
-            <a:off x="9372600" y="3159252"/>
-            <a:ext cx="685800" cy="274320"/>
+          <p:cNvPr id="163" name="TextBox 162"/>
+          <p:cNvSpPr txBox="1"/>
+          <p:nvPr/>
+        </p:nvSpPr>
+        <p:spPr>
+          <a:xfrm>
+            <a:off x="9144000" y="3159252"/>
+            <a:ext cx="548640" cy="274320"/>
           </a:xfrm>
           <a:prstGeom prst="rect">
             <a:avLst/>
@@ -8177,14 +8842,14 @@
       </p:sp>
       <p:sp>
         <p:nvSpPr>
-          <p:cNvPr id="145" name="TextBox 144"/>
-          <p:cNvSpPr txBox="1"/>
-          <p:nvPr/>
-        </p:nvSpPr>
-        <p:spPr>
-          <a:xfrm>
-            <a:off x="10058400" y="3172968"/>
-            <a:ext cx="685800" cy="274320"/>
+          <p:cNvPr id="164" name="TextBox 163"/>
+          <p:cNvSpPr txBox="1"/>
+          <p:nvPr/>
+        </p:nvSpPr>
+        <p:spPr>
+          <a:xfrm>
+            <a:off x="9692640" y="3172968"/>
+            <a:ext cx="548640" cy="274320"/>
           </a:xfrm>
           <a:prstGeom prst="rect">
             <a:avLst/>
@@ -8212,14 +8877,14 @@
       </p:sp>
       <p:sp>
         <p:nvSpPr>
-          <p:cNvPr id="146" name="TextBox 145"/>
-          <p:cNvSpPr txBox="1"/>
-          <p:nvPr/>
-        </p:nvSpPr>
-        <p:spPr>
-          <a:xfrm>
-            <a:off x="10744200" y="3172968"/>
-            <a:ext cx="594360" cy="274320"/>
+          <p:cNvPr id="165" name="TextBox 164"/>
+          <p:cNvSpPr txBox="1"/>
+          <p:nvPr/>
+        </p:nvSpPr>
+        <p:spPr>
+          <a:xfrm>
+            <a:off x="10241280" y="3172968"/>
+            <a:ext cx="548640" cy="274320"/>
           </a:xfrm>
           <a:prstGeom prst="rect">
             <a:avLst/>
@@ -8234,6 +8899,41 @@
           <a:p>
             <a:pPr algn="r"/>
             <a:r>
+              <a:rPr sz="1100" b="1" i="0">
+                <a:solidFill>
+                  <a:srgbClr val="F47321"/>
+                </a:solidFill>
+                <a:latin typeface="Arial"/>
+              </a:rPr>
+              <a:t>+9.7</a:t>
+            </a:r>
+          </a:p>
+        </p:txBody>
+      </p:sp>
+      <p:sp>
+        <p:nvSpPr>
+          <p:cNvPr id="166" name="TextBox 165"/>
+          <p:cNvSpPr txBox="1"/>
+          <p:nvPr/>
+        </p:nvSpPr>
+        <p:spPr>
+          <a:xfrm>
+            <a:off x="10789920" y="3172968"/>
+            <a:ext cx="548640" cy="274320"/>
+          </a:xfrm>
+          <a:prstGeom prst="rect">
+            <a:avLst/>
+          </a:prstGeom>
+          <a:noFill/>
+        </p:spPr>
+        <p:txBody>
+          <a:bodyPr wrap="square" lIns="0" rIns="0" tIns="0" bIns="0">
+            <a:spAutoFit/>
+          </a:bodyPr>
+          <a:lstStyle/>
+          <a:p>
+            <a:pPr algn="r"/>
+            <a:r>
               <a:rPr sz="1000" b="0" i="0">
                 <a:solidFill>
                   <a:srgbClr val="CADCFC"/>
@@ -8247,7 +8947,7 @@
       </p:sp>
       <p:sp>
         <p:nvSpPr>
-          <p:cNvPr id="147" name="TextBox 146"/>
+          <p:cNvPr id="167" name="TextBox 166"/>
           <p:cNvSpPr txBox="1"/>
           <p:nvPr/>
         </p:nvSpPr>
@@ -8282,7 +8982,7 @@
       </p:sp>
       <p:sp>
         <p:nvSpPr>
-          <p:cNvPr id="148" name="Oval 147"/>
+          <p:cNvPr id="168" name="Oval 167"/>
           <p:cNvSpPr/>
           <p:nvPr/>
         </p:nvSpPr>
@@ -8326,7 +9026,7 @@
       </p:sp>
       <p:pic>
         <p:nvPicPr>
-          <p:cNvPr id="149" name="Picture 148" descr="byu.png"/>
+          <p:cNvPr id="169" name="Picture 168" descr="byu.png"/>
           <p:cNvPicPr>
             <a:picLocks noChangeAspect="1"/>
           </p:cNvPicPr>
@@ -8350,14 +9050,14 @@
       </p:pic>
       <p:sp>
         <p:nvSpPr>
-          <p:cNvPr id="150" name="TextBox 149"/>
-          <p:cNvSpPr txBox="1"/>
-          <p:nvPr/>
-        </p:nvSpPr>
-        <p:spPr>
-          <a:xfrm>
-            <a:off x="7269480" y="3488436"/>
-            <a:ext cx="2103120" cy="274320"/>
+          <p:cNvPr id="170" name="TextBox 169"/>
+          <p:cNvSpPr txBox="1"/>
+          <p:nvPr/>
+        </p:nvSpPr>
+        <p:spPr>
+          <a:xfrm>
+            <a:off x="7269480" y="3497579"/>
+            <a:ext cx="1874519" cy="274320"/>
           </a:xfrm>
           <a:prstGeom prst="rect">
             <a:avLst/>
@@ -8372,7 +9072,7 @@
           <a:p>
             <a:pPr algn="l"/>
             <a:r>
-              <a:rPr sz="1250" b="1" i="0">
+              <a:rPr sz="1200" b="1" i="0">
                 <a:solidFill>
                   <a:srgbClr val="FFFFFF"/>
                 </a:solidFill>
@@ -8385,14 +9085,14 @@
       </p:sp>
       <p:sp>
         <p:nvSpPr>
-          <p:cNvPr id="151" name="TextBox 150"/>
-          <p:cNvSpPr txBox="1"/>
-          <p:nvPr/>
-        </p:nvSpPr>
-        <p:spPr>
-          <a:xfrm>
-            <a:off x="9372600" y="3488436"/>
-            <a:ext cx="685800" cy="274320"/>
+          <p:cNvPr id="171" name="TextBox 170"/>
+          <p:cNvSpPr txBox="1"/>
+          <p:nvPr/>
+        </p:nvSpPr>
+        <p:spPr>
+          <a:xfrm>
+            <a:off x="9144000" y="3488436"/>
+            <a:ext cx="548640" cy="274320"/>
           </a:xfrm>
           <a:prstGeom prst="rect">
             <a:avLst/>
@@ -8420,14 +9120,14 @@
       </p:sp>
       <p:sp>
         <p:nvSpPr>
-          <p:cNvPr id="152" name="TextBox 151"/>
-          <p:cNvSpPr txBox="1"/>
-          <p:nvPr/>
-        </p:nvSpPr>
-        <p:spPr>
-          <a:xfrm>
-            <a:off x="10058400" y="3502151"/>
-            <a:ext cx="685800" cy="274320"/>
+          <p:cNvPr id="172" name="TextBox 171"/>
+          <p:cNvSpPr txBox="1"/>
+          <p:nvPr/>
+        </p:nvSpPr>
+        <p:spPr>
+          <a:xfrm>
+            <a:off x="9692640" y="3502151"/>
+            <a:ext cx="548640" cy="274320"/>
           </a:xfrm>
           <a:prstGeom prst="rect">
             <a:avLst/>
@@ -8455,14 +9155,14 @@
       </p:sp>
       <p:sp>
         <p:nvSpPr>
-          <p:cNvPr id="153" name="TextBox 152"/>
-          <p:cNvSpPr txBox="1"/>
-          <p:nvPr/>
-        </p:nvSpPr>
-        <p:spPr>
-          <a:xfrm>
-            <a:off x="10744200" y="3502151"/>
-            <a:ext cx="594360" cy="274320"/>
+          <p:cNvPr id="173" name="TextBox 172"/>
+          <p:cNvSpPr txBox="1"/>
+          <p:nvPr/>
+        </p:nvSpPr>
+        <p:spPr>
+          <a:xfrm>
+            <a:off x="10241280" y="3502151"/>
+            <a:ext cx="548640" cy="274320"/>
           </a:xfrm>
           <a:prstGeom prst="rect">
             <a:avLst/>
@@ -8477,6 +9177,41 @@
           <a:p>
             <a:pPr algn="r"/>
             <a:r>
+              <a:rPr sz="1100" b="1" i="0">
+                <a:solidFill>
+                  <a:srgbClr val="F47321"/>
+                </a:solidFill>
+                <a:latin typeface="Arial"/>
+              </a:rPr>
+              <a:t>-5.4</a:t>
+            </a:r>
+          </a:p>
+        </p:txBody>
+      </p:sp>
+      <p:sp>
+        <p:nvSpPr>
+          <p:cNvPr id="174" name="TextBox 173"/>
+          <p:cNvSpPr txBox="1"/>
+          <p:nvPr/>
+        </p:nvSpPr>
+        <p:spPr>
+          <a:xfrm>
+            <a:off x="10789920" y="3502151"/>
+            <a:ext cx="548640" cy="274320"/>
+          </a:xfrm>
+          <a:prstGeom prst="rect">
+            <a:avLst/>
+          </a:prstGeom>
+          <a:noFill/>
+        </p:spPr>
+        <p:txBody>
+          <a:bodyPr wrap="square" lIns="0" rIns="0" tIns="0" bIns="0">
+            <a:spAutoFit/>
+          </a:bodyPr>
+          <a:lstStyle/>
+          <a:p>
+            <a:pPr algn="r"/>
+            <a:r>
               <a:rPr sz="1000" b="0" i="0">
                 <a:solidFill>
                   <a:srgbClr val="CADCFC"/>
@@ -8490,7 +9225,7 @@
       </p:sp>
       <p:sp>
         <p:nvSpPr>
-          <p:cNvPr id="154" name="Rectangle 153"/>
+          <p:cNvPr id="175" name="Rectangle 174"/>
           <p:cNvSpPr/>
           <p:nvPr/>
         </p:nvSpPr>
@@ -8534,7 +9269,7 @@
       </p:sp>
       <p:sp>
         <p:nvSpPr>
-          <p:cNvPr id="155" name="TextBox 154"/>
+          <p:cNvPr id="176" name="TextBox 175"/>
           <p:cNvSpPr txBox="1"/>
           <p:nvPr/>
         </p:nvSpPr>
@@ -8569,7 +9304,7 @@
       </p:sp>
       <p:sp>
         <p:nvSpPr>
-          <p:cNvPr id="156" name="Oval 155"/>
+          <p:cNvPr id="177" name="Oval 176"/>
           <p:cNvSpPr/>
           <p:nvPr/>
         </p:nvSpPr>
@@ -8613,7 +9348,7 @@
       </p:sp>
       <p:pic>
         <p:nvPicPr>
-          <p:cNvPr id="157" name="Picture 156" descr="michigan.png"/>
+          <p:cNvPr id="178" name="Picture 177" descr="michigan.png"/>
           <p:cNvPicPr>
             <a:picLocks noChangeAspect="1"/>
           </p:cNvPicPr>
@@ -8637,14 +9372,14 @@
       </p:pic>
       <p:sp>
         <p:nvSpPr>
-          <p:cNvPr id="158" name="TextBox 157"/>
-          <p:cNvSpPr txBox="1"/>
-          <p:nvPr/>
-        </p:nvSpPr>
-        <p:spPr>
-          <a:xfrm>
-            <a:off x="7269480" y="3817620"/>
-            <a:ext cx="2103120" cy="274320"/>
+          <p:cNvPr id="179" name="TextBox 178"/>
+          <p:cNvSpPr txBox="1"/>
+          <p:nvPr/>
+        </p:nvSpPr>
+        <p:spPr>
+          <a:xfrm>
+            <a:off x="7269480" y="3826764"/>
+            <a:ext cx="1874519" cy="274320"/>
           </a:xfrm>
           <a:prstGeom prst="rect">
             <a:avLst/>
@@ -8659,7 +9394,7 @@
           <a:p>
             <a:pPr algn="l"/>
             <a:r>
-              <a:rPr sz="1250" b="1" i="0">
+              <a:rPr sz="1200" b="1" i="0">
                 <a:solidFill>
                   <a:srgbClr val="FFFFFF"/>
                 </a:solidFill>
@@ -8672,14 +9407,14 @@
       </p:sp>
       <p:sp>
         <p:nvSpPr>
-          <p:cNvPr id="159" name="TextBox 158"/>
-          <p:cNvSpPr txBox="1"/>
-          <p:nvPr/>
-        </p:nvSpPr>
-        <p:spPr>
-          <a:xfrm>
-            <a:off x="9372600" y="3817620"/>
-            <a:ext cx="685800" cy="274320"/>
+          <p:cNvPr id="180" name="TextBox 179"/>
+          <p:cNvSpPr txBox="1"/>
+          <p:nvPr/>
+        </p:nvSpPr>
+        <p:spPr>
+          <a:xfrm>
+            <a:off x="9144000" y="3817620"/>
+            <a:ext cx="548640" cy="274320"/>
           </a:xfrm>
           <a:prstGeom prst="rect">
             <a:avLst/>
@@ -8707,14 +9442,14 @@
       </p:sp>
       <p:sp>
         <p:nvSpPr>
-          <p:cNvPr id="160" name="TextBox 159"/>
-          <p:cNvSpPr txBox="1"/>
-          <p:nvPr/>
-        </p:nvSpPr>
-        <p:spPr>
-          <a:xfrm>
-            <a:off x="10058400" y="3831336"/>
-            <a:ext cx="685800" cy="274320"/>
+          <p:cNvPr id="181" name="TextBox 180"/>
+          <p:cNvSpPr txBox="1"/>
+          <p:nvPr/>
+        </p:nvSpPr>
+        <p:spPr>
+          <a:xfrm>
+            <a:off x="9692640" y="3831336"/>
+            <a:ext cx="548640" cy="274320"/>
           </a:xfrm>
           <a:prstGeom prst="rect">
             <a:avLst/>
@@ -8742,14 +9477,14 @@
       </p:sp>
       <p:sp>
         <p:nvSpPr>
-          <p:cNvPr id="161" name="TextBox 160"/>
-          <p:cNvSpPr txBox="1"/>
-          <p:nvPr/>
-        </p:nvSpPr>
-        <p:spPr>
-          <a:xfrm>
-            <a:off x="10744200" y="3831336"/>
-            <a:ext cx="594360" cy="274320"/>
+          <p:cNvPr id="182" name="TextBox 181"/>
+          <p:cNvSpPr txBox="1"/>
+          <p:nvPr/>
+        </p:nvSpPr>
+        <p:spPr>
+          <a:xfrm>
+            <a:off x="10241280" y="3831336"/>
+            <a:ext cx="548640" cy="274320"/>
           </a:xfrm>
           <a:prstGeom prst="rect">
             <a:avLst/>
@@ -8764,6 +9499,41 @@
           <a:p>
             <a:pPr algn="r"/>
             <a:r>
+              <a:rPr sz="1100" b="0" i="0">
+                <a:solidFill>
+                  <a:srgbClr val="CADCFC"/>
+                </a:solidFill>
+                <a:latin typeface="Arial"/>
+              </a:rPr>
+              <a:t>-4.2</a:t>
+            </a:r>
+          </a:p>
+        </p:txBody>
+      </p:sp>
+      <p:sp>
+        <p:nvSpPr>
+          <p:cNvPr id="183" name="TextBox 182"/>
+          <p:cNvSpPr txBox="1"/>
+          <p:nvPr/>
+        </p:nvSpPr>
+        <p:spPr>
+          <a:xfrm>
+            <a:off x="10789920" y="3831336"/>
+            <a:ext cx="548640" cy="274320"/>
+          </a:xfrm>
+          <a:prstGeom prst="rect">
+            <a:avLst/>
+          </a:prstGeom>
+          <a:noFill/>
+        </p:spPr>
+        <p:txBody>
+          <a:bodyPr wrap="square" lIns="0" rIns="0" tIns="0" bIns="0">
+            <a:spAutoFit/>
+          </a:bodyPr>
+          <a:lstStyle/>
+          <a:p>
+            <a:pPr algn="r"/>
+            <a:r>
               <a:rPr sz="1000" b="0" i="0">
                 <a:solidFill>
                   <a:srgbClr val="CADCFC"/>
@@ -8777,7 +9547,7 @@
       </p:sp>
       <p:sp>
         <p:nvSpPr>
-          <p:cNvPr id="162" name="TextBox 161"/>
+          <p:cNvPr id="184" name="TextBox 183"/>
           <p:cNvSpPr txBox="1"/>
           <p:nvPr/>
         </p:nvSpPr>
@@ -8812,7 +9582,7 @@
       </p:sp>
       <p:sp>
         <p:nvSpPr>
-          <p:cNvPr id="163" name="Oval 162"/>
+          <p:cNvPr id="185" name="Oval 184"/>
           <p:cNvSpPr/>
           <p:nvPr/>
         </p:nvSpPr>
@@ -8856,7 +9626,7 @@
       </p:sp>
       <p:pic>
         <p:nvPicPr>
-          <p:cNvPr id="164" name="Picture 163" descr="utah.png"/>
+          <p:cNvPr id="186" name="Picture 185" descr="utah.png"/>
           <p:cNvPicPr>
             <a:picLocks noChangeAspect="1"/>
           </p:cNvPicPr>
@@ -8880,14 +9650,14 @@
       </p:pic>
       <p:sp>
         <p:nvSpPr>
-          <p:cNvPr id="165" name="TextBox 164"/>
-          <p:cNvSpPr txBox="1"/>
-          <p:nvPr/>
-        </p:nvSpPr>
-        <p:spPr>
-          <a:xfrm>
-            <a:off x="7269480" y="4146804"/>
-            <a:ext cx="2103120" cy="274320"/>
+          <p:cNvPr id="187" name="TextBox 186"/>
+          <p:cNvSpPr txBox="1"/>
+          <p:nvPr/>
+        </p:nvSpPr>
+        <p:spPr>
+          <a:xfrm>
+            <a:off x="7269480" y="4155948"/>
+            <a:ext cx="1874519" cy="274320"/>
           </a:xfrm>
           <a:prstGeom prst="rect">
             <a:avLst/>
@@ -8902,7 +9672,7 @@
           <a:p>
             <a:pPr algn="l"/>
             <a:r>
-              <a:rPr sz="1250" b="1" i="0">
+              <a:rPr sz="1200" b="1" i="0">
                 <a:solidFill>
                   <a:srgbClr val="FFFFFF"/>
                 </a:solidFill>
@@ -8915,14 +9685,14 @@
       </p:sp>
       <p:sp>
         <p:nvSpPr>
-          <p:cNvPr id="166" name="TextBox 165"/>
-          <p:cNvSpPr txBox="1"/>
-          <p:nvPr/>
-        </p:nvSpPr>
-        <p:spPr>
-          <a:xfrm>
-            <a:off x="9372600" y="4146804"/>
-            <a:ext cx="685800" cy="274320"/>
+          <p:cNvPr id="188" name="TextBox 187"/>
+          <p:cNvSpPr txBox="1"/>
+          <p:nvPr/>
+        </p:nvSpPr>
+        <p:spPr>
+          <a:xfrm>
+            <a:off x="9144000" y="4146804"/>
+            <a:ext cx="548640" cy="274320"/>
           </a:xfrm>
           <a:prstGeom prst="rect">
             <a:avLst/>
@@ -8950,14 +9720,14 @@
       </p:sp>
       <p:sp>
         <p:nvSpPr>
-          <p:cNvPr id="167" name="TextBox 166"/>
-          <p:cNvSpPr txBox="1"/>
-          <p:nvPr/>
-        </p:nvSpPr>
-        <p:spPr>
-          <a:xfrm>
-            <a:off x="10058400" y="4160520"/>
-            <a:ext cx="685800" cy="274320"/>
+          <p:cNvPr id="189" name="TextBox 188"/>
+          <p:cNvSpPr txBox="1"/>
+          <p:nvPr/>
+        </p:nvSpPr>
+        <p:spPr>
+          <a:xfrm>
+            <a:off x="9692640" y="4160520"/>
+            <a:ext cx="548640" cy="274320"/>
           </a:xfrm>
           <a:prstGeom prst="rect">
             <a:avLst/>
@@ -8985,14 +9755,14 @@
       </p:sp>
       <p:sp>
         <p:nvSpPr>
-          <p:cNvPr id="168" name="TextBox 167"/>
-          <p:cNvSpPr txBox="1"/>
-          <p:nvPr/>
-        </p:nvSpPr>
-        <p:spPr>
-          <a:xfrm>
-            <a:off x="10744200" y="4160520"/>
-            <a:ext cx="594360" cy="274320"/>
+          <p:cNvPr id="190" name="TextBox 189"/>
+          <p:cNvSpPr txBox="1"/>
+          <p:nvPr/>
+        </p:nvSpPr>
+        <p:spPr>
+          <a:xfrm>
+            <a:off x="10241280" y="4160520"/>
+            <a:ext cx="548640" cy="274320"/>
           </a:xfrm>
           <a:prstGeom prst="rect">
             <a:avLst/>
@@ -9007,6 +9777,41 @@
           <a:p>
             <a:pPr algn="r"/>
             <a:r>
+              <a:rPr sz="1100" b="1" i="0">
+                <a:solidFill>
+                  <a:srgbClr val="F47321"/>
+                </a:solidFill>
+                <a:latin typeface="Arial"/>
+              </a:rPr>
+              <a:t>+14.3</a:t>
+            </a:r>
+          </a:p>
+        </p:txBody>
+      </p:sp>
+      <p:sp>
+        <p:nvSpPr>
+          <p:cNvPr id="191" name="TextBox 190"/>
+          <p:cNvSpPr txBox="1"/>
+          <p:nvPr/>
+        </p:nvSpPr>
+        <p:spPr>
+          <a:xfrm>
+            <a:off x="10789920" y="4160520"/>
+            <a:ext cx="548640" cy="274320"/>
+          </a:xfrm>
+          <a:prstGeom prst="rect">
+            <a:avLst/>
+          </a:prstGeom>
+          <a:noFill/>
+        </p:spPr>
+        <p:txBody>
+          <a:bodyPr wrap="square" lIns="0" rIns="0" tIns="0" bIns="0">
+            <a:spAutoFit/>
+          </a:bodyPr>
+          <a:lstStyle/>
+          <a:p>
+            <a:pPr algn="r"/>
+            <a:r>
               <a:rPr sz="1000" b="0" i="0">
                 <a:solidFill>
                   <a:srgbClr val="CADCFC"/>
@@ -9020,7 +9825,7 @@
       </p:sp>
       <p:sp>
         <p:nvSpPr>
-          <p:cNvPr id="169" name="Rectangle 168"/>
+          <p:cNvPr id="192" name="Rectangle 191"/>
           <p:cNvSpPr/>
           <p:nvPr/>
         </p:nvSpPr>
@@ -9064,7 +9869,7 @@
       </p:sp>
       <p:sp>
         <p:nvSpPr>
-          <p:cNvPr id="170" name="TextBox 169"/>
+          <p:cNvPr id="193" name="TextBox 192"/>
           <p:cNvSpPr txBox="1"/>
           <p:nvPr/>
         </p:nvSpPr>
@@ -9099,7 +9904,7 @@
       </p:sp>
       <p:sp>
         <p:nvSpPr>
-          <p:cNvPr id="171" name="Oval 170"/>
+          <p:cNvPr id="194" name="Oval 193"/>
           <p:cNvSpPr/>
           <p:nvPr/>
         </p:nvSpPr>
@@ -9143,7 +9948,7 @@
       </p:sp>
       <p:pic>
         <p:nvPicPr>
-          <p:cNvPr id="172" name="Picture 171" descr="auburn.png"/>
+          <p:cNvPr id="195" name="Picture 194" descr="auburn.png"/>
           <p:cNvPicPr>
             <a:picLocks noChangeAspect="1"/>
           </p:cNvPicPr>
@@ -9167,14 +9972,14 @@
       </p:pic>
       <p:sp>
         <p:nvSpPr>
-          <p:cNvPr id="173" name="TextBox 172"/>
-          <p:cNvSpPr txBox="1"/>
-          <p:nvPr/>
-        </p:nvSpPr>
-        <p:spPr>
-          <a:xfrm>
-            <a:off x="7269480" y="4475988"/>
-            <a:ext cx="2103120" cy="274320"/>
+          <p:cNvPr id="196" name="TextBox 195"/>
+          <p:cNvSpPr txBox="1"/>
+          <p:nvPr/>
+        </p:nvSpPr>
+        <p:spPr>
+          <a:xfrm>
+            <a:off x="7269480" y="4485131"/>
+            <a:ext cx="1874519" cy="274320"/>
           </a:xfrm>
           <a:prstGeom prst="rect">
             <a:avLst/>
@@ -9189,7 +9994,7 @@
           <a:p>
             <a:pPr algn="l"/>
             <a:r>
-              <a:rPr sz="1250" b="1" i="0">
+              <a:rPr sz="1200" b="1" i="0">
                 <a:solidFill>
                   <a:srgbClr val="FFFFFF"/>
                 </a:solidFill>
@@ -9202,14 +10007,14 @@
       </p:sp>
       <p:sp>
         <p:nvSpPr>
-          <p:cNvPr id="174" name="TextBox 173"/>
-          <p:cNvSpPr txBox="1"/>
-          <p:nvPr/>
-        </p:nvSpPr>
-        <p:spPr>
-          <a:xfrm>
-            <a:off x="9372600" y="4475988"/>
-            <a:ext cx="685800" cy="274320"/>
+          <p:cNvPr id="197" name="TextBox 196"/>
+          <p:cNvSpPr txBox="1"/>
+          <p:nvPr/>
+        </p:nvSpPr>
+        <p:spPr>
+          <a:xfrm>
+            <a:off x="9144000" y="4475988"/>
+            <a:ext cx="548640" cy="274320"/>
           </a:xfrm>
           <a:prstGeom prst="rect">
             <a:avLst/>
@@ -9237,14 +10042,14 @@
       </p:sp>
       <p:sp>
         <p:nvSpPr>
-          <p:cNvPr id="175" name="TextBox 174"/>
-          <p:cNvSpPr txBox="1"/>
-          <p:nvPr/>
-        </p:nvSpPr>
-        <p:spPr>
-          <a:xfrm>
-            <a:off x="10058400" y="4489703"/>
-            <a:ext cx="685800" cy="274320"/>
+          <p:cNvPr id="198" name="TextBox 197"/>
+          <p:cNvSpPr txBox="1"/>
+          <p:nvPr/>
+        </p:nvSpPr>
+        <p:spPr>
+          <a:xfrm>
+            <a:off x="9692640" y="4489703"/>
+            <a:ext cx="548640" cy="274320"/>
           </a:xfrm>
           <a:prstGeom prst="rect">
             <a:avLst/>
@@ -9272,14 +10077,14 @@
       </p:sp>
       <p:sp>
         <p:nvSpPr>
-          <p:cNvPr id="176" name="TextBox 175"/>
-          <p:cNvSpPr txBox="1"/>
-          <p:nvPr/>
-        </p:nvSpPr>
-        <p:spPr>
-          <a:xfrm>
-            <a:off x="10744200" y="4489703"/>
-            <a:ext cx="594360" cy="274320"/>
+          <p:cNvPr id="199" name="TextBox 198"/>
+          <p:cNvSpPr txBox="1"/>
+          <p:nvPr/>
+        </p:nvSpPr>
+        <p:spPr>
+          <a:xfrm>
+            <a:off x="10241280" y="4489703"/>
+            <a:ext cx="548640" cy="274320"/>
           </a:xfrm>
           <a:prstGeom prst="rect">
             <a:avLst/>
@@ -9294,6 +10099,41 @@
           <a:p>
             <a:pPr algn="r"/>
             <a:r>
+              <a:rPr sz="1100" b="0" i="0">
+                <a:solidFill>
+                  <a:srgbClr val="CADCFC"/>
+                </a:solidFill>
+                <a:latin typeface="Arial"/>
+              </a:rPr>
+              <a:t>+1.6</a:t>
+            </a:r>
+          </a:p>
+        </p:txBody>
+      </p:sp>
+      <p:sp>
+        <p:nvSpPr>
+          <p:cNvPr id="200" name="TextBox 199"/>
+          <p:cNvSpPr txBox="1"/>
+          <p:nvPr/>
+        </p:nvSpPr>
+        <p:spPr>
+          <a:xfrm>
+            <a:off x="10789920" y="4489703"/>
+            <a:ext cx="548640" cy="274320"/>
+          </a:xfrm>
+          <a:prstGeom prst="rect">
+            <a:avLst/>
+          </a:prstGeom>
+          <a:noFill/>
+        </p:spPr>
+        <p:txBody>
+          <a:bodyPr wrap="square" lIns="0" rIns="0" tIns="0" bIns="0">
+            <a:spAutoFit/>
+          </a:bodyPr>
+          <a:lstStyle/>
+          <a:p>
+            <a:pPr algn="r"/>
+            <a:r>
               <a:rPr sz="1000" b="0" i="0">
                 <a:solidFill>
                   <a:srgbClr val="CADCFC"/>
@@ -9307,7 +10147,7 @@
       </p:sp>
       <p:sp>
         <p:nvSpPr>
-          <p:cNvPr id="177" name="TextBox 176"/>
+          <p:cNvPr id="201" name="TextBox 200"/>
           <p:cNvSpPr txBox="1"/>
           <p:nvPr/>
         </p:nvSpPr>
@@ -9342,7 +10182,7 @@
       </p:sp>
       <p:sp>
         <p:nvSpPr>
-          <p:cNvPr id="178" name="Oval 177"/>
+          <p:cNvPr id="202" name="Oval 201"/>
           <p:cNvSpPr/>
           <p:nvPr/>
         </p:nvSpPr>
@@ -9386,7 +10226,7 @@
       </p:sp>
       <p:pic>
         <p:nvPicPr>
-          <p:cNvPr id="179" name="Picture 178" descr="virginia.png"/>
+          <p:cNvPr id="203" name="Picture 202" descr="virginia.png"/>
           <p:cNvPicPr>
             <a:picLocks noChangeAspect="1"/>
           </p:cNvPicPr>
@@ -9410,14 +10250,14 @@
       </p:pic>
       <p:sp>
         <p:nvSpPr>
-          <p:cNvPr id="180" name="TextBox 179"/>
-          <p:cNvSpPr txBox="1"/>
-          <p:nvPr/>
-        </p:nvSpPr>
-        <p:spPr>
-          <a:xfrm>
-            <a:off x="7269480" y="4805172"/>
-            <a:ext cx="2103120" cy="274320"/>
+          <p:cNvPr id="204" name="TextBox 203"/>
+          <p:cNvSpPr txBox="1"/>
+          <p:nvPr/>
+        </p:nvSpPr>
+        <p:spPr>
+          <a:xfrm>
+            <a:off x="7269480" y="4814316"/>
+            <a:ext cx="1874519" cy="274320"/>
           </a:xfrm>
           <a:prstGeom prst="rect">
             <a:avLst/>
@@ -9432,7 +10272,7 @@
           <a:p>
             <a:pPr algn="l"/>
             <a:r>
-              <a:rPr sz="1250" b="1" i="0">
+              <a:rPr sz="1200" b="1" i="0">
                 <a:solidFill>
                   <a:srgbClr val="FFFFFF"/>
                 </a:solidFill>
@@ -9445,14 +10285,14 @@
       </p:sp>
       <p:sp>
         <p:nvSpPr>
-          <p:cNvPr id="181" name="TextBox 180"/>
-          <p:cNvSpPr txBox="1"/>
-          <p:nvPr/>
-        </p:nvSpPr>
-        <p:spPr>
-          <a:xfrm>
-            <a:off x="9372600" y="4805172"/>
-            <a:ext cx="685800" cy="274320"/>
+          <p:cNvPr id="205" name="TextBox 204"/>
+          <p:cNvSpPr txBox="1"/>
+          <p:nvPr/>
+        </p:nvSpPr>
+        <p:spPr>
+          <a:xfrm>
+            <a:off x="9144000" y="4805172"/>
+            <a:ext cx="548640" cy="274320"/>
           </a:xfrm>
           <a:prstGeom prst="rect">
             <a:avLst/>
@@ -9480,14 +10320,14 @@
       </p:sp>
       <p:sp>
         <p:nvSpPr>
-          <p:cNvPr id="182" name="TextBox 181"/>
-          <p:cNvSpPr txBox="1"/>
-          <p:nvPr/>
-        </p:nvSpPr>
-        <p:spPr>
-          <a:xfrm>
-            <a:off x="10058400" y="4818888"/>
-            <a:ext cx="685800" cy="274320"/>
+          <p:cNvPr id="206" name="TextBox 205"/>
+          <p:cNvSpPr txBox="1"/>
+          <p:nvPr/>
+        </p:nvSpPr>
+        <p:spPr>
+          <a:xfrm>
+            <a:off x="9692640" y="4818888"/>
+            <a:ext cx="548640" cy="274320"/>
           </a:xfrm>
           <a:prstGeom prst="rect">
             <a:avLst/>
@@ -9515,14 +10355,14 @@
       </p:sp>
       <p:sp>
         <p:nvSpPr>
-          <p:cNvPr id="183" name="TextBox 182"/>
-          <p:cNvSpPr txBox="1"/>
-          <p:nvPr/>
-        </p:nvSpPr>
-        <p:spPr>
-          <a:xfrm>
-            <a:off x="10744200" y="4818888"/>
-            <a:ext cx="594360" cy="274320"/>
+          <p:cNvPr id="207" name="TextBox 206"/>
+          <p:cNvSpPr txBox="1"/>
+          <p:nvPr/>
+        </p:nvSpPr>
+        <p:spPr>
+          <a:xfrm>
+            <a:off x="10241280" y="4818888"/>
+            <a:ext cx="548640" cy="274320"/>
           </a:xfrm>
           <a:prstGeom prst="rect">
             <a:avLst/>
@@ -9537,6 +10377,41 @@
           <a:p>
             <a:pPr algn="r"/>
             <a:r>
+              <a:rPr sz="1100" b="0" i="0">
+                <a:solidFill>
+                  <a:srgbClr val="CADCFC"/>
+                </a:solidFill>
+                <a:latin typeface="Arial"/>
+              </a:rPr>
+              <a:t>-2.1</a:t>
+            </a:r>
+          </a:p>
+        </p:txBody>
+      </p:sp>
+      <p:sp>
+        <p:nvSpPr>
+          <p:cNvPr id="208" name="TextBox 207"/>
+          <p:cNvSpPr txBox="1"/>
+          <p:nvPr/>
+        </p:nvSpPr>
+        <p:spPr>
+          <a:xfrm>
+            <a:off x="10789920" y="4818888"/>
+            <a:ext cx="548640" cy="274320"/>
+          </a:xfrm>
+          <a:prstGeom prst="rect">
+            <a:avLst/>
+          </a:prstGeom>
+          <a:noFill/>
+        </p:spPr>
+        <p:txBody>
+          <a:bodyPr wrap="square" lIns="0" rIns="0" tIns="0" bIns="0">
+            <a:spAutoFit/>
+          </a:bodyPr>
+          <a:lstStyle/>
+          <a:p>
+            <a:pPr algn="r"/>
+            <a:r>
               <a:rPr sz="1000" b="0" i="0">
                 <a:solidFill>
                   <a:srgbClr val="CADCFC"/>
@@ -9550,7 +10425,7 @@
       </p:sp>
       <p:sp>
         <p:nvSpPr>
-          <p:cNvPr id="184" name="Rectangle 183"/>
+          <p:cNvPr id="209" name="Rectangle 208"/>
           <p:cNvSpPr/>
           <p:nvPr/>
         </p:nvSpPr>
@@ -9594,7 +10469,7 @@
       </p:sp>
       <p:sp>
         <p:nvSpPr>
-          <p:cNvPr id="185" name="TextBox 184"/>
+          <p:cNvPr id="210" name="TextBox 209"/>
           <p:cNvSpPr txBox="1"/>
           <p:nvPr/>
         </p:nvSpPr>
@@ -9629,7 +10504,7 @@
       </p:sp>
       <p:sp>
         <p:nvSpPr>
-          <p:cNvPr id="186" name="Oval 185"/>
+          <p:cNvPr id="211" name="Oval 210"/>
           <p:cNvSpPr/>
           <p:nvPr/>
         </p:nvSpPr>
@@ -9673,7 +10548,7 @@
       </p:sp>
       <p:pic>
         <p:nvPicPr>
-          <p:cNvPr id="187" name="Picture 186" descr="smu.png"/>
+          <p:cNvPr id="212" name="Picture 211" descr="smu.png"/>
           <p:cNvPicPr>
             <a:picLocks noChangeAspect="1"/>
           </p:cNvPicPr>
@@ -9697,14 +10572,14 @@
       </p:pic>
       <p:sp>
         <p:nvSpPr>
-          <p:cNvPr id="188" name="TextBox 187"/>
-          <p:cNvSpPr txBox="1"/>
-          <p:nvPr/>
-        </p:nvSpPr>
-        <p:spPr>
-          <a:xfrm>
-            <a:off x="7269480" y="5134356"/>
-            <a:ext cx="2103120" cy="274320"/>
+          <p:cNvPr id="213" name="TextBox 212"/>
+          <p:cNvSpPr txBox="1"/>
+          <p:nvPr/>
+        </p:nvSpPr>
+        <p:spPr>
+          <a:xfrm>
+            <a:off x="7269480" y="5143500"/>
+            <a:ext cx="1874519" cy="274320"/>
           </a:xfrm>
           <a:prstGeom prst="rect">
             <a:avLst/>
@@ -9719,7 +10594,7 @@
           <a:p>
             <a:pPr algn="l"/>
             <a:r>
-              <a:rPr sz="1250" b="1" i="0">
+              <a:rPr sz="1200" b="1" i="0">
                 <a:solidFill>
                   <a:srgbClr val="FFFFFF"/>
                 </a:solidFill>
@@ -9732,14 +10607,14 @@
       </p:sp>
       <p:sp>
         <p:nvSpPr>
-          <p:cNvPr id="189" name="TextBox 188"/>
-          <p:cNvSpPr txBox="1"/>
-          <p:nvPr/>
-        </p:nvSpPr>
-        <p:spPr>
-          <a:xfrm>
-            <a:off x="9372600" y="5134356"/>
-            <a:ext cx="685800" cy="274320"/>
+          <p:cNvPr id="214" name="TextBox 213"/>
+          <p:cNvSpPr txBox="1"/>
+          <p:nvPr/>
+        </p:nvSpPr>
+        <p:spPr>
+          <a:xfrm>
+            <a:off x="9144000" y="5134356"/>
+            <a:ext cx="548640" cy="274320"/>
           </a:xfrm>
           <a:prstGeom prst="rect">
             <a:avLst/>
@@ -9767,14 +10642,14 @@
       </p:sp>
       <p:sp>
         <p:nvSpPr>
-          <p:cNvPr id="190" name="TextBox 189"/>
-          <p:cNvSpPr txBox="1"/>
-          <p:nvPr/>
-        </p:nvSpPr>
-        <p:spPr>
-          <a:xfrm>
-            <a:off x="10058400" y="5148072"/>
-            <a:ext cx="685800" cy="274320"/>
+          <p:cNvPr id="215" name="TextBox 214"/>
+          <p:cNvSpPr txBox="1"/>
+          <p:nvPr/>
+        </p:nvSpPr>
+        <p:spPr>
+          <a:xfrm>
+            <a:off x="9692640" y="5148072"/>
+            <a:ext cx="548640" cy="274320"/>
           </a:xfrm>
           <a:prstGeom prst="rect">
             <a:avLst/>
@@ -9802,14 +10677,14 @@
       </p:sp>
       <p:sp>
         <p:nvSpPr>
-          <p:cNvPr id="191" name="TextBox 190"/>
-          <p:cNvSpPr txBox="1"/>
-          <p:nvPr/>
-        </p:nvSpPr>
-        <p:spPr>
-          <a:xfrm>
-            <a:off x="10744200" y="5148072"/>
-            <a:ext cx="594360" cy="274320"/>
+          <p:cNvPr id="216" name="TextBox 215"/>
+          <p:cNvSpPr txBox="1"/>
+          <p:nvPr/>
+        </p:nvSpPr>
+        <p:spPr>
+          <a:xfrm>
+            <a:off x="10241280" y="5148072"/>
+            <a:ext cx="548640" cy="274320"/>
           </a:xfrm>
           <a:prstGeom prst="rect">
             <a:avLst/>
@@ -9824,6 +10699,41 @@
           <a:p>
             <a:pPr algn="r"/>
             <a:r>
+              <a:rPr sz="1100" b="1" i="0">
+                <a:solidFill>
+                  <a:srgbClr val="F47321"/>
+                </a:solidFill>
+                <a:latin typeface="Arial"/>
+              </a:rPr>
+              <a:t>-10.4</a:t>
+            </a:r>
+          </a:p>
+        </p:txBody>
+      </p:sp>
+      <p:sp>
+        <p:nvSpPr>
+          <p:cNvPr id="217" name="TextBox 216"/>
+          <p:cNvSpPr txBox="1"/>
+          <p:nvPr/>
+        </p:nvSpPr>
+        <p:spPr>
+          <a:xfrm>
+            <a:off x="10789920" y="5148072"/>
+            <a:ext cx="548640" cy="274320"/>
+          </a:xfrm>
+          <a:prstGeom prst="rect">
+            <a:avLst/>
+          </a:prstGeom>
+          <a:noFill/>
+        </p:spPr>
+        <p:txBody>
+          <a:bodyPr wrap="square" lIns="0" rIns="0" tIns="0" bIns="0">
+            <a:spAutoFit/>
+          </a:bodyPr>
+          <a:lstStyle/>
+          <a:p>
+            <a:pPr algn="r"/>
+            <a:r>
               <a:rPr sz="1000" b="0" i="0">
                 <a:solidFill>
                   <a:srgbClr val="CADCFC"/>
@@ -9837,7 +10747,7 @@
       </p:sp>
       <p:sp>
         <p:nvSpPr>
-          <p:cNvPr id="192" name="TextBox 191"/>
+          <p:cNvPr id="218" name="TextBox 217"/>
           <p:cNvSpPr txBox="1"/>
           <p:nvPr/>
         </p:nvSpPr>
@@ -9872,7 +10782,7 @@
       </p:sp>
       <p:sp>
         <p:nvSpPr>
-          <p:cNvPr id="193" name="Oval 192"/>
+          <p:cNvPr id="219" name="Oval 218"/>
           <p:cNvSpPr/>
           <p:nvPr/>
         </p:nvSpPr>
@@ -9916,7 +10826,7 @@
       </p:sp>
       <p:pic>
         <p:nvPicPr>
-          <p:cNvPr id="194" name="Picture 193" descr="southcarolina.png"/>
+          <p:cNvPr id="220" name="Picture 219" descr="southcarolina.png"/>
           <p:cNvPicPr>
             <a:picLocks noChangeAspect="1"/>
           </p:cNvPicPr>
@@ -9940,14 +10850,14 @@
       </p:pic>
       <p:sp>
         <p:nvSpPr>
-          <p:cNvPr id="195" name="TextBox 194"/>
-          <p:cNvSpPr txBox="1"/>
-          <p:nvPr/>
-        </p:nvSpPr>
-        <p:spPr>
-          <a:xfrm>
-            <a:off x="7269480" y="5463540"/>
-            <a:ext cx="2103120" cy="274320"/>
+          <p:cNvPr id="221" name="TextBox 220"/>
+          <p:cNvSpPr txBox="1"/>
+          <p:nvPr/>
+        </p:nvSpPr>
+        <p:spPr>
+          <a:xfrm>
+            <a:off x="7269480" y="5472683"/>
+            <a:ext cx="1874519" cy="274320"/>
           </a:xfrm>
           <a:prstGeom prst="rect">
             <a:avLst/>
@@ -9962,7 +10872,7 @@
           <a:p>
             <a:pPr algn="l"/>
             <a:r>
-              <a:rPr sz="1250" b="1" i="0">
+              <a:rPr sz="1200" b="1" i="0">
                 <a:solidFill>
                   <a:srgbClr val="FFFFFF"/>
                 </a:solidFill>
@@ -9975,14 +10885,14 @@
       </p:sp>
       <p:sp>
         <p:nvSpPr>
-          <p:cNvPr id="196" name="TextBox 195"/>
-          <p:cNvSpPr txBox="1"/>
-          <p:nvPr/>
-        </p:nvSpPr>
-        <p:spPr>
-          <a:xfrm>
-            <a:off x="9372600" y="5463540"/>
-            <a:ext cx="685800" cy="274320"/>
+          <p:cNvPr id="222" name="TextBox 221"/>
+          <p:cNvSpPr txBox="1"/>
+          <p:nvPr/>
+        </p:nvSpPr>
+        <p:spPr>
+          <a:xfrm>
+            <a:off x="9144000" y="5463540"/>
+            <a:ext cx="548640" cy="274320"/>
           </a:xfrm>
           <a:prstGeom prst="rect">
             <a:avLst/>
@@ -10010,14 +10920,14 @@
       </p:sp>
       <p:sp>
         <p:nvSpPr>
-          <p:cNvPr id="197" name="TextBox 196"/>
-          <p:cNvSpPr txBox="1"/>
-          <p:nvPr/>
-        </p:nvSpPr>
-        <p:spPr>
-          <a:xfrm>
-            <a:off x="10058400" y="5477255"/>
-            <a:ext cx="685800" cy="274320"/>
+          <p:cNvPr id="223" name="TextBox 222"/>
+          <p:cNvSpPr txBox="1"/>
+          <p:nvPr/>
+        </p:nvSpPr>
+        <p:spPr>
+          <a:xfrm>
+            <a:off x="9692640" y="5477255"/>
+            <a:ext cx="548640" cy="274320"/>
           </a:xfrm>
           <a:prstGeom prst="rect">
             <a:avLst/>
@@ -10045,14 +10955,14 @@
       </p:sp>
       <p:sp>
         <p:nvSpPr>
-          <p:cNvPr id="198" name="TextBox 197"/>
-          <p:cNvSpPr txBox="1"/>
-          <p:nvPr/>
-        </p:nvSpPr>
-        <p:spPr>
-          <a:xfrm>
-            <a:off x="10744200" y="5477255"/>
-            <a:ext cx="594360" cy="274320"/>
+          <p:cNvPr id="224" name="TextBox 223"/>
+          <p:cNvSpPr txBox="1"/>
+          <p:nvPr/>
+        </p:nvSpPr>
+        <p:spPr>
+          <a:xfrm>
+            <a:off x="10241280" y="5477255"/>
+            <a:ext cx="548640" cy="274320"/>
           </a:xfrm>
           <a:prstGeom prst="rect">
             <a:avLst/>
@@ -10067,6 +10977,41 @@
           <a:p>
             <a:pPr algn="r"/>
             <a:r>
+              <a:rPr sz="1100" b="0" i="0">
+                <a:solidFill>
+                  <a:srgbClr val="CADCFC"/>
+                </a:solidFill>
+                <a:latin typeface="Arial"/>
+              </a:rPr>
+              <a:t>+0.7</a:t>
+            </a:r>
+          </a:p>
+        </p:txBody>
+      </p:sp>
+      <p:sp>
+        <p:nvSpPr>
+          <p:cNvPr id="225" name="TextBox 224"/>
+          <p:cNvSpPr txBox="1"/>
+          <p:nvPr/>
+        </p:nvSpPr>
+        <p:spPr>
+          <a:xfrm>
+            <a:off x="10789920" y="5477255"/>
+            <a:ext cx="548640" cy="274320"/>
+          </a:xfrm>
+          <a:prstGeom prst="rect">
+            <a:avLst/>
+          </a:prstGeom>
+          <a:noFill/>
+        </p:spPr>
+        <p:txBody>
+          <a:bodyPr wrap="square" lIns="0" rIns="0" tIns="0" bIns="0">
+            <a:spAutoFit/>
+          </a:bodyPr>
+          <a:lstStyle/>
+          <a:p>
+            <a:pPr algn="r"/>
+            <a:r>
               <a:rPr sz="1000" b="0" i="0">
                 <a:solidFill>
                   <a:srgbClr val="CADCFC"/>
@@ -10080,7 +11025,7 @@
       </p:sp>
       <p:sp>
         <p:nvSpPr>
-          <p:cNvPr id="199" name="Rounded Rectangle 198"/>
+          <p:cNvPr id="226" name="Rounded Rectangle 225"/>
           <p:cNvSpPr/>
           <p:nvPr/>
         </p:nvSpPr>
@@ -10124,7 +11069,7 @@
       </p:sp>
       <p:sp>
         <p:nvSpPr>
-          <p:cNvPr id="200" name="TextBox 199"/>
+          <p:cNvPr id="227" name="TextBox 226"/>
           <p:cNvSpPr txBox="1"/>
           <p:nvPr/>
         </p:nvSpPr>
@@ -10159,7 +11104,7 @@
       </p:sp>
       <p:sp>
         <p:nvSpPr>
-          <p:cNvPr id="201" name="TextBox 200"/>
+          <p:cNvPr id="228" name="TextBox 227"/>
           <p:cNvSpPr txBox="1"/>
           <p:nvPr/>
         </p:nvSpPr>
@@ -31164,7 +32109,7 @@
                 </a:solidFill>
                 <a:latin typeface="Arial"/>
               </a:rPr>
-              <a:t>Calls frozen at recording · closing line = last pre-kick pull · off by = miss vs the final margin</a:t>
+              <a:t>Calls frozen at recording · closing line = last pre-kick pull · off by = miss vs the final margin · deserved = the efficiency margin</a:t>
             </a:r>
           </a:p>
         </p:txBody>
@@ -31361,7 +32306,7 @@
                 </a:solidFill>
                 <a:latin typeface="Arial"/>
               </a:rPr>
-              <a:t>our line Texas –3.5 · closing Texas –1.5</a:t>
+              <a:t>our line Texas –3.5 · closing Texas –1.5 · deserved TEX +5.6</a:t>
             </a:r>
           </a:p>
         </p:txBody>
@@ -31593,7 +32538,7 @@
                 </a:solidFill>
                 <a:latin typeface="Arial"/>
               </a:rPr>
-              <a:t>our line Oklahoma –2 · closing Oklahoma –5.5</a:t>
+              <a:t>our line Oklahoma –2 · closing Oklahoma –5.5 · deserved MICH +0.8</a:t>
             </a:r>
           </a:p>
         </p:txBody>
@@ -31825,7 +32770,7 @@
                 </a:solidFill>
                 <a:latin typeface="Arial"/>
               </a:rPr>
-              <a:t>our line Texas A&amp;M –16.5 · closing Texas A&amp;M –14.5</a:t>
+              <a:t>our line Texas A&amp;M –16.5 · closing Texas A&amp;M –14.5 · deserved TAMU +15.1</a:t>
             </a:r>
           </a:p>
         </p:txBody>
@@ -32057,7 +33002,7 @@
                 </a:solidFill>
                 <a:latin typeface="Arial"/>
               </a:rPr>
-              <a:t>our line BYU –8.5 · closing BYU –7.5</a:t>
+              <a:t>our line BYU –8.5 · closing BYU –7.5 · deserved BYU +16.4</a:t>
             </a:r>
           </a:p>
         </p:txBody>
@@ -32289,7 +33234,7 @@
                 </a:solidFill>
                 <a:latin typeface="Arial"/>
               </a:rPr>
-              <a:t>our line Alabama –13 · closing Alabama –10</a:t>
+              <a:t>our line Alabama –13 · closing Alabama –10 · deserved BAMA +22.4</a:t>
             </a:r>
           </a:p>
         </p:txBody>
@@ -32403,7 +33348,7 @@
                 </a:solidFill>
                 <a:latin typeface="Arial"/>
               </a:rPr>
-              <a:t>Machine 40.5 · market 48.0 · machine closer in 4, market 1, 0 tie</a:t>
+              <a:t>Machine 40.5 · market 48.0 · machine closer in 4, market 1, 0 tie · vs the deserved margins: machine 23.6</a:t>
             </a:r>
           </a:p>
         </p:txBody>

</xml_diff>

<commit_message>
Deck: line movement is internal (LINE MOVE readout + footer strip removed from the game slides; ledger and notes keep it); notes: Houston key says six-point Vegas move, machine line unmoved; Ep4 deck rebuilt and pushed
Co-Authored-By: Claude Fable 5.1 <noreply@anthropic.com>
</commit_message>
<xml_diff>
--- a/decks/2026_Week3_Episode4.pptx
+++ b/decks/2026_Week3_Episode4.pptx
@@ -12768,76 +12768,6 @@
           </a:p>
         </p:txBody>
       </p:sp>
-      <p:sp>
-        <p:nvSpPr>
-          <p:cNvPr id="32" name="TextBox 31"/>
-          <p:cNvSpPr txBox="1"/>
-          <p:nvPr/>
-        </p:nvSpPr>
-        <p:spPr>
-          <a:xfrm>
-            <a:off x="8046720" y="5440680"/>
-            <a:ext cx="3017520" cy="274320"/>
-          </a:xfrm>
-          <a:prstGeom prst="rect">
-            <a:avLst/>
-          </a:prstGeom>
-          <a:noFill/>
-        </p:spPr>
-        <p:txBody>
-          <a:bodyPr wrap="square" lIns="0" rIns="0" tIns="0" bIns="0">
-            <a:spAutoFit/>
-          </a:bodyPr>
-          <a:lstStyle/>
-          <a:p>
-            <a:pPr algn="l"/>
-            <a:r>
-              <a:rPr sz="950" b="1" i="0">
-                <a:solidFill>
-                  <a:srgbClr val="F47321"/>
-                </a:solidFill>
-                <a:latin typeface="Arial"/>
-              </a:rPr>
-              <a:t>LINE MOVE  –7.5 → –3.5 · CLV +4</a:t>
-            </a:r>
-          </a:p>
-        </p:txBody>
-      </p:sp>
-      <p:sp>
-        <p:nvSpPr>
-          <p:cNvPr id="33" name="TextBox 32"/>
-          <p:cNvSpPr txBox="1"/>
-          <p:nvPr/>
-        </p:nvSpPr>
-        <p:spPr>
-          <a:xfrm>
-            <a:off x="822960" y="6236208"/>
-            <a:ext cx="10515600" cy="274320"/>
-          </a:xfrm>
-          <a:prstGeom prst="rect">
-            <a:avLst/>
-          </a:prstGeom>
-          <a:noFill/>
-        </p:spPr>
-        <p:txBody>
-          <a:bodyPr wrap="square" lIns="0" rIns="0" tIns="0" bIns="0">
-            <a:spAutoFit/>
-          </a:bodyPr>
-          <a:lstStyle/>
-          <a:p>
-            <a:pPr algn="l"/>
-            <a:r>
-              <a:rPr sz="1050" b="0" i="0">
-                <a:solidFill>
-                  <a:srgbClr val="5C6B7E"/>
-                </a:solidFill>
-                <a:latin typeface="Arial"/>
-              </a:rPr>
-              <a:t>Line movement: first-seen –7.5 (Sep 11) → now –3.5 · CLV +4</a:t>
-            </a:r>
-          </a:p>
-        </p:txBody>
-      </p:sp>
     </p:spTree>
   </p:cSld>
   <p:clrMapOvr>
@@ -15414,76 +15344,6 @@
           </a:p>
         </p:txBody>
       </p:sp>
-      <p:sp>
-        <p:nvSpPr>
-          <p:cNvPr id="32" name="TextBox 31"/>
-          <p:cNvSpPr txBox="1"/>
-          <p:nvPr/>
-        </p:nvSpPr>
-        <p:spPr>
-          <a:xfrm>
-            <a:off x="8046720" y="5440680"/>
-            <a:ext cx="3017520" cy="274320"/>
-          </a:xfrm>
-          <a:prstGeom prst="rect">
-            <a:avLst/>
-          </a:prstGeom>
-          <a:noFill/>
-        </p:spPr>
-        <p:txBody>
-          <a:bodyPr wrap="square" lIns="0" rIns="0" tIns="0" bIns="0">
-            <a:spAutoFit/>
-          </a:bodyPr>
-          <a:lstStyle/>
-          <a:p>
-            <a:pPr algn="l"/>
-            <a:r>
-              <a:rPr sz="950" b="1" i="0">
-                <a:solidFill>
-                  <a:srgbClr val="F47321"/>
-                </a:solidFill>
-                <a:latin typeface="Arial"/>
-              </a:rPr>
-              <a:t>LINE MOVE  –1.5 → +2.5 · CLV +4</a:t>
-            </a:r>
-          </a:p>
-        </p:txBody>
-      </p:sp>
-      <p:sp>
-        <p:nvSpPr>
-          <p:cNvPr id="33" name="TextBox 32"/>
-          <p:cNvSpPr txBox="1"/>
-          <p:nvPr/>
-        </p:nvSpPr>
-        <p:spPr>
-          <a:xfrm>
-            <a:off x="822960" y="6236208"/>
-            <a:ext cx="10515600" cy="274320"/>
-          </a:xfrm>
-          <a:prstGeom prst="rect">
-            <a:avLst/>
-          </a:prstGeom>
-          <a:noFill/>
-        </p:spPr>
-        <p:txBody>
-          <a:bodyPr wrap="square" lIns="0" rIns="0" tIns="0" bIns="0">
-            <a:spAutoFit/>
-          </a:bodyPr>
-          <a:lstStyle/>
-          <a:p>
-            <a:pPr algn="l"/>
-            <a:r>
-              <a:rPr sz="1050" b="0" i="0">
-                <a:solidFill>
-                  <a:srgbClr val="5C6B7E"/>
-                </a:solidFill>
-                <a:latin typeface="Arial"/>
-              </a:rPr>
-              <a:t>Line movement: first-seen –1.5 (Aug 23) → now +2.5 · CLV +4</a:t>
-            </a:r>
-          </a:p>
-        </p:txBody>
-      </p:sp>
     </p:spTree>
   </p:cSld>
   <p:clrMapOvr>
@@ -18060,76 +17920,6 @@
           </a:p>
         </p:txBody>
       </p:sp>
-      <p:sp>
-        <p:nvSpPr>
-          <p:cNvPr id="32" name="TextBox 31"/>
-          <p:cNvSpPr txBox="1"/>
-          <p:nvPr/>
-        </p:nvSpPr>
-        <p:spPr>
-          <a:xfrm>
-            <a:off x="8046720" y="5440680"/>
-            <a:ext cx="3017520" cy="274320"/>
-          </a:xfrm>
-          <a:prstGeom prst="rect">
-            <a:avLst/>
-          </a:prstGeom>
-          <a:noFill/>
-        </p:spPr>
-        <p:txBody>
-          <a:bodyPr wrap="square" lIns="0" rIns="0" tIns="0" bIns="0">
-            <a:spAutoFit/>
-          </a:bodyPr>
-          <a:lstStyle/>
-          <a:p>
-            <a:pPr algn="l"/>
-            <a:r>
-              <a:rPr sz="950" b="1" i="0">
-                <a:solidFill>
-                  <a:srgbClr val="F47321"/>
-                </a:solidFill>
-                <a:latin typeface="Arial"/>
-              </a:rPr>
-              <a:t>LINE MOVE  –1.5 → +3 · CLV +4.5</a:t>
-            </a:r>
-          </a:p>
-        </p:txBody>
-      </p:sp>
-      <p:sp>
-        <p:nvSpPr>
-          <p:cNvPr id="33" name="TextBox 32"/>
-          <p:cNvSpPr txBox="1"/>
-          <p:nvPr/>
-        </p:nvSpPr>
-        <p:spPr>
-          <a:xfrm>
-            <a:off x="822960" y="6236208"/>
-            <a:ext cx="10515600" cy="274320"/>
-          </a:xfrm>
-          <a:prstGeom prst="rect">
-            <a:avLst/>
-          </a:prstGeom>
-          <a:noFill/>
-        </p:spPr>
-        <p:txBody>
-          <a:bodyPr wrap="square" lIns="0" rIns="0" tIns="0" bIns="0">
-            <a:spAutoFit/>
-          </a:bodyPr>
-          <a:lstStyle/>
-          <a:p>
-            <a:pPr algn="l"/>
-            <a:r>
-              <a:rPr sz="1050" b="0" i="0">
-                <a:solidFill>
-                  <a:srgbClr val="5C6B7E"/>
-                </a:solidFill>
-                <a:latin typeface="Arial"/>
-              </a:rPr>
-              <a:t>Line movement: first-seen –1.5 (Aug 23) → now +3 · CLV +4.5</a:t>
-            </a:r>
-          </a:p>
-        </p:txBody>
-      </p:sp>
     </p:spTree>
   </p:cSld>
   <p:clrMapOvr>
@@ -33569,76 +33359,6 @@
           </a:p>
         </p:txBody>
       </p:sp>
-      <p:sp>
-        <p:nvSpPr>
-          <p:cNvPr id="32" name="TextBox 31"/>
-          <p:cNvSpPr txBox="1"/>
-          <p:nvPr/>
-        </p:nvSpPr>
-        <p:spPr>
-          <a:xfrm>
-            <a:off x="8046720" y="5440680"/>
-            <a:ext cx="3017520" cy="274320"/>
-          </a:xfrm>
-          <a:prstGeom prst="rect">
-            <a:avLst/>
-          </a:prstGeom>
-          <a:noFill/>
-        </p:spPr>
-        <p:txBody>
-          <a:bodyPr wrap="square" lIns="0" rIns="0" tIns="0" bIns="0">
-            <a:spAutoFit/>
-          </a:bodyPr>
-          <a:lstStyle/>
-          <a:p>
-            <a:pPr algn="l"/>
-            <a:r>
-              <a:rPr sz="950" b="1" i="0">
-                <a:solidFill>
-                  <a:srgbClr val="F47321"/>
-                </a:solidFill>
-                <a:latin typeface="Arial"/>
-              </a:rPr>
-              <a:t>LINE MOVE  –13.5 → –7.5 · CLV +6</a:t>
-            </a:r>
-          </a:p>
-        </p:txBody>
-      </p:sp>
-      <p:sp>
-        <p:nvSpPr>
-          <p:cNvPr id="33" name="TextBox 32"/>
-          <p:cNvSpPr txBox="1"/>
-          <p:nvPr/>
-        </p:nvSpPr>
-        <p:spPr>
-          <a:xfrm>
-            <a:off x="822960" y="6236208"/>
-            <a:ext cx="10515600" cy="274320"/>
-          </a:xfrm>
-          <a:prstGeom prst="rect">
-            <a:avLst/>
-          </a:prstGeom>
-          <a:noFill/>
-        </p:spPr>
-        <p:txBody>
-          <a:bodyPr wrap="square" lIns="0" rIns="0" tIns="0" bIns="0">
-            <a:spAutoFit/>
-          </a:bodyPr>
-          <a:lstStyle/>
-          <a:p>
-            <a:pPr algn="l"/>
-            <a:r>
-              <a:rPr sz="1050" b="0" i="0">
-                <a:solidFill>
-                  <a:srgbClr val="5C6B7E"/>
-                </a:solidFill>
-                <a:latin typeface="Arial"/>
-              </a:rPr>
-              <a:t>Line movement: first-seen –13.5 (Aug 23) → now –7.5 · CLV +6</a:t>
-            </a:r>
-          </a:p>
-        </p:txBody>
-      </p:sp>
     </p:spTree>
   </p:cSld>
   <p:clrMapOvr>
@@ -36211,76 +35931,6 @@
                 <a:latin typeface="Arial"/>
               </a:rPr>
               <a:t>win probability (machine)</a:t>
-            </a:r>
-          </a:p>
-        </p:txBody>
-      </p:sp>
-      <p:sp>
-        <p:nvSpPr>
-          <p:cNvPr id="32" name="TextBox 31"/>
-          <p:cNvSpPr txBox="1"/>
-          <p:nvPr/>
-        </p:nvSpPr>
-        <p:spPr>
-          <a:xfrm>
-            <a:off x="8046720" y="5440680"/>
-            <a:ext cx="3017520" cy="274320"/>
-          </a:xfrm>
-          <a:prstGeom prst="rect">
-            <a:avLst/>
-          </a:prstGeom>
-          <a:noFill/>
-        </p:spPr>
-        <p:txBody>
-          <a:bodyPr wrap="square" lIns="0" rIns="0" tIns="0" bIns="0">
-            <a:spAutoFit/>
-          </a:bodyPr>
-          <a:lstStyle/>
-          <a:p>
-            <a:pPr algn="l"/>
-            <a:r>
-              <a:rPr sz="950" b="1" i="0">
-                <a:solidFill>
-                  <a:srgbClr val="F47321"/>
-                </a:solidFill>
-                <a:latin typeface="Arial"/>
-              </a:rPr>
-              <a:t>LINE MOVE  –1.5 → –1.5</a:t>
-            </a:r>
-          </a:p>
-        </p:txBody>
-      </p:sp>
-      <p:sp>
-        <p:nvSpPr>
-          <p:cNvPr id="33" name="TextBox 32"/>
-          <p:cNvSpPr txBox="1"/>
-          <p:nvPr/>
-        </p:nvSpPr>
-        <p:spPr>
-          <a:xfrm>
-            <a:off x="822960" y="6236208"/>
-            <a:ext cx="10515600" cy="274320"/>
-          </a:xfrm>
-          <a:prstGeom prst="rect">
-            <a:avLst/>
-          </a:prstGeom>
-          <a:noFill/>
-        </p:spPr>
-        <p:txBody>
-          <a:bodyPr wrap="square" lIns="0" rIns="0" tIns="0" bIns="0">
-            <a:spAutoFit/>
-          </a:bodyPr>
-          <a:lstStyle/>
-          <a:p>
-            <a:pPr algn="l"/>
-            <a:r>
-              <a:rPr sz="1050" b="0" i="0">
-                <a:solidFill>
-                  <a:srgbClr val="5C6B7E"/>
-                </a:solidFill>
-                <a:latin typeface="Arial"/>
-              </a:rPr>
-              <a:t>Line movement: first-seen –1.5 (Aug 23) → now –1.5 · CLV +0</a:t>
             </a:r>
           </a:p>
         </p:txBody>

</xml_diff>

<commit_message>
Game talk, not bettor talk: Win the trenches explained as line play; four WHY IT MATTERS bullets (SMU-LOU, MSST-SC, FLA-AUB, LSU-Ole Miss) swapped from totals/line-move/home-dog framing to matchup framing on the slides and in the notes (betting context kept as internal asides); Ep4 deck rebuilt and pushed
Co-Authored-By: Claude Fable 5.1 <noreply@anthropic.com>
</commit_message>
<xml_diff>
--- a/decks/2026_Week3_Episode4.pptx
+++ b/decks/2026_Week3_Episode4.pptx
@@ -12167,7 +12167,7 @@
                 </a:solidFill>
                 <a:latin typeface="Arial"/>
               </a:rPr>
-              <a:t>Four points to State in 48 hours</a:t>
+              <a:t>Arnett's defense, back in Starkville</a:t>
             </a:r>
           </a:p>
         </p:txBody>
@@ -14585,7 +14585,7 @@
                 </a:solidFill>
                 <a:latin typeface="Arial"/>
               </a:rPr>
-              <a:t>Machine takes the home dog</a:t>
+              <a:t>Auburn's rebuilt lines vs Florida's front</a:t>
             </a:r>
           </a:p>
         </p:txBody>
@@ -17319,7 +17319,7 @@
                 </a:solidFill>
                 <a:latin typeface="Arial"/>
               </a:rPr>
-              <a:t>Monster Under: 58.5</a:t>
+              <a:t>55–49 or 24–19</a:t>
             </a:r>
           </a:p>
         </p:txBody>
@@ -35334,7 +35334,7 @@
                 </a:solidFill>
                 <a:latin typeface="Arial"/>
               </a:rPr>
-              <a:t>Monster Under: 59.5</a:t>
+              <a:t>Both offenses score fast</a:t>
             </a:r>
           </a:p>
         </p:txBody>

</xml_diff>

<commit_message>
Heisman slide rows carry box-score lines (comp-att, yards, TD, INT) instead of model terms; notes get an editable Lucas's Top 25 template prefilled with the machine's order; Ep4 and merged decks rebuilt and pushed
Co-Authored-By: Claude Fable 5.1 <noreply@anthropic.com>
</commit_message>
<xml_diff>
--- a/decks/2026_Week3_Episode4.pptx
+++ b/decks/2026_Week3_Episode4.pptx
@@ -26693,7 +26693,7 @@
                 </a:solidFill>
                 <a:latin typeface="Arial"/>
               </a:rPr>
-              <a:t>41-of-45, 653 yards, 8 TD through two · machine and market agree</a:t>
+              <a:t>41-of-45, 653 yards, 8 TD, 0 INT through two</a:t>
             </a:r>
           </a:p>
         </p:txBody>
@@ -27146,7 +27146,7 @@
                 </a:solidFill>
                 <a:latin typeface="Arial"/>
               </a:rPr>
-              <a:t>1.42 per play on 29 plays · Indiana's 79% P(10+) · market has him 8th</a:t>
+              <a:t>19-of-27, 376 yards, 8 TD, 0 INT through two</a:t>
             </a:r>
           </a:p>
         </p:txBody>
@@ -27643,7 +27643,7 @@
                 </a:solidFill>
                 <a:latin typeface="Arial"/>
               </a:rPr>
-              <a:t>253 and four scores vs Rice · Notre Dame's 86% carries him</a:t>
+              <a:t>35-of-49, 492 yards, 6 TD, 0 INT · 253 and 4 TD vs Rice</a:t>
             </a:r>
           </a:p>
         </p:txBody>
@@ -28096,7 +28096,7 @@
                 </a:solidFill>
                 <a:latin typeface="Arial"/>
               </a:rPr>
-              <a:t>The 2025 prior keeps him top 4 · 278 in the loss at Texas</a:t>
+              <a:t>38-of-57, 598 yards, 4 TD, 1 INT · 278 in the loss at Texas</a:t>
             </a:r>
           </a:p>
         </p:txBody>
@@ -28593,7 +28593,7 @@
                 </a:solidFill>
                 <a:latin typeface="Arial"/>
               </a:rPr>
-              <a:t>Best blended line on the board (0.567) · USC's 16% P(10+) is the drag</a:t>
+              <a:t>67-of-83, 896 yards, 10 TD, 1 INT through three</a:t>
             </a:r>
           </a:p>
         </p:txBody>

</xml_diff>

<commit_message>
Pre-record pull (Tue 9/15 6:18 PM MT): South Carolina -4, Monster Under line 59.5 (State-SC 58.5 out, LSU-Ole Miss 59.5 in), Houston total 53, superdog MLs +2200; deck honesty text + notes + appendix synced; Ep4 and merged decks pushed; Tuesday weekly refresh outputs (workbook, rosters, ledger) committed
Co-Authored-By: Claude Fable 5.1 <noreply@anthropic.com>
</commit_message>
<xml_diff>
--- a/decks/2026_Week3_Episode4.pptx
+++ b/decks/2026_Week3_Episode4.pptx
@@ -12246,7 +12246,7 @@
                 </a:solidFill>
                 <a:latin typeface="Arial"/>
               </a:rPr>
-              <a:t>1.4 to South Carolina — no play · Monster Under 59.5</a:t>
+              <a:t>0.9 to South Carolina — no play</a:t>
             </a:r>
           </a:p>
         </p:txBody>
@@ -12465,7 +12465,7 @@
                 </a:solidFill>
                 <a:latin typeface="Arial"/>
               </a:rPr>
-              <a:t>–3.5 / –3.5</a:t>
+              <a:t>–4 / –3.5</a:t>
             </a:r>
           </a:p>
         </p:txBody>
@@ -12500,7 +12500,7 @@
                 </a:solidFill>
                 <a:latin typeface="Arial"/>
               </a:rPr>
-              <a:t>market (DK / Bovada) · DK South Carolina -162 / Mississippi State +136 · Bov South Carolina -165 / Mississippi State +140</a:t>
+              <a:t>market (DK / Bovada) · DK South Carolina -180 / Mississippi State +150 · Bov South Carolina -165 / Mississippi State +140</a:t>
             </a:r>
           </a:p>
         </p:txBody>
@@ -17398,7 +17398,7 @@
                 </a:solidFill>
                 <a:latin typeface="Arial"/>
               </a:rPr>
-              <a:t>2.2 to LSU — quibble · Monster Under 58.5</a:t>
+              <a:t>2.2 to LSU — quibble · Monster Under 59.5</a:t>
             </a:r>
           </a:p>
         </p:txBody>
@@ -25276,7 +25276,7 @@
                 </a:solidFill>
                 <a:latin typeface="Arial"/>
               </a:rPr>
-              <a:t>market –3.5</a:t>
+              <a:t>market –4</a:t>
             </a:r>
           </a:p>
         </p:txBody>
@@ -25960,7 +25960,7 @@
                 </a:solidFill>
                 <a:latin typeface="Arial"/>
               </a:rPr>
-              <a:t>Sacramento State +27.5 vs North Dakota State · ML +2500</a:t>
+              <a:t>Sacramento State +27.5 vs North Dakota State · ML +2200</a:t>
             </a:r>
           </a:p>
         </p:txBody>
@@ -26030,7 +26030,7 @@
                 </a:solidFill>
                 <a:latin typeface="Arial"/>
               </a:rPr>
-              <a:t>Utah State +28.5 at #17 Utah · ML +2000</a:t>
+              <a:t>Utah State +28.5 at #17 Utah · ML +2200</a:t>
             </a:r>
           </a:p>
         </p:txBody>
@@ -29828,7 +29828,7 @@
                 </a:solidFill>
                 <a:latin typeface="Arial"/>
               </a:rPr>
-              <a:t>Louisville –1   ·   –1.5 / –1</a:t>
+              <a:t>Louisville –1   ·   –1.5 / –1.5</a:t>
             </a:r>
           </a:p>
         </p:txBody>
@@ -30148,7 +30148,7 @@
                 </a:solidFill>
                 <a:latin typeface="Arial"/>
               </a:rPr>
-              <a:t>South Carolina –5   ·   –3.5 / –3.5</a:t>
+              <a:t>South Carolina –5   ·   –4 / –3.5</a:t>
             </a:r>
           </a:p>
         </p:txBody>
@@ -30858,7 +30858,7 @@
                 </a:solidFill>
                 <a:latin typeface="Arial"/>
               </a:rPr>
-              <a:t>Machine = our in-season rating + 2.5 home field · lines as of Sep 14</a:t>
+              <a:t>Machine = our in-season rating + 2.5 home field · lines as of Sep 15</a:t>
             </a:r>
           </a:p>
         </p:txBody>
@@ -35632,7 +35632,7 @@
                 </a:solidFill>
                 <a:latin typeface="Arial"/>
               </a:rPr>
-              <a:t>–1.5 / –1</a:t>
+              <a:t>–1.5 / –1.5</a:t>
             </a:r>
           </a:p>
         </p:txBody>

</xml_diff>

<commit_message>
Deck: score-bug fonts shrink for long team names (no overlap on Mississippi State-South Carolina)
Co-Authored-By: Claude Fable 5.1 <noreply@anthropic.com>
</commit_message>
<xml_diff>
--- a/decks/2026_Week3_Episode4.pptx
+++ b/decks/2026_Week3_Episode4.pptx
@@ -12354,7 +12354,7 @@
           <a:p>
             <a:pPr algn="l"/>
             <a:r>
-              <a:rPr sz="2800" b="1" i="0">
+              <a:rPr sz="2100" b="1" i="0">
                 <a:solidFill>
                   <a:srgbClr val="FFFFFF"/>
                 </a:solidFill>
@@ -12389,7 +12389,7 @@
           <a:p>
             <a:pPr algn="l"/>
             <a:r>
-              <a:rPr sz="1200" b="1" i="0">
+              <a:rPr sz="950" b="1" i="0">
                 <a:solidFill>
                   <a:srgbClr val="FFFFFF"/>
                 </a:solidFill>
@@ -12529,7 +12529,7 @@
           <a:p>
             <a:pPr algn="l"/>
             <a:r>
-              <a:rPr sz="1300" b="1" i="0">
+              <a:rPr sz="1050" b="1" i="0">
                 <a:solidFill>
                   <a:srgbClr val="F47321"/>
                 </a:solidFill>

</xml_diff>

<commit_message>
Deck template (Corey's feedback): one WHY IT MATTERS point per number slide, three keys per team slide, one fact per COACH/QB/ROSTER cell (SLIDE_POINTS / SLIDE_KEYS / one_fact); notes keep all four of each as the reserve
Co-Authored-By: Claude Fable 5.1 <noreply@anthropic.com>
</commit_message>
<xml_diff>
--- a/decks/2026_Week3_Episode4.pptx
+++ b/decks/2026_Week3_Episode4.pptx
@@ -10421,7 +10421,7 @@
                 </a:solidFill>
                 <a:latin typeface="Arial"/>
               </a:rPr>
-              <a:t>Lashlee, year 5 · coordinator troikas</a:t>
+              <a:t>Lashlee, year 5</a:t>
             </a:r>
           </a:p>
         </p:txBody>
@@ -10561,7 +10561,7 @@
                 </a:solidFill>
                 <a:latin typeface="Arial"/>
               </a:rPr>
-              <a:t>57% back · 15 portal adds</a:t>
+              <a:t>57% back</a:t>
             </a:r>
           </a:p>
         </p:txBody>
@@ -10574,7 +10574,7 @@
         </p:nvSpPr>
         <p:spPr>
           <a:xfrm>
-            <a:off x="914400" y="3291840"/>
+            <a:off x="914400" y="3383280"/>
             <a:ext cx="137160" cy="137160"/>
           </a:xfrm>
           <a:prstGeom prst="ellipse">
@@ -10618,7 +10618,7 @@
         </p:nvSpPr>
         <p:spPr>
           <a:xfrm>
-            <a:off x="1325880" y="3108960"/>
+            <a:off x="1325880" y="3200400"/>
             <a:ext cx="9601200" cy="731520"/>
           </a:xfrm>
           <a:prstGeom prst="rect">
@@ -10653,7 +10653,7 @@
         </p:nvSpPr>
         <p:spPr>
           <a:xfrm>
-            <a:off x="914400" y="4133088"/>
+            <a:off x="914400" y="4389120"/>
             <a:ext cx="137160" cy="137160"/>
           </a:xfrm>
           <a:prstGeom prst="ellipse">
@@ -10697,7 +10697,7 @@
         </p:nvSpPr>
         <p:spPr>
           <a:xfrm>
-            <a:off x="1325880" y="3950208"/>
+            <a:off x="1325880" y="4206240"/>
             <a:ext cx="9601200" cy="731520"/>
           </a:xfrm>
           <a:prstGeom prst="rect">
@@ -10732,7 +10732,7 @@
         </p:nvSpPr>
         <p:spPr>
           <a:xfrm>
-            <a:off x="914400" y="4974336"/>
+            <a:off x="914400" y="5394959"/>
             <a:ext cx="137160" cy="137160"/>
           </a:xfrm>
           <a:prstGeom prst="ellipse">
@@ -10776,7 +10776,7 @@
         </p:nvSpPr>
         <p:spPr>
           <a:xfrm>
-            <a:off x="1325880" y="4791456"/>
+            <a:off x="1325880" y="5212079"/>
             <a:ext cx="9601200" cy="731520"/>
           </a:xfrm>
           <a:prstGeom prst="rect">
@@ -10805,86 +10805,7 @@
       </p:sp>
       <p:sp>
         <p:nvSpPr>
-          <p:cNvPr id="18" name="Oval 17"/>
-          <p:cNvSpPr/>
-          <p:nvPr/>
-        </p:nvSpPr>
-        <p:spPr>
-          <a:xfrm>
-            <a:off x="914400" y="5815584"/>
-            <a:ext cx="137160" cy="137160"/>
-          </a:xfrm>
-          <a:prstGeom prst="ellipse">
-            <a:avLst/>
-          </a:prstGeom>
-          <a:solidFill>
-            <a:srgbClr val="F47321"/>
-          </a:solidFill>
-          <a:ln>
-            <a:noFill/>
-          </a:ln>
-          <a:effectLst/>
-        </p:spPr>
-        <p:style>
-          <a:lnRef idx="1">
-            <a:schemeClr val="accent1"/>
-          </a:lnRef>
-          <a:fillRef idx="3">
-            <a:schemeClr val="accent1"/>
-          </a:fillRef>
-          <a:effectRef idx="2">
-            <a:schemeClr val="accent1"/>
-          </a:effectRef>
-          <a:fontRef idx="minor">
-            <a:schemeClr val="lt1"/>
-          </a:fontRef>
-        </p:style>
-        <p:txBody>
-          <a:bodyPr rtlCol="0" anchor="ctr"/>
-          <a:lstStyle/>
-          <a:p>
-            <a:pPr algn="ctr"/>
-          </a:p>
-        </p:txBody>
-      </p:sp>
-      <p:sp>
-        <p:nvSpPr>
-          <p:cNvPr id="19" name="TextBox 18"/>
-          <p:cNvSpPr txBox="1"/>
-          <p:nvPr/>
-        </p:nvSpPr>
-        <p:spPr>
-          <a:xfrm>
-            <a:off x="1325880" y="5632704"/>
-            <a:ext cx="9601200" cy="731520"/>
-          </a:xfrm>
-          <a:prstGeom prst="rect">
-            <a:avLst/>
-          </a:prstGeom>
-          <a:noFill/>
-        </p:spPr>
-        <p:txBody>
-          <a:bodyPr wrap="square" lIns="0" rIns="0" tIns="0" bIns="0">
-            <a:spAutoFit/>
-          </a:bodyPr>
-          <a:lstStyle/>
-          <a:p>
-            <a:pPr algn="l"/>
-            <a:r>
-              <a:rPr sz="2400" b="1" i="0">
-                <a:solidFill>
-                  <a:srgbClr val="16273D"/>
-                </a:solidFill>
-                <a:latin typeface="Arial"/>
-              </a:rPr>
-              <a:t>Explosives, not long drives</a:t>
-            </a:r>
-          </a:p>
-        </p:txBody>
-      </p:sp>
-      <p:sp>
-        <p:nvSpPr>
-          <p:cNvPr id="20" name="TextBox 19"/>
+          <p:cNvPr id="18" name="TextBox 17"/>
           <p:cNvSpPr txBox="1"/>
           <p:nvPr/>
         </p:nvSpPr>
@@ -11286,7 +11207,7 @@
                 </a:solidFill>
                 <a:latin typeface="Arial"/>
               </a:rPr>
-              <a:t>35% back · 33 portal adds</a:t>
+              <a:t>35% back</a:t>
             </a:r>
           </a:p>
         </p:txBody>
@@ -11299,7 +11220,7 @@
         </p:nvSpPr>
         <p:spPr>
           <a:xfrm>
-            <a:off x="914400" y="3291840"/>
+            <a:off x="914400" y="3383280"/>
             <a:ext cx="137160" cy="137160"/>
           </a:xfrm>
           <a:prstGeom prst="ellipse">
@@ -11343,7 +11264,7 @@
         </p:nvSpPr>
         <p:spPr>
           <a:xfrm>
-            <a:off x="1325880" y="3108960"/>
+            <a:off x="1325880" y="3200400"/>
             <a:ext cx="9601200" cy="731520"/>
           </a:xfrm>
           <a:prstGeom prst="rect">
@@ -11378,7 +11299,7 @@
         </p:nvSpPr>
         <p:spPr>
           <a:xfrm>
-            <a:off x="914400" y="4133088"/>
+            <a:off x="914400" y="4389120"/>
             <a:ext cx="137160" cy="137160"/>
           </a:xfrm>
           <a:prstGeom prst="ellipse">
@@ -11422,7 +11343,7 @@
         </p:nvSpPr>
         <p:spPr>
           <a:xfrm>
-            <a:off x="1325880" y="3950208"/>
+            <a:off x="1325880" y="4206240"/>
             <a:ext cx="9601200" cy="731520"/>
           </a:xfrm>
           <a:prstGeom prst="rect">
@@ -11457,7 +11378,7 @@
         </p:nvSpPr>
         <p:spPr>
           <a:xfrm>
-            <a:off x="914400" y="4974336"/>
+            <a:off x="914400" y="5394959"/>
             <a:ext cx="137160" cy="137160"/>
           </a:xfrm>
           <a:prstGeom prst="ellipse">
@@ -11501,7 +11422,7 @@
         </p:nvSpPr>
         <p:spPr>
           <a:xfrm>
-            <a:off x="1325880" y="4791456"/>
+            <a:off x="1325880" y="5212079"/>
             <a:ext cx="9601200" cy="731520"/>
           </a:xfrm>
           <a:prstGeom prst="rect">
@@ -11530,86 +11451,7 @@
       </p:sp>
       <p:sp>
         <p:nvSpPr>
-          <p:cNvPr id="18" name="Oval 17"/>
-          <p:cNvSpPr/>
-          <p:nvPr/>
-        </p:nvSpPr>
-        <p:spPr>
-          <a:xfrm>
-            <a:off x="914400" y="5815584"/>
-            <a:ext cx="137160" cy="137160"/>
-          </a:xfrm>
-          <a:prstGeom prst="ellipse">
-            <a:avLst/>
-          </a:prstGeom>
-          <a:solidFill>
-            <a:srgbClr val="F47321"/>
-          </a:solidFill>
-          <a:ln>
-            <a:noFill/>
-          </a:ln>
-          <a:effectLst/>
-        </p:spPr>
-        <p:style>
-          <a:lnRef idx="1">
-            <a:schemeClr val="accent1"/>
-          </a:lnRef>
-          <a:fillRef idx="3">
-            <a:schemeClr val="accent1"/>
-          </a:fillRef>
-          <a:effectRef idx="2">
-            <a:schemeClr val="accent1"/>
-          </a:effectRef>
-          <a:fontRef idx="minor">
-            <a:schemeClr val="lt1"/>
-          </a:fontRef>
-        </p:style>
-        <p:txBody>
-          <a:bodyPr rtlCol="0" anchor="ctr"/>
-          <a:lstStyle/>
-          <a:p>
-            <a:pPr algn="ctr"/>
-          </a:p>
-        </p:txBody>
-      </p:sp>
-      <p:sp>
-        <p:nvSpPr>
-          <p:cNvPr id="19" name="TextBox 18"/>
-          <p:cNvSpPr txBox="1"/>
-          <p:nvPr/>
-        </p:nvSpPr>
-        <p:spPr>
-          <a:xfrm>
-            <a:off x="1325880" y="5632704"/>
-            <a:ext cx="9601200" cy="731520"/>
-          </a:xfrm>
-          <a:prstGeom prst="rect">
-            <a:avLst/>
-          </a:prstGeom>
-          <a:noFill/>
-        </p:spPr>
-        <p:txBody>
-          <a:bodyPr wrap="square" lIns="0" rIns="0" tIns="0" bIns="0">
-            <a:spAutoFit/>
-          </a:bodyPr>
-          <a:lstStyle/>
-          <a:p>
-            <a:pPr algn="l"/>
-            <a:r>
-              <a:rPr sz="2400" b="1" i="0">
-                <a:solidFill>
-                  <a:srgbClr val="16273D"/>
-                </a:solidFill>
-                <a:latin typeface="Arial"/>
-              </a:rPr>
-              <a:t>Win the one-score game</a:t>
-            </a:r>
-          </a:p>
-        </p:txBody>
-      </p:sp>
-      <p:sp>
-        <p:nvSpPr>
-          <p:cNvPr id="20" name="TextBox 19"/>
+          <p:cNvPr id="18" name="TextBox 17"/>
           <p:cNvSpPr txBox="1"/>
           <p:nvPr/>
         </p:nvSpPr>
@@ -11864,7 +11706,7 @@
         </p:nvSpPr>
         <p:spPr>
           <a:xfrm>
-            <a:off x="868680" y="2212848"/>
+            <a:off x="868680" y="2231136"/>
             <a:ext cx="128016" cy="128016"/>
           </a:xfrm>
           <a:prstGeom prst="ellipse">
@@ -11909,7 +11751,7 @@
         <p:spPr>
           <a:xfrm>
             <a:off x="1188720" y="2057400"/>
-            <a:ext cx="6217920" cy="731520"/>
+            <a:ext cx="6217920" cy="822960"/>
           </a:xfrm>
           <a:prstGeom prst="rect">
             <a:avLst/>
@@ -11924,7 +11766,7 @@
           <a:p>
             <a:pPr algn="l"/>
             <a:r>
-              <a:rPr sz="2100" b="1" i="0">
+              <a:rPr sz="2400" b="1" i="0">
                 <a:solidFill>
                   <a:srgbClr val="16273D"/>
                 </a:solidFill>
@@ -11937,250 +11779,13 @@
       </p:sp>
       <p:sp>
         <p:nvSpPr>
-          <p:cNvPr id="10" name="Oval 9"/>
+          <p:cNvPr id="10" name="Rounded Rectangle 9"/>
           <p:cNvSpPr/>
           <p:nvPr/>
         </p:nvSpPr>
         <p:spPr>
           <a:xfrm>
-            <a:off x="868680" y="2926080"/>
-            <a:ext cx="128016" cy="128016"/>
-          </a:xfrm>
-          <a:prstGeom prst="ellipse">
-            <a:avLst/>
-          </a:prstGeom>
-          <a:solidFill>
-            <a:srgbClr val="F47321"/>
-          </a:solidFill>
-          <a:ln>
-            <a:noFill/>
-          </a:ln>
-          <a:effectLst/>
-        </p:spPr>
-        <p:style>
-          <a:lnRef idx="1">
-            <a:schemeClr val="accent1"/>
-          </a:lnRef>
-          <a:fillRef idx="3">
-            <a:schemeClr val="accent1"/>
-          </a:fillRef>
-          <a:effectRef idx="2">
-            <a:schemeClr val="accent1"/>
-          </a:effectRef>
-          <a:fontRef idx="minor">
-            <a:schemeClr val="lt1"/>
-          </a:fontRef>
-        </p:style>
-        <p:txBody>
-          <a:bodyPr rtlCol="0" anchor="ctr"/>
-          <a:lstStyle/>
-          <a:p>
-            <a:pPr algn="ctr"/>
-          </a:p>
-        </p:txBody>
-      </p:sp>
-      <p:sp>
-        <p:nvSpPr>
-          <p:cNvPr id="11" name="TextBox 10"/>
-          <p:cNvSpPr txBox="1"/>
-          <p:nvPr/>
-        </p:nvSpPr>
-        <p:spPr>
-          <a:xfrm>
-            <a:off x="1188720" y="2770632"/>
-            <a:ext cx="6217920" cy="731520"/>
-          </a:xfrm>
-          <a:prstGeom prst="rect">
-            <a:avLst/>
-          </a:prstGeom>
-          <a:noFill/>
-        </p:spPr>
-        <p:txBody>
-          <a:bodyPr wrap="square" lIns="0" rIns="0" tIns="0" bIns="0">
-            <a:spAutoFit/>
-          </a:bodyPr>
-          <a:lstStyle/>
-          <a:p>
-            <a:pPr algn="l"/>
-            <a:r>
-              <a:rPr sz="2100" b="1" i="0">
-                <a:solidFill>
-                  <a:srgbClr val="16273D"/>
-                </a:solidFill>
-                <a:latin typeface="Arial"/>
-              </a:rPr>
-              <a:t>Kamario Taylor's breakout</a:t>
-            </a:r>
-          </a:p>
-        </p:txBody>
-      </p:sp>
-      <p:sp>
-        <p:nvSpPr>
-          <p:cNvPr id="12" name="Oval 11"/>
-          <p:cNvSpPr/>
-          <p:nvPr/>
-        </p:nvSpPr>
-        <p:spPr>
-          <a:xfrm>
-            <a:off x="868680" y="3639312"/>
-            <a:ext cx="128016" cy="128016"/>
-          </a:xfrm>
-          <a:prstGeom prst="ellipse">
-            <a:avLst/>
-          </a:prstGeom>
-          <a:solidFill>
-            <a:srgbClr val="F47321"/>
-          </a:solidFill>
-          <a:ln>
-            <a:noFill/>
-          </a:ln>
-          <a:effectLst/>
-        </p:spPr>
-        <p:style>
-          <a:lnRef idx="1">
-            <a:schemeClr val="accent1"/>
-          </a:lnRef>
-          <a:fillRef idx="3">
-            <a:schemeClr val="accent1"/>
-          </a:fillRef>
-          <a:effectRef idx="2">
-            <a:schemeClr val="accent1"/>
-          </a:effectRef>
-          <a:fontRef idx="minor">
-            <a:schemeClr val="lt1"/>
-          </a:fontRef>
-        </p:style>
-        <p:txBody>
-          <a:bodyPr rtlCol="0" anchor="ctr"/>
-          <a:lstStyle/>
-          <a:p>
-            <a:pPr algn="ctr"/>
-          </a:p>
-        </p:txBody>
-      </p:sp>
-      <p:sp>
-        <p:nvSpPr>
-          <p:cNvPr id="13" name="TextBox 12"/>
-          <p:cNvSpPr txBox="1"/>
-          <p:nvPr/>
-        </p:nvSpPr>
-        <p:spPr>
-          <a:xfrm>
-            <a:off x="1188720" y="3483864"/>
-            <a:ext cx="6217920" cy="731520"/>
-          </a:xfrm>
-          <a:prstGeom prst="rect">
-            <a:avLst/>
-          </a:prstGeom>
-          <a:noFill/>
-        </p:spPr>
-        <p:txBody>
-          <a:bodyPr wrap="square" lIns="0" rIns="0" tIns="0" bIns="0">
-            <a:spAutoFit/>
-          </a:bodyPr>
-          <a:lstStyle/>
-          <a:p>
-            <a:pPr algn="l"/>
-            <a:r>
-              <a:rPr sz="2100" b="1" i="0">
-                <a:solidFill>
-                  <a:srgbClr val="16273D"/>
-                </a:solidFill>
-                <a:latin typeface="Arial"/>
-              </a:rPr>
-              <a:t>Sellers hasn't thrown yet</a:t>
-            </a:r>
-          </a:p>
-        </p:txBody>
-      </p:sp>
-      <p:sp>
-        <p:nvSpPr>
-          <p:cNvPr id="14" name="Oval 13"/>
-          <p:cNvSpPr/>
-          <p:nvPr/>
-        </p:nvSpPr>
-        <p:spPr>
-          <a:xfrm>
-            <a:off x="868680" y="4352544"/>
-            <a:ext cx="128016" cy="128016"/>
-          </a:xfrm>
-          <a:prstGeom prst="ellipse">
-            <a:avLst/>
-          </a:prstGeom>
-          <a:solidFill>
-            <a:srgbClr val="F47321"/>
-          </a:solidFill>
-          <a:ln>
-            <a:noFill/>
-          </a:ln>
-          <a:effectLst/>
-        </p:spPr>
-        <p:style>
-          <a:lnRef idx="1">
-            <a:schemeClr val="accent1"/>
-          </a:lnRef>
-          <a:fillRef idx="3">
-            <a:schemeClr val="accent1"/>
-          </a:fillRef>
-          <a:effectRef idx="2">
-            <a:schemeClr val="accent1"/>
-          </a:effectRef>
-          <a:fontRef idx="minor">
-            <a:schemeClr val="lt1"/>
-          </a:fontRef>
-        </p:style>
-        <p:txBody>
-          <a:bodyPr rtlCol="0" anchor="ctr"/>
-          <a:lstStyle/>
-          <a:p>
-            <a:pPr algn="ctr"/>
-          </a:p>
-        </p:txBody>
-      </p:sp>
-      <p:sp>
-        <p:nvSpPr>
-          <p:cNvPr id="15" name="TextBox 14"/>
-          <p:cNvSpPr txBox="1"/>
-          <p:nvPr/>
-        </p:nvSpPr>
-        <p:spPr>
-          <a:xfrm>
-            <a:off x="1188720" y="4197096"/>
-            <a:ext cx="6217920" cy="731520"/>
-          </a:xfrm>
-          <a:prstGeom prst="rect">
-            <a:avLst/>
-          </a:prstGeom>
-          <a:noFill/>
-        </p:spPr>
-        <p:txBody>
-          <a:bodyPr wrap="square" lIns="0" rIns="0" tIns="0" bIns="0">
-            <a:spAutoFit/>
-          </a:bodyPr>
-          <a:lstStyle/>
-          <a:p>
-            <a:pPr algn="l"/>
-            <a:r>
-              <a:rPr sz="2100" b="1" i="0">
-                <a:solidFill>
-                  <a:srgbClr val="16273D"/>
-                </a:solidFill>
-                <a:latin typeface="Arial"/>
-              </a:rPr>
-              <a:t>Arnett's defense, back in Starkville</a:t>
-            </a:r>
-          </a:p>
-        </p:txBody>
-      </p:sp>
-      <p:sp>
-        <p:nvSpPr>
-          <p:cNvPr id="16" name="Rounded Rectangle 15"/>
-          <p:cNvSpPr/>
-          <p:nvPr/>
-        </p:nvSpPr>
-        <p:spPr>
-          <a:xfrm>
-            <a:off x="822960" y="5047488"/>
+            <a:off x="822960" y="4754880"/>
             <a:ext cx="6583680" cy="960120"/>
           </a:xfrm>
           <a:prstGeom prst="roundRect">
@@ -12218,13 +11823,13 @@
       </p:sp>
       <p:sp>
         <p:nvSpPr>
-          <p:cNvPr id="17" name="TextBox 16"/>
-          <p:cNvSpPr txBox="1"/>
-          <p:nvPr/>
-        </p:nvSpPr>
-        <p:spPr>
-          <a:xfrm>
-            <a:off x="1051560" y="5276088"/>
+          <p:cNvPr id="11" name="TextBox 10"/>
+          <p:cNvSpPr txBox="1"/>
+          <p:nvPr/>
+        </p:nvSpPr>
+        <p:spPr>
+          <a:xfrm>
+            <a:off x="1051560" y="4983480"/>
             <a:ext cx="6126480" cy="502920"/>
           </a:xfrm>
           <a:prstGeom prst="rect">
@@ -12253,7 +11858,7 @@
       </p:sp>
       <p:sp>
         <p:nvSpPr>
-          <p:cNvPr id="18" name="Rounded Rectangle 17"/>
+          <p:cNvPr id="12" name="Rounded Rectangle 11"/>
           <p:cNvSpPr/>
           <p:nvPr/>
         </p:nvSpPr>
@@ -12297,7 +11902,7 @@
       </p:sp>
       <p:sp>
         <p:nvSpPr>
-          <p:cNvPr id="19" name="TextBox 18"/>
+          <p:cNvPr id="13" name="TextBox 12"/>
           <p:cNvSpPr txBox="1"/>
           <p:nvPr/>
         </p:nvSpPr>
@@ -12332,7 +11937,7 @@
       </p:sp>
       <p:sp>
         <p:nvSpPr>
-          <p:cNvPr id="20" name="TextBox 19"/>
+          <p:cNvPr id="14" name="TextBox 13"/>
           <p:cNvSpPr txBox="1"/>
           <p:nvPr/>
         </p:nvSpPr>
@@ -12367,7 +11972,7 @@
       </p:sp>
       <p:sp>
         <p:nvSpPr>
-          <p:cNvPr id="21" name="TextBox 20"/>
+          <p:cNvPr id="15" name="TextBox 14"/>
           <p:cNvSpPr txBox="1"/>
           <p:nvPr/>
         </p:nvSpPr>
@@ -12402,7 +12007,7 @@
       </p:sp>
       <p:sp>
         <p:nvSpPr>
-          <p:cNvPr id="22" name="TextBox 21"/>
+          <p:cNvPr id="16" name="TextBox 15"/>
           <p:cNvSpPr txBox="1"/>
           <p:nvPr/>
         </p:nvSpPr>
@@ -12437,7 +12042,7 @@
       </p:sp>
       <p:sp>
         <p:nvSpPr>
-          <p:cNvPr id="23" name="TextBox 22"/>
+          <p:cNvPr id="17" name="TextBox 16"/>
           <p:cNvSpPr txBox="1"/>
           <p:nvPr/>
         </p:nvSpPr>
@@ -12472,7 +12077,7 @@
       </p:sp>
       <p:sp>
         <p:nvSpPr>
-          <p:cNvPr id="24" name="TextBox 23"/>
+          <p:cNvPr id="18" name="TextBox 17"/>
           <p:cNvSpPr txBox="1"/>
           <p:nvPr/>
         </p:nvSpPr>
@@ -12507,7 +12112,7 @@
       </p:sp>
       <p:sp>
         <p:nvSpPr>
-          <p:cNvPr id="25" name="TextBox 24"/>
+          <p:cNvPr id="19" name="TextBox 18"/>
           <p:cNvSpPr txBox="1"/>
           <p:nvPr/>
         </p:nvSpPr>
@@ -12542,7 +12147,7 @@
       </p:sp>
       <p:sp>
         <p:nvSpPr>
-          <p:cNvPr id="26" name="TextBox 25"/>
+          <p:cNvPr id="20" name="TextBox 19"/>
           <p:cNvSpPr txBox="1"/>
           <p:nvPr/>
         </p:nvSpPr>
@@ -12577,7 +12182,7 @@
       </p:sp>
       <p:sp>
         <p:nvSpPr>
-          <p:cNvPr id="27" name="Rounded Rectangle 26"/>
+          <p:cNvPr id="21" name="Rounded Rectangle 20"/>
           <p:cNvSpPr/>
           <p:nvPr/>
         </p:nvSpPr>
@@ -12621,7 +12226,7 @@
       </p:sp>
       <p:sp>
         <p:nvSpPr>
-          <p:cNvPr id="28" name="Rounded Rectangle 27"/>
+          <p:cNvPr id="22" name="Rounded Rectangle 21"/>
           <p:cNvSpPr/>
           <p:nvPr/>
         </p:nvSpPr>
@@ -12665,7 +12270,7 @@
       </p:sp>
       <p:sp>
         <p:nvSpPr>
-          <p:cNvPr id="29" name="TextBox 28"/>
+          <p:cNvPr id="23" name="TextBox 22"/>
           <p:cNvSpPr txBox="1"/>
           <p:nvPr/>
         </p:nvSpPr>
@@ -12700,7 +12305,7 @@
       </p:sp>
       <p:sp>
         <p:nvSpPr>
-          <p:cNvPr id="30" name="TextBox 29"/>
+          <p:cNvPr id="24" name="TextBox 23"/>
           <p:cNvSpPr txBox="1"/>
           <p:nvPr/>
         </p:nvSpPr>
@@ -12735,7 +12340,7 @@
       </p:sp>
       <p:sp>
         <p:nvSpPr>
-          <p:cNvPr id="31" name="TextBox 30"/>
+          <p:cNvPr id="25" name="TextBox 24"/>
           <p:cNvSpPr txBox="1"/>
           <p:nvPr/>
         </p:nvSpPr>
@@ -12997,7 +12602,7 @@
                 </a:solidFill>
                 <a:latin typeface="Arial"/>
               </a:rPr>
-              <a:t>Lebby, year 3 · Arnett DC</a:t>
+              <a:t>Lebby, year 3</a:t>
             </a:r>
           </a:p>
         </p:txBody>
@@ -13137,7 +12742,7 @@
                 </a:solidFill>
                 <a:latin typeface="Arial"/>
               </a:rPr>
-              <a:t>34% back · 28 portal adds</a:t>
+              <a:t>34% back</a:t>
             </a:r>
           </a:p>
         </p:txBody>
@@ -13150,7 +12755,7 @@
         </p:nvSpPr>
         <p:spPr>
           <a:xfrm>
-            <a:off x="914400" y="3291840"/>
+            <a:off x="914400" y="3383280"/>
             <a:ext cx="137160" cy="137160"/>
           </a:xfrm>
           <a:prstGeom prst="ellipse">
@@ -13194,7 +12799,7 @@
         </p:nvSpPr>
         <p:spPr>
           <a:xfrm>
-            <a:off x="1325880" y="3108960"/>
+            <a:off x="1325880" y="3200400"/>
             <a:ext cx="9601200" cy="731520"/>
           </a:xfrm>
           <a:prstGeom prst="rect">
@@ -13229,7 +12834,7 @@
         </p:nvSpPr>
         <p:spPr>
           <a:xfrm>
-            <a:off x="914400" y="4133088"/>
+            <a:off x="914400" y="4389120"/>
             <a:ext cx="137160" cy="137160"/>
           </a:xfrm>
           <a:prstGeom prst="ellipse">
@@ -13273,7 +12878,7 @@
         </p:nvSpPr>
         <p:spPr>
           <a:xfrm>
-            <a:off x="1325880" y="3950208"/>
+            <a:off x="1325880" y="4206240"/>
             <a:ext cx="9601200" cy="731520"/>
           </a:xfrm>
           <a:prstGeom prst="rect">
@@ -13308,7 +12913,7 @@
         </p:nvSpPr>
         <p:spPr>
           <a:xfrm>
-            <a:off x="914400" y="4974336"/>
+            <a:off x="914400" y="5394959"/>
             <a:ext cx="137160" cy="137160"/>
           </a:xfrm>
           <a:prstGeom prst="ellipse">
@@ -13352,7 +12957,7 @@
         </p:nvSpPr>
         <p:spPr>
           <a:xfrm>
-            <a:off x="1325880" y="4791456"/>
+            <a:off x="1325880" y="5212079"/>
             <a:ext cx="9601200" cy="731520"/>
           </a:xfrm>
           <a:prstGeom prst="rect">
@@ -13381,86 +12986,7 @@
       </p:sp>
       <p:sp>
         <p:nvSpPr>
-          <p:cNvPr id="18" name="Oval 17"/>
-          <p:cNvSpPr/>
-          <p:nvPr/>
-        </p:nvSpPr>
-        <p:spPr>
-          <a:xfrm>
-            <a:off x="914400" y="5815584"/>
-            <a:ext cx="137160" cy="137160"/>
-          </a:xfrm>
-          <a:prstGeom prst="ellipse">
-            <a:avLst/>
-          </a:prstGeom>
-          <a:solidFill>
-            <a:srgbClr val="F47321"/>
-          </a:solidFill>
-          <a:ln>
-            <a:noFill/>
-          </a:ln>
-          <a:effectLst/>
-        </p:spPr>
-        <p:style>
-          <a:lnRef idx="1">
-            <a:schemeClr val="accent1"/>
-          </a:lnRef>
-          <a:fillRef idx="3">
-            <a:schemeClr val="accent1"/>
-          </a:fillRef>
-          <a:effectRef idx="2">
-            <a:schemeClr val="accent1"/>
-          </a:effectRef>
-          <a:fontRef idx="minor">
-            <a:schemeClr val="lt1"/>
-          </a:fontRef>
-        </p:style>
-        <p:txBody>
-          <a:bodyPr rtlCol="0" anchor="ctr"/>
-          <a:lstStyle/>
-          <a:p>
-            <a:pPr algn="ctr"/>
-          </a:p>
-        </p:txBody>
-      </p:sp>
-      <p:sp>
-        <p:nvSpPr>
-          <p:cNvPr id="19" name="TextBox 18"/>
-          <p:cNvSpPr txBox="1"/>
-          <p:nvPr/>
-        </p:nvSpPr>
-        <p:spPr>
-          <a:xfrm>
-            <a:off x="1325880" y="5632704"/>
-            <a:ext cx="9601200" cy="731520"/>
-          </a:xfrm>
-          <a:prstGeom prst="rect">
-            <a:avLst/>
-          </a:prstGeom>
-          <a:noFill/>
-        </p:spPr>
-        <p:txBody>
-          <a:bodyPr wrap="square" lIns="0" rIns="0" tIns="0" bIns="0">
-            <a:spAutoFit/>
-          </a:bodyPr>
-          <a:lstStyle/>
-          <a:p>
-            <a:pPr algn="l"/>
-            <a:r>
-              <a:rPr sz="2400" b="1" i="0">
-                <a:solidFill>
-                  <a:srgbClr val="16273D"/>
-                </a:solidFill>
-                <a:latin typeface="Arial"/>
-              </a:rPr>
-              <a:t>Win the turnover ledger</a:t>
-            </a:r>
-          </a:p>
-        </p:txBody>
-      </p:sp>
-      <p:sp>
-        <p:nvSpPr>
-          <p:cNvPr id="20" name="TextBox 19"/>
+          <p:cNvPr id="18" name="TextBox 17"/>
           <p:cNvSpPr txBox="1"/>
           <p:nvPr/>
         </p:nvSpPr>
@@ -13722,7 +13248,7 @@
                 </a:solidFill>
                 <a:latin typeface="Arial"/>
               </a:rPr>
-              <a:t>Beamer, year 6 · new OC Briles</a:t>
+              <a:t>Beamer, year 6</a:t>
             </a:r>
           </a:p>
         </p:txBody>
@@ -13862,7 +13388,7 @@
                 </a:solidFill>
                 <a:latin typeface="Arial"/>
               </a:rPr>
-              <a:t>69% back · 26 portal adds</a:t>
+              <a:t>69% back</a:t>
             </a:r>
           </a:p>
         </p:txBody>
@@ -13875,7 +13401,7 @@
         </p:nvSpPr>
         <p:spPr>
           <a:xfrm>
-            <a:off x="914400" y="3291840"/>
+            <a:off x="914400" y="3383280"/>
             <a:ext cx="137160" cy="137160"/>
           </a:xfrm>
           <a:prstGeom prst="ellipse">
@@ -13919,7 +13445,7 @@
         </p:nvSpPr>
         <p:spPr>
           <a:xfrm>
-            <a:off x="1325880" y="3108960"/>
+            <a:off x="1325880" y="3200400"/>
             <a:ext cx="9601200" cy="731520"/>
           </a:xfrm>
           <a:prstGeom prst="rect">
@@ -13954,7 +13480,7 @@
         </p:nvSpPr>
         <p:spPr>
           <a:xfrm>
-            <a:off x="914400" y="4133088"/>
+            <a:off x="914400" y="4389120"/>
             <a:ext cx="137160" cy="137160"/>
           </a:xfrm>
           <a:prstGeom prst="ellipse">
@@ -13998,7 +13524,7 @@
         </p:nvSpPr>
         <p:spPr>
           <a:xfrm>
-            <a:off x="1325880" y="3950208"/>
+            <a:off x="1325880" y="4206240"/>
             <a:ext cx="9601200" cy="731520"/>
           </a:xfrm>
           <a:prstGeom prst="rect">
@@ -14033,7 +13559,7 @@
         </p:nvSpPr>
         <p:spPr>
           <a:xfrm>
-            <a:off x="914400" y="4974336"/>
+            <a:off x="914400" y="5394959"/>
             <a:ext cx="137160" cy="137160"/>
           </a:xfrm>
           <a:prstGeom prst="ellipse">
@@ -14077,7 +13603,7 @@
         </p:nvSpPr>
         <p:spPr>
           <a:xfrm>
-            <a:off x="1325880" y="4791456"/>
+            <a:off x="1325880" y="5212079"/>
             <a:ext cx="9601200" cy="731520"/>
           </a:xfrm>
           <a:prstGeom prst="rect">
@@ -14106,86 +13632,7 @@
       </p:sp>
       <p:sp>
         <p:nvSpPr>
-          <p:cNvPr id="18" name="Oval 17"/>
-          <p:cNvSpPr/>
-          <p:nvPr/>
-        </p:nvSpPr>
-        <p:spPr>
-          <a:xfrm>
-            <a:off x="914400" y="5815584"/>
-            <a:ext cx="137160" cy="137160"/>
-          </a:xfrm>
-          <a:prstGeom prst="ellipse">
-            <a:avLst/>
-          </a:prstGeom>
-          <a:solidFill>
-            <a:srgbClr val="F47321"/>
-          </a:solidFill>
-          <a:ln>
-            <a:noFill/>
-          </a:ln>
-          <a:effectLst/>
-        </p:spPr>
-        <p:style>
-          <a:lnRef idx="1">
-            <a:schemeClr val="accent1"/>
-          </a:lnRef>
-          <a:fillRef idx="3">
-            <a:schemeClr val="accent1"/>
-          </a:fillRef>
-          <a:effectRef idx="2">
-            <a:schemeClr val="accent1"/>
-          </a:effectRef>
-          <a:fontRef idx="minor">
-            <a:schemeClr val="lt1"/>
-          </a:fontRef>
-        </p:style>
-        <p:txBody>
-          <a:bodyPr rtlCol="0" anchor="ctr"/>
-          <a:lstStyle/>
-          <a:p>
-            <a:pPr algn="ctr"/>
-          </a:p>
-        </p:txBody>
-      </p:sp>
-      <p:sp>
-        <p:nvSpPr>
-          <p:cNvPr id="19" name="TextBox 18"/>
-          <p:cNvSpPr txBox="1"/>
-          <p:nvPr/>
-        </p:nvSpPr>
-        <p:spPr>
-          <a:xfrm>
-            <a:off x="1325880" y="5632704"/>
-            <a:ext cx="9601200" cy="731520"/>
-          </a:xfrm>
-          <a:prstGeom prst="rect">
-            <a:avLst/>
-          </a:prstGeom>
-          <a:noFill/>
-        </p:spPr>
-        <p:txBody>
-          <a:bodyPr wrap="square" lIns="0" rIns="0" tIns="0" bIns="0">
-            <a:spAutoFit/>
-          </a:bodyPr>
-          <a:lstStyle/>
-          <a:p>
-            <a:pPr algn="l"/>
-            <a:r>
-              <a:rPr sz="2400" b="1" i="0">
-                <a:solidFill>
-                  <a:srgbClr val="16273D"/>
-                </a:solidFill>
-                <a:latin typeface="Arial"/>
-              </a:rPr>
-              <a:t>Stewart off the edge</a:t>
-            </a:r>
-          </a:p>
-        </p:txBody>
-      </p:sp>
-      <p:sp>
-        <p:nvSpPr>
-          <p:cNvPr id="20" name="TextBox 19"/>
+          <p:cNvPr id="18" name="TextBox 17"/>
           <p:cNvSpPr txBox="1"/>
           <p:nvPr/>
         </p:nvSpPr>
@@ -14440,7 +13887,7 @@
         </p:nvSpPr>
         <p:spPr>
           <a:xfrm>
-            <a:off x="868680" y="2212848"/>
+            <a:off x="868680" y="2231136"/>
             <a:ext cx="128016" cy="128016"/>
           </a:xfrm>
           <a:prstGeom prst="ellipse">
@@ -14485,7 +13932,7 @@
         <p:spPr>
           <a:xfrm>
             <a:off x="1188720" y="2057400"/>
-            <a:ext cx="6217920" cy="731520"/>
+            <a:ext cx="6217920" cy="822960"/>
           </a:xfrm>
           <a:prstGeom prst="rect">
             <a:avLst/>
@@ -14500,7 +13947,7 @@
           <a:p>
             <a:pPr algn="l"/>
             <a:r>
-              <a:rPr sz="2100" b="1" i="0">
+              <a:rPr sz="2400" b="1" i="0">
                 <a:solidFill>
                   <a:srgbClr val="16273D"/>
                 </a:solidFill>
@@ -14513,250 +13960,13 @@
       </p:sp>
       <p:sp>
         <p:nvSpPr>
-          <p:cNvPr id="10" name="Oval 9"/>
+          <p:cNvPr id="10" name="Rounded Rectangle 9"/>
           <p:cNvSpPr/>
           <p:nvPr/>
         </p:nvSpPr>
         <p:spPr>
           <a:xfrm>
-            <a:off x="868680" y="2926080"/>
-            <a:ext cx="128016" cy="128016"/>
-          </a:xfrm>
-          <a:prstGeom prst="ellipse">
-            <a:avLst/>
-          </a:prstGeom>
-          <a:solidFill>
-            <a:srgbClr val="F47321"/>
-          </a:solidFill>
-          <a:ln>
-            <a:noFill/>
-          </a:ln>
-          <a:effectLst/>
-        </p:spPr>
-        <p:style>
-          <a:lnRef idx="1">
-            <a:schemeClr val="accent1"/>
-          </a:lnRef>
-          <a:fillRef idx="3">
-            <a:schemeClr val="accent1"/>
-          </a:fillRef>
-          <a:effectRef idx="2">
-            <a:schemeClr val="accent1"/>
-          </a:effectRef>
-          <a:fontRef idx="minor">
-            <a:schemeClr val="lt1"/>
-          </a:fontRef>
-        </p:style>
-        <p:txBody>
-          <a:bodyPr rtlCol="0" anchor="ctr"/>
-          <a:lstStyle/>
-          <a:p>
-            <a:pPr algn="ctr"/>
-          </a:p>
-        </p:txBody>
-      </p:sp>
-      <p:sp>
-        <p:nvSpPr>
-          <p:cNvPr id="11" name="TextBox 10"/>
-          <p:cNvSpPr txBox="1"/>
-          <p:nvPr/>
-        </p:nvSpPr>
-        <p:spPr>
-          <a:xfrm>
-            <a:off x="1188720" y="2770632"/>
-            <a:ext cx="6217920" cy="731520"/>
-          </a:xfrm>
-          <a:prstGeom prst="rect">
-            <a:avLst/>
-          </a:prstGeom>
-          <a:noFill/>
-        </p:spPr>
-        <p:txBody>
-          <a:bodyPr wrap="square" lIns="0" rIns="0" tIns="0" bIns="0">
-            <a:spAutoFit/>
-          </a:bodyPr>
-          <a:lstStyle/>
-          <a:p>
-            <a:pPr algn="l"/>
-            <a:r>
-              <a:rPr sz="2100" b="1" i="0">
-                <a:solidFill>
-                  <a:srgbClr val="16273D"/>
-                </a:solidFill>
-                <a:latin typeface="Arial"/>
-              </a:rPr>
-              <a:t>Auburn's rebuilt lines vs Florida's front</a:t>
-            </a:r>
-          </a:p>
-        </p:txBody>
-      </p:sp>
-      <p:sp>
-        <p:nvSpPr>
-          <p:cNvPr id="12" name="Oval 11"/>
-          <p:cNvSpPr/>
-          <p:nvPr/>
-        </p:nvSpPr>
-        <p:spPr>
-          <a:xfrm>
-            <a:off x="868680" y="3639312"/>
-            <a:ext cx="128016" cy="128016"/>
-          </a:xfrm>
-          <a:prstGeom prst="ellipse">
-            <a:avLst/>
-          </a:prstGeom>
-          <a:solidFill>
-            <a:srgbClr val="F47321"/>
-          </a:solidFill>
-          <a:ln>
-            <a:noFill/>
-          </a:ln>
-          <a:effectLst/>
-        </p:spPr>
-        <p:style>
-          <a:lnRef idx="1">
-            <a:schemeClr val="accent1"/>
-          </a:lnRef>
-          <a:fillRef idx="3">
-            <a:schemeClr val="accent1"/>
-          </a:fillRef>
-          <a:effectRef idx="2">
-            <a:schemeClr val="accent1"/>
-          </a:effectRef>
-          <a:fontRef idx="minor">
-            <a:schemeClr val="lt1"/>
-          </a:fontRef>
-        </p:style>
-        <p:txBody>
-          <a:bodyPr rtlCol="0" anchor="ctr"/>
-          <a:lstStyle/>
-          <a:p>
-            <a:pPr algn="ctr"/>
-          </a:p>
-        </p:txBody>
-      </p:sp>
-      <p:sp>
-        <p:nvSpPr>
-          <p:cNvPr id="13" name="TextBox 12"/>
-          <p:cNvSpPr txBox="1"/>
-          <p:nvPr/>
-        </p:nvSpPr>
-        <p:spPr>
-          <a:xfrm>
-            <a:off x="1188720" y="3483864"/>
-            <a:ext cx="6217920" cy="731520"/>
-          </a:xfrm>
-          <a:prstGeom prst="rect">
-            <a:avLst/>
-          </a:prstGeom>
-          <a:noFill/>
-        </p:spPr>
-        <p:txBody>
-          <a:bodyPr wrap="square" lIns="0" rIns="0" tIns="0" bIns="0">
-            <a:spAutoFit/>
-          </a:bodyPr>
-          <a:lstStyle/>
-          <a:p>
-            <a:pPr algn="l"/>
-            <a:r>
-              <a:rPr sz="2100" b="1" i="0">
-                <a:solidFill>
-                  <a:srgbClr val="16273D"/>
-                </a:solidFill>
-                <a:latin typeface="Arial"/>
-              </a:rPr>
-              <a:t>Byrum Brown vs Aaron Philo</a:t>
-            </a:r>
-          </a:p>
-        </p:txBody>
-      </p:sp>
-      <p:sp>
-        <p:nvSpPr>
-          <p:cNvPr id="14" name="Oval 13"/>
-          <p:cNvSpPr/>
-          <p:nvPr/>
-        </p:nvSpPr>
-        <p:spPr>
-          <a:xfrm>
-            <a:off x="868680" y="4352544"/>
-            <a:ext cx="128016" cy="128016"/>
-          </a:xfrm>
-          <a:prstGeom prst="ellipse">
-            <a:avLst/>
-          </a:prstGeom>
-          <a:solidFill>
-            <a:srgbClr val="F47321"/>
-          </a:solidFill>
-          <a:ln>
-            <a:noFill/>
-          </a:ln>
-          <a:effectLst/>
-        </p:spPr>
-        <p:style>
-          <a:lnRef idx="1">
-            <a:schemeClr val="accent1"/>
-          </a:lnRef>
-          <a:fillRef idx="3">
-            <a:schemeClr val="accent1"/>
-          </a:fillRef>
-          <a:effectRef idx="2">
-            <a:schemeClr val="accent1"/>
-          </a:effectRef>
-          <a:fontRef idx="minor">
-            <a:schemeClr val="lt1"/>
-          </a:fontRef>
-        </p:style>
-        <p:txBody>
-          <a:bodyPr rtlCol="0" anchor="ctr"/>
-          <a:lstStyle/>
-          <a:p>
-            <a:pPr algn="ctr"/>
-          </a:p>
-        </p:txBody>
-      </p:sp>
-      <p:sp>
-        <p:nvSpPr>
-          <p:cNvPr id="15" name="TextBox 14"/>
-          <p:cNvSpPr txBox="1"/>
-          <p:nvPr/>
-        </p:nvSpPr>
-        <p:spPr>
-          <a:xfrm>
-            <a:off x="1188720" y="4197096"/>
-            <a:ext cx="6217920" cy="731520"/>
-          </a:xfrm>
-          <a:prstGeom prst="rect">
-            <a:avLst/>
-          </a:prstGeom>
-          <a:noFill/>
-        </p:spPr>
-        <p:txBody>
-          <a:bodyPr wrap="square" lIns="0" rIns="0" tIns="0" bIns="0">
-            <a:spAutoFit/>
-          </a:bodyPr>
-          <a:lstStyle/>
-          <a:p>
-            <a:pPr algn="l"/>
-            <a:r>
-              <a:rPr sz="2100" b="1" i="0">
-                <a:solidFill>
-                  <a:srgbClr val="16273D"/>
-                </a:solidFill>
-                <a:latin typeface="Arial"/>
-              </a:rPr>
-              <a:t>Jordan-Hare at night</a:t>
-            </a:r>
-          </a:p>
-        </p:txBody>
-      </p:sp>
-      <p:sp>
-        <p:nvSpPr>
-          <p:cNvPr id="16" name="Rounded Rectangle 15"/>
-          <p:cNvSpPr/>
-          <p:nvPr/>
-        </p:nvSpPr>
-        <p:spPr>
-          <a:xfrm>
-            <a:off x="822960" y="5047488"/>
+            <a:off x="822960" y="4754880"/>
             <a:ext cx="6583680" cy="960120"/>
           </a:xfrm>
           <a:prstGeom prst="roundRect">
@@ -14794,13 +14004,13 @@
       </p:sp>
       <p:sp>
         <p:nvSpPr>
-          <p:cNvPr id="17" name="TextBox 16"/>
-          <p:cNvSpPr txBox="1"/>
-          <p:nvPr/>
-        </p:nvSpPr>
-        <p:spPr>
-          <a:xfrm>
-            <a:off x="1051560" y="5276088"/>
+          <p:cNvPr id="11" name="TextBox 10"/>
+          <p:cNvSpPr txBox="1"/>
+          <p:nvPr/>
+        </p:nvSpPr>
+        <p:spPr>
+          <a:xfrm>
+            <a:off x="1051560" y="4983480"/>
             <a:ext cx="6126480" cy="502920"/>
           </a:xfrm>
           <a:prstGeom prst="rect">
@@ -14829,7 +14039,7 @@
       </p:sp>
       <p:sp>
         <p:nvSpPr>
-          <p:cNvPr id="18" name="Rounded Rectangle 17"/>
+          <p:cNvPr id="12" name="Rounded Rectangle 11"/>
           <p:cNvSpPr/>
           <p:nvPr/>
         </p:nvSpPr>
@@ -14873,7 +14083,7 @@
       </p:sp>
       <p:sp>
         <p:nvSpPr>
-          <p:cNvPr id="19" name="TextBox 18"/>
+          <p:cNvPr id="13" name="TextBox 12"/>
           <p:cNvSpPr txBox="1"/>
           <p:nvPr/>
         </p:nvSpPr>
@@ -14908,7 +14118,7 @@
       </p:sp>
       <p:sp>
         <p:nvSpPr>
-          <p:cNvPr id="20" name="TextBox 19"/>
+          <p:cNvPr id="14" name="TextBox 13"/>
           <p:cNvSpPr txBox="1"/>
           <p:nvPr/>
         </p:nvSpPr>
@@ -14943,7 +14153,7 @@
       </p:sp>
       <p:sp>
         <p:nvSpPr>
-          <p:cNvPr id="21" name="TextBox 20"/>
+          <p:cNvPr id="15" name="TextBox 14"/>
           <p:cNvSpPr txBox="1"/>
           <p:nvPr/>
         </p:nvSpPr>
@@ -14978,7 +14188,7 @@
       </p:sp>
       <p:sp>
         <p:nvSpPr>
-          <p:cNvPr id="22" name="TextBox 21"/>
+          <p:cNvPr id="16" name="TextBox 15"/>
           <p:cNvSpPr txBox="1"/>
           <p:nvPr/>
         </p:nvSpPr>
@@ -15013,7 +14223,7 @@
       </p:sp>
       <p:sp>
         <p:nvSpPr>
-          <p:cNvPr id="23" name="TextBox 22"/>
+          <p:cNvPr id="17" name="TextBox 16"/>
           <p:cNvSpPr txBox="1"/>
           <p:nvPr/>
         </p:nvSpPr>
@@ -15048,7 +14258,7 @@
       </p:sp>
       <p:sp>
         <p:nvSpPr>
-          <p:cNvPr id="24" name="TextBox 23"/>
+          <p:cNvPr id="18" name="TextBox 17"/>
           <p:cNvSpPr txBox="1"/>
           <p:nvPr/>
         </p:nvSpPr>
@@ -15083,7 +14293,7 @@
       </p:sp>
       <p:sp>
         <p:nvSpPr>
-          <p:cNvPr id="25" name="TextBox 24"/>
+          <p:cNvPr id="19" name="TextBox 18"/>
           <p:cNvSpPr txBox="1"/>
           <p:nvPr/>
         </p:nvSpPr>
@@ -15118,7 +14328,7 @@
       </p:sp>
       <p:sp>
         <p:nvSpPr>
-          <p:cNvPr id="26" name="TextBox 25"/>
+          <p:cNvPr id="20" name="TextBox 19"/>
           <p:cNvSpPr txBox="1"/>
           <p:nvPr/>
         </p:nvSpPr>
@@ -15153,7 +14363,7 @@
       </p:sp>
       <p:sp>
         <p:nvSpPr>
-          <p:cNvPr id="27" name="Rounded Rectangle 26"/>
+          <p:cNvPr id="21" name="Rounded Rectangle 20"/>
           <p:cNvSpPr/>
           <p:nvPr/>
         </p:nvSpPr>
@@ -15197,7 +14407,7 @@
       </p:sp>
       <p:sp>
         <p:nvSpPr>
-          <p:cNvPr id="28" name="Rounded Rectangle 27"/>
+          <p:cNvPr id="22" name="Rounded Rectangle 21"/>
           <p:cNvSpPr/>
           <p:nvPr/>
         </p:nvSpPr>
@@ -15241,7 +14451,7 @@
       </p:sp>
       <p:sp>
         <p:nvSpPr>
-          <p:cNvPr id="29" name="TextBox 28"/>
+          <p:cNvPr id="23" name="TextBox 22"/>
           <p:cNvSpPr txBox="1"/>
           <p:nvPr/>
         </p:nvSpPr>
@@ -15276,7 +14486,7 @@
       </p:sp>
       <p:sp>
         <p:nvSpPr>
-          <p:cNvPr id="30" name="TextBox 29"/>
+          <p:cNvPr id="24" name="TextBox 23"/>
           <p:cNvSpPr txBox="1"/>
           <p:nvPr/>
         </p:nvSpPr>
@@ -15311,7 +14521,7 @@
       </p:sp>
       <p:sp>
         <p:nvSpPr>
-          <p:cNvPr id="31" name="TextBox 30"/>
+          <p:cNvPr id="25" name="TextBox 24"/>
           <p:cNvSpPr txBox="1"/>
           <p:nvPr/>
         </p:nvSpPr>
@@ -15713,7 +14923,7 @@
                 </a:solidFill>
                 <a:latin typeface="Arial"/>
               </a:rPr>
-              <a:t>69% back · 27 portal adds</a:t>
+              <a:t>69% back</a:t>
             </a:r>
           </a:p>
         </p:txBody>
@@ -15726,7 +14936,7 @@
         </p:nvSpPr>
         <p:spPr>
           <a:xfrm>
-            <a:off x="914400" y="3291840"/>
+            <a:off x="914400" y="3383280"/>
             <a:ext cx="137160" cy="137160"/>
           </a:xfrm>
           <a:prstGeom prst="ellipse">
@@ -15770,7 +14980,7 @@
         </p:nvSpPr>
         <p:spPr>
           <a:xfrm>
-            <a:off x="1325880" y="3108960"/>
+            <a:off x="1325880" y="3200400"/>
             <a:ext cx="9601200" cy="731520"/>
           </a:xfrm>
           <a:prstGeom prst="rect">
@@ -15805,7 +15015,7 @@
         </p:nvSpPr>
         <p:spPr>
           <a:xfrm>
-            <a:off x="914400" y="4133088"/>
+            <a:off x="914400" y="4389120"/>
             <a:ext cx="137160" cy="137160"/>
           </a:xfrm>
           <a:prstGeom prst="ellipse">
@@ -15849,7 +15059,7 @@
         </p:nvSpPr>
         <p:spPr>
           <a:xfrm>
-            <a:off x="1325880" y="3950208"/>
+            <a:off x="1325880" y="4206240"/>
             <a:ext cx="9601200" cy="731520"/>
           </a:xfrm>
           <a:prstGeom prst="rect">
@@ -15884,7 +15094,7 @@
         </p:nvSpPr>
         <p:spPr>
           <a:xfrm>
-            <a:off x="914400" y="4974336"/>
+            <a:off x="914400" y="5394959"/>
             <a:ext cx="137160" cy="137160"/>
           </a:xfrm>
           <a:prstGeom prst="ellipse">
@@ -15928,7 +15138,7 @@
         </p:nvSpPr>
         <p:spPr>
           <a:xfrm>
-            <a:off x="1325880" y="4791456"/>
+            <a:off x="1325880" y="5212079"/>
             <a:ext cx="9601200" cy="731520"/>
           </a:xfrm>
           <a:prstGeom prst="rect">
@@ -15957,86 +15167,7 @@
       </p:sp>
       <p:sp>
         <p:nvSpPr>
-          <p:cNvPr id="18" name="Oval 17"/>
-          <p:cNvSpPr/>
-          <p:nvPr/>
-        </p:nvSpPr>
-        <p:spPr>
-          <a:xfrm>
-            <a:off x="914400" y="5815584"/>
-            <a:ext cx="137160" cy="137160"/>
-          </a:xfrm>
-          <a:prstGeom prst="ellipse">
-            <a:avLst/>
-          </a:prstGeom>
-          <a:solidFill>
-            <a:srgbClr val="F47321"/>
-          </a:solidFill>
-          <a:ln>
-            <a:noFill/>
-          </a:ln>
-          <a:effectLst/>
-        </p:spPr>
-        <p:style>
-          <a:lnRef idx="1">
-            <a:schemeClr val="accent1"/>
-          </a:lnRef>
-          <a:fillRef idx="3">
-            <a:schemeClr val="accent1"/>
-          </a:fillRef>
-          <a:effectRef idx="2">
-            <a:schemeClr val="accent1"/>
-          </a:effectRef>
-          <a:fontRef idx="minor">
-            <a:schemeClr val="lt1"/>
-          </a:fontRef>
-        </p:style>
-        <p:txBody>
-          <a:bodyPr rtlCol="0" anchor="ctr"/>
-          <a:lstStyle/>
-          <a:p>
-            <a:pPr algn="ctr"/>
-          </a:p>
-        </p:txBody>
-      </p:sp>
-      <p:sp>
-        <p:nvSpPr>
-          <p:cNvPr id="19" name="TextBox 18"/>
-          <p:cNvSpPr txBox="1"/>
-          <p:nvPr/>
-        </p:nvSpPr>
-        <p:spPr>
-          <a:xfrm>
-            <a:off x="1325880" y="5632704"/>
-            <a:ext cx="9601200" cy="731520"/>
-          </a:xfrm>
-          <a:prstGeom prst="rect">
-            <a:avLst/>
-          </a:prstGeom>
-          <a:noFill/>
-        </p:spPr>
-        <p:txBody>
-          <a:bodyPr wrap="square" lIns="0" rIns="0" tIns="0" bIns="0">
-            <a:spAutoFit/>
-          </a:bodyPr>
-          <a:lstStyle/>
-          <a:p>
-            <a:pPr algn="l"/>
-            <a:r>
-              <a:rPr sz="2400" b="1" i="0">
-                <a:solidFill>
-                  <a:srgbClr val="16273D"/>
-                </a:solidFill>
-                <a:latin typeface="Arial"/>
-              </a:rPr>
-              <a:t>Fourth-down conviction</a:t>
-            </a:r>
-          </a:p>
-        </p:txBody>
-      </p:sp>
-      <p:sp>
-        <p:nvSpPr>
-          <p:cNvPr id="20" name="TextBox 19"/>
+          <p:cNvPr id="18" name="TextBox 17"/>
           <p:cNvSpPr txBox="1"/>
           <p:nvPr/>
         </p:nvSpPr>
@@ -16298,7 +15429,7 @@
                 </a:solidFill>
                 <a:latin typeface="Arial"/>
               </a:rPr>
-              <a:t>NEW — Golesh · Durkin kept</a:t>
+              <a:t>NEW — Golesh</a:t>
             </a:r>
           </a:p>
         </p:txBody>
@@ -16438,7 +15569,7 @@
                 </a:solidFill>
                 <a:latin typeface="Arial"/>
               </a:rPr>
-              <a:t>14% back · 39 portal adds</a:t>
+              <a:t>14% back</a:t>
             </a:r>
           </a:p>
         </p:txBody>
@@ -16451,7 +15582,7 @@
         </p:nvSpPr>
         <p:spPr>
           <a:xfrm>
-            <a:off x="914400" y="3291840"/>
+            <a:off x="914400" y="3383280"/>
             <a:ext cx="137160" cy="137160"/>
           </a:xfrm>
           <a:prstGeom prst="ellipse">
@@ -16495,7 +15626,7 @@
         </p:nvSpPr>
         <p:spPr>
           <a:xfrm>
-            <a:off x="1325880" y="3108960"/>
+            <a:off x="1325880" y="3200400"/>
             <a:ext cx="9601200" cy="731520"/>
           </a:xfrm>
           <a:prstGeom prst="rect">
@@ -16530,7 +15661,7 @@
         </p:nvSpPr>
         <p:spPr>
           <a:xfrm>
-            <a:off x="914400" y="4133088"/>
+            <a:off x="914400" y="4389120"/>
             <a:ext cx="137160" cy="137160"/>
           </a:xfrm>
           <a:prstGeom prst="ellipse">
@@ -16574,7 +15705,7 @@
         </p:nvSpPr>
         <p:spPr>
           <a:xfrm>
-            <a:off x="1325880" y="3950208"/>
+            <a:off x="1325880" y="4206240"/>
             <a:ext cx="9601200" cy="731520"/>
           </a:xfrm>
           <a:prstGeom prst="rect">
@@ -16609,7 +15740,7 @@
         </p:nvSpPr>
         <p:spPr>
           <a:xfrm>
-            <a:off x="914400" y="4974336"/>
+            <a:off x="914400" y="5394959"/>
             <a:ext cx="137160" cy="137160"/>
           </a:xfrm>
           <a:prstGeom prst="ellipse">
@@ -16653,7 +15784,7 @@
         </p:nvSpPr>
         <p:spPr>
           <a:xfrm>
-            <a:off x="1325880" y="4791456"/>
+            <a:off x="1325880" y="5212079"/>
             <a:ext cx="9601200" cy="731520"/>
           </a:xfrm>
           <a:prstGeom prst="rect">
@@ -16682,86 +15813,7 @@
       </p:sp>
       <p:sp>
         <p:nvSpPr>
-          <p:cNvPr id="18" name="Oval 17"/>
-          <p:cNvSpPr/>
-          <p:nvPr/>
-        </p:nvSpPr>
-        <p:spPr>
-          <a:xfrm>
-            <a:off x="914400" y="5815584"/>
-            <a:ext cx="137160" cy="137160"/>
-          </a:xfrm>
-          <a:prstGeom prst="ellipse">
-            <a:avLst/>
-          </a:prstGeom>
-          <a:solidFill>
-            <a:srgbClr val="F47321"/>
-          </a:solidFill>
-          <a:ln>
-            <a:noFill/>
-          </a:ln>
-          <a:effectLst/>
-        </p:spPr>
-        <p:style>
-          <a:lnRef idx="1">
-            <a:schemeClr val="accent1"/>
-          </a:lnRef>
-          <a:fillRef idx="3">
-            <a:schemeClr val="accent1"/>
-          </a:fillRef>
-          <a:effectRef idx="2">
-            <a:schemeClr val="accent1"/>
-          </a:effectRef>
-          <a:fontRef idx="minor">
-            <a:schemeClr val="lt1"/>
-          </a:fontRef>
-        </p:style>
-        <p:txBody>
-          <a:bodyPr rtlCol="0" anchor="ctr"/>
-          <a:lstStyle/>
-          <a:p>
-            <a:pPr algn="ctr"/>
-          </a:p>
-        </p:txBody>
-      </p:sp>
-      <p:sp>
-        <p:nvSpPr>
-          <p:cNvPr id="19" name="TextBox 18"/>
-          <p:cNvSpPr txBox="1"/>
-          <p:nvPr/>
-        </p:nvSpPr>
-        <p:spPr>
-          <a:xfrm>
-            <a:off x="1325880" y="5632704"/>
-            <a:ext cx="9601200" cy="731520"/>
-          </a:xfrm>
-          <a:prstGeom prst="rect">
-            <a:avLst/>
-          </a:prstGeom>
-          <a:noFill/>
-        </p:spPr>
-        <p:txBody>
-          <a:bodyPr wrap="square" lIns="0" rIns="0" tIns="0" bIns="0">
-            <a:spAutoFit/>
-          </a:bodyPr>
-          <a:lstStyle/>
-          <a:p>
-            <a:pPr algn="l"/>
-            <a:r>
-              <a:rPr sz="2400" b="1" i="0">
-                <a:solidFill>
-                  <a:srgbClr val="16273D"/>
-                </a:solidFill>
-                <a:latin typeface="Arial"/>
-              </a:rPr>
-              <a:t>Tempo without turnovers</a:t>
-            </a:r>
-          </a:p>
-        </p:txBody>
-      </p:sp>
-      <p:sp>
-        <p:nvSpPr>
-          <p:cNvPr id="20" name="TextBox 19"/>
+          <p:cNvPr id="18" name="TextBox 17"/>
           <p:cNvSpPr txBox="1"/>
           <p:nvPr/>
         </p:nvSpPr>
@@ -17016,7 +16068,7 @@
         </p:nvSpPr>
         <p:spPr>
           <a:xfrm>
-            <a:off x="868680" y="2212848"/>
+            <a:off x="868680" y="2231136"/>
             <a:ext cx="128016" cy="128016"/>
           </a:xfrm>
           <a:prstGeom prst="ellipse">
@@ -17061,7 +16113,7 @@
         <p:spPr>
           <a:xfrm>
             <a:off x="1188720" y="2057400"/>
-            <a:ext cx="6217920" cy="731520"/>
+            <a:ext cx="6217920" cy="822960"/>
           </a:xfrm>
           <a:prstGeom prst="rect">
             <a:avLst/>
@@ -17076,7 +16128,7 @@
           <a:p>
             <a:pPr algn="l"/>
             <a:r>
-              <a:rPr sz="2100" b="1" i="0">
+              <a:rPr sz="2400" b="1" i="0">
                 <a:solidFill>
                   <a:srgbClr val="16273D"/>
                 </a:solidFill>
@@ -17089,250 +16141,13 @@
       </p:sp>
       <p:sp>
         <p:nvSpPr>
-          <p:cNvPr id="10" name="Oval 9"/>
+          <p:cNvPr id="10" name="Rounded Rectangle 9"/>
           <p:cNvSpPr/>
           <p:nvPr/>
         </p:nvSpPr>
         <p:spPr>
           <a:xfrm>
-            <a:off x="868680" y="2926080"/>
-            <a:ext cx="128016" cy="128016"/>
-          </a:xfrm>
-          <a:prstGeom prst="ellipse">
-            <a:avLst/>
-          </a:prstGeom>
-          <a:solidFill>
-            <a:srgbClr val="F47321"/>
-          </a:solidFill>
-          <a:ln>
-            <a:noFill/>
-          </a:ln>
-          <a:effectLst/>
-        </p:spPr>
-        <p:style>
-          <a:lnRef idx="1">
-            <a:schemeClr val="accent1"/>
-          </a:lnRef>
-          <a:fillRef idx="3">
-            <a:schemeClr val="accent1"/>
-          </a:fillRef>
-          <a:effectRef idx="2">
-            <a:schemeClr val="accent1"/>
-          </a:effectRef>
-          <a:fontRef idx="minor">
-            <a:schemeClr val="lt1"/>
-          </a:fontRef>
-        </p:style>
-        <p:txBody>
-          <a:bodyPr rtlCol="0" anchor="ctr"/>
-          <a:lstStyle/>
-          <a:p>
-            <a:pPr algn="ctr"/>
-          </a:p>
-        </p:txBody>
-      </p:sp>
-      <p:sp>
-        <p:nvSpPr>
-          <p:cNvPr id="11" name="TextBox 10"/>
-          <p:cNvSpPr txBox="1"/>
-          <p:nvPr/>
-        </p:nvSpPr>
-        <p:spPr>
-          <a:xfrm>
-            <a:off x="1188720" y="2770632"/>
-            <a:ext cx="6217920" cy="731520"/>
-          </a:xfrm>
-          <a:prstGeom prst="rect">
-            <a:avLst/>
-          </a:prstGeom>
-          <a:noFill/>
-        </p:spPr>
-        <p:txBody>
-          <a:bodyPr wrap="square" lIns="0" rIns="0" tIns="0" bIns="0">
-            <a:spAutoFit/>
-          </a:bodyPr>
-          <a:lstStyle/>
-          <a:p>
-            <a:pPr algn="l"/>
-            <a:r>
-              <a:rPr sz="2100" b="1" i="0">
-                <a:solidFill>
-                  <a:srgbClr val="16273D"/>
-                </a:solidFill>
-                <a:latin typeface="Arial"/>
-              </a:rPr>
-              <a:t>Home team five straight</a:t>
-            </a:r>
-          </a:p>
-        </p:txBody>
-      </p:sp>
-      <p:sp>
-        <p:nvSpPr>
-          <p:cNvPr id="12" name="Oval 11"/>
-          <p:cNvSpPr/>
-          <p:nvPr/>
-        </p:nvSpPr>
-        <p:spPr>
-          <a:xfrm>
-            <a:off x="868680" y="3639312"/>
-            <a:ext cx="128016" cy="128016"/>
-          </a:xfrm>
-          <a:prstGeom prst="ellipse">
-            <a:avLst/>
-          </a:prstGeom>
-          <a:solidFill>
-            <a:srgbClr val="F47321"/>
-          </a:solidFill>
-          <a:ln>
-            <a:noFill/>
-          </a:ln>
-          <a:effectLst/>
-        </p:spPr>
-        <p:style>
-          <a:lnRef idx="1">
-            <a:schemeClr val="accent1"/>
-          </a:lnRef>
-          <a:fillRef idx="3">
-            <a:schemeClr val="accent1"/>
-          </a:fillRef>
-          <a:effectRef idx="2">
-            <a:schemeClr val="accent1"/>
-          </a:effectRef>
-          <a:fontRef idx="minor">
-            <a:schemeClr val="lt1"/>
-          </a:fontRef>
-        </p:style>
-        <p:txBody>
-          <a:bodyPr rtlCol="0" anchor="ctr"/>
-          <a:lstStyle/>
-          <a:p>
-            <a:pPr algn="ctr"/>
-          </a:p>
-        </p:txBody>
-      </p:sp>
-      <p:sp>
-        <p:nvSpPr>
-          <p:cNvPr id="13" name="TextBox 12"/>
-          <p:cNvSpPr txBox="1"/>
-          <p:nvPr/>
-        </p:nvSpPr>
-        <p:spPr>
-          <a:xfrm>
-            <a:off x="1188720" y="3483864"/>
-            <a:ext cx="6217920" cy="731520"/>
-          </a:xfrm>
-          <a:prstGeom prst="rect">
-            <a:avLst/>
-          </a:prstGeom>
-          <a:noFill/>
-        </p:spPr>
-        <p:txBody>
-          <a:bodyPr wrap="square" lIns="0" rIns="0" tIns="0" bIns="0">
-            <a:spAutoFit/>
-          </a:bodyPr>
-          <a:lstStyle/>
-          <a:p>
-            <a:pPr algn="l"/>
-            <a:r>
-              <a:rPr sz="2100" b="1" i="0">
-                <a:solidFill>
-                  <a:srgbClr val="16273D"/>
-                </a:solidFill>
-                <a:latin typeface="Arial"/>
-              </a:rPr>
-              <a:t>Leavitt's three picks</a:t>
-            </a:r>
-          </a:p>
-        </p:txBody>
-      </p:sp>
-      <p:sp>
-        <p:nvSpPr>
-          <p:cNvPr id="14" name="Oval 13"/>
-          <p:cNvSpPr/>
-          <p:nvPr/>
-        </p:nvSpPr>
-        <p:spPr>
-          <a:xfrm>
-            <a:off x="868680" y="4352544"/>
-            <a:ext cx="128016" cy="128016"/>
-          </a:xfrm>
-          <a:prstGeom prst="ellipse">
-            <a:avLst/>
-          </a:prstGeom>
-          <a:solidFill>
-            <a:srgbClr val="F47321"/>
-          </a:solidFill>
-          <a:ln>
-            <a:noFill/>
-          </a:ln>
-          <a:effectLst/>
-        </p:spPr>
-        <p:style>
-          <a:lnRef idx="1">
-            <a:schemeClr val="accent1"/>
-          </a:lnRef>
-          <a:fillRef idx="3">
-            <a:schemeClr val="accent1"/>
-          </a:fillRef>
-          <a:effectRef idx="2">
-            <a:schemeClr val="accent1"/>
-          </a:effectRef>
-          <a:fontRef idx="minor">
-            <a:schemeClr val="lt1"/>
-          </a:fontRef>
-        </p:style>
-        <p:txBody>
-          <a:bodyPr rtlCol="0" anchor="ctr"/>
-          <a:lstStyle/>
-          <a:p>
-            <a:pPr algn="ctr"/>
-          </a:p>
-        </p:txBody>
-      </p:sp>
-      <p:sp>
-        <p:nvSpPr>
-          <p:cNvPr id="15" name="TextBox 14"/>
-          <p:cNvSpPr txBox="1"/>
-          <p:nvPr/>
-        </p:nvSpPr>
-        <p:spPr>
-          <a:xfrm>
-            <a:off x="1188720" y="4197096"/>
-            <a:ext cx="6217920" cy="731520"/>
-          </a:xfrm>
-          <a:prstGeom prst="rect">
-            <a:avLst/>
-          </a:prstGeom>
-          <a:noFill/>
-        </p:spPr>
-        <p:txBody>
-          <a:bodyPr wrap="square" lIns="0" rIns="0" tIns="0" bIns="0">
-            <a:spAutoFit/>
-          </a:bodyPr>
-          <a:lstStyle/>
-          <a:p>
-            <a:pPr algn="l"/>
-            <a:r>
-              <a:rPr sz="2100" b="1" i="0">
-                <a:solidFill>
-                  <a:srgbClr val="16273D"/>
-                </a:solidFill>
-                <a:latin typeface="Arial"/>
-              </a:rPr>
-              <a:t>55–49 or 24–19</a:t>
-            </a:r>
-          </a:p>
-        </p:txBody>
-      </p:sp>
-      <p:sp>
-        <p:nvSpPr>
-          <p:cNvPr id="16" name="Rounded Rectangle 15"/>
-          <p:cNvSpPr/>
-          <p:nvPr/>
-        </p:nvSpPr>
-        <p:spPr>
-          <a:xfrm>
-            <a:off x="822960" y="5047488"/>
+            <a:off x="822960" y="4754880"/>
             <a:ext cx="6583680" cy="960120"/>
           </a:xfrm>
           <a:prstGeom prst="roundRect">
@@ -17370,13 +16185,13 @@
       </p:sp>
       <p:sp>
         <p:nvSpPr>
-          <p:cNvPr id="17" name="TextBox 16"/>
-          <p:cNvSpPr txBox="1"/>
-          <p:nvPr/>
-        </p:nvSpPr>
-        <p:spPr>
-          <a:xfrm>
-            <a:off x="1051560" y="5276088"/>
+          <p:cNvPr id="11" name="TextBox 10"/>
+          <p:cNvSpPr txBox="1"/>
+          <p:nvPr/>
+        </p:nvSpPr>
+        <p:spPr>
+          <a:xfrm>
+            <a:off x="1051560" y="4983480"/>
             <a:ext cx="6126480" cy="502920"/>
           </a:xfrm>
           <a:prstGeom prst="rect">
@@ -17405,7 +16220,7 @@
       </p:sp>
       <p:sp>
         <p:nvSpPr>
-          <p:cNvPr id="18" name="Rounded Rectangle 17"/>
+          <p:cNvPr id="12" name="Rounded Rectangle 11"/>
           <p:cNvSpPr/>
           <p:nvPr/>
         </p:nvSpPr>
@@ -17449,7 +16264,7 @@
       </p:sp>
       <p:sp>
         <p:nvSpPr>
-          <p:cNvPr id="19" name="TextBox 18"/>
+          <p:cNvPr id="13" name="TextBox 12"/>
           <p:cNvSpPr txBox="1"/>
           <p:nvPr/>
         </p:nvSpPr>
@@ -17484,7 +16299,7 @@
       </p:sp>
       <p:sp>
         <p:nvSpPr>
-          <p:cNvPr id="20" name="TextBox 19"/>
+          <p:cNvPr id="14" name="TextBox 13"/>
           <p:cNvSpPr txBox="1"/>
           <p:nvPr/>
         </p:nvSpPr>
@@ -17519,7 +16334,7 @@
       </p:sp>
       <p:sp>
         <p:nvSpPr>
-          <p:cNvPr id="21" name="TextBox 20"/>
+          <p:cNvPr id="15" name="TextBox 14"/>
           <p:cNvSpPr txBox="1"/>
           <p:nvPr/>
         </p:nvSpPr>
@@ -17554,7 +16369,7 @@
       </p:sp>
       <p:sp>
         <p:nvSpPr>
-          <p:cNvPr id="22" name="TextBox 21"/>
+          <p:cNvPr id="16" name="TextBox 15"/>
           <p:cNvSpPr txBox="1"/>
           <p:nvPr/>
         </p:nvSpPr>
@@ -17589,7 +16404,7 @@
       </p:sp>
       <p:sp>
         <p:nvSpPr>
-          <p:cNvPr id="23" name="TextBox 22"/>
+          <p:cNvPr id="17" name="TextBox 16"/>
           <p:cNvSpPr txBox="1"/>
           <p:nvPr/>
         </p:nvSpPr>
@@ -17624,7 +16439,7 @@
       </p:sp>
       <p:sp>
         <p:nvSpPr>
-          <p:cNvPr id="24" name="TextBox 23"/>
+          <p:cNvPr id="18" name="TextBox 17"/>
           <p:cNvSpPr txBox="1"/>
           <p:nvPr/>
         </p:nvSpPr>
@@ -17659,7 +16474,7 @@
       </p:sp>
       <p:sp>
         <p:nvSpPr>
-          <p:cNvPr id="25" name="TextBox 24"/>
+          <p:cNvPr id="19" name="TextBox 18"/>
           <p:cNvSpPr txBox="1"/>
           <p:nvPr/>
         </p:nvSpPr>
@@ -17694,7 +16509,7 @@
       </p:sp>
       <p:sp>
         <p:nvSpPr>
-          <p:cNvPr id="26" name="TextBox 25"/>
+          <p:cNvPr id="20" name="TextBox 19"/>
           <p:cNvSpPr txBox="1"/>
           <p:nvPr/>
         </p:nvSpPr>
@@ -17729,7 +16544,7 @@
       </p:sp>
       <p:sp>
         <p:nvSpPr>
-          <p:cNvPr id="27" name="Rounded Rectangle 26"/>
+          <p:cNvPr id="21" name="Rounded Rectangle 20"/>
           <p:cNvSpPr/>
           <p:nvPr/>
         </p:nvSpPr>
@@ -17773,7 +16588,7 @@
       </p:sp>
       <p:sp>
         <p:nvSpPr>
-          <p:cNvPr id="28" name="Rounded Rectangle 27"/>
+          <p:cNvPr id="22" name="Rounded Rectangle 21"/>
           <p:cNvSpPr/>
           <p:nvPr/>
         </p:nvSpPr>
@@ -17817,7 +16632,7 @@
       </p:sp>
       <p:sp>
         <p:nvSpPr>
-          <p:cNvPr id="29" name="TextBox 28"/>
+          <p:cNvPr id="23" name="TextBox 22"/>
           <p:cNvSpPr txBox="1"/>
           <p:nvPr/>
         </p:nvSpPr>
@@ -17852,7 +16667,7 @@
       </p:sp>
       <p:sp>
         <p:nvSpPr>
-          <p:cNvPr id="30" name="TextBox 29"/>
+          <p:cNvPr id="24" name="TextBox 23"/>
           <p:cNvSpPr txBox="1"/>
           <p:nvPr/>
         </p:nvSpPr>
@@ -17887,7 +16702,7 @@
       </p:sp>
       <p:sp>
         <p:nvSpPr>
-          <p:cNvPr id="31" name="TextBox 30"/>
+          <p:cNvPr id="25" name="TextBox 24"/>
           <p:cNvSpPr txBox="1"/>
           <p:nvPr/>
         </p:nvSpPr>
@@ -18289,7 +17104,7 @@
                 </a:solidFill>
                 <a:latin typeface="Arial"/>
               </a:rPr>
-              <a:t>21% back · 44 portal adds</a:t>
+              <a:t>21% back</a:t>
             </a:r>
           </a:p>
         </p:txBody>
@@ -18302,7 +17117,7 @@
         </p:nvSpPr>
         <p:spPr>
           <a:xfrm>
-            <a:off x="914400" y="3291840"/>
+            <a:off x="914400" y="3383280"/>
             <a:ext cx="137160" cy="137160"/>
           </a:xfrm>
           <a:prstGeom prst="ellipse">
@@ -18346,7 +17161,7 @@
         </p:nvSpPr>
         <p:spPr>
           <a:xfrm>
-            <a:off x="1325880" y="3108960"/>
+            <a:off x="1325880" y="3200400"/>
             <a:ext cx="9601200" cy="731520"/>
           </a:xfrm>
           <a:prstGeom prst="rect">
@@ -18381,7 +17196,7 @@
         </p:nvSpPr>
         <p:spPr>
           <a:xfrm>
-            <a:off x="914400" y="4133088"/>
+            <a:off x="914400" y="4389120"/>
             <a:ext cx="137160" cy="137160"/>
           </a:xfrm>
           <a:prstGeom prst="ellipse">
@@ -18425,7 +17240,7 @@
         </p:nvSpPr>
         <p:spPr>
           <a:xfrm>
-            <a:off x="1325880" y="3950208"/>
+            <a:off x="1325880" y="4206240"/>
             <a:ext cx="9601200" cy="731520"/>
           </a:xfrm>
           <a:prstGeom prst="rect">
@@ -18460,7 +17275,7 @@
         </p:nvSpPr>
         <p:spPr>
           <a:xfrm>
-            <a:off x="914400" y="4974336"/>
+            <a:off x="914400" y="5394959"/>
             <a:ext cx="137160" cy="137160"/>
           </a:xfrm>
           <a:prstGeom prst="ellipse">
@@ -18504,7 +17319,7 @@
         </p:nvSpPr>
         <p:spPr>
           <a:xfrm>
-            <a:off x="1325880" y="4791456"/>
+            <a:off x="1325880" y="5212079"/>
             <a:ext cx="9601200" cy="731520"/>
           </a:xfrm>
           <a:prstGeom prst="rect">
@@ -18533,86 +17348,7 @@
       </p:sp>
       <p:sp>
         <p:nvSpPr>
-          <p:cNvPr id="18" name="Oval 17"/>
-          <p:cNvSpPr/>
-          <p:nvPr/>
-        </p:nvSpPr>
-        <p:spPr>
-          <a:xfrm>
-            <a:off x="914400" y="5815584"/>
-            <a:ext cx="137160" cy="137160"/>
-          </a:xfrm>
-          <a:prstGeom prst="ellipse">
-            <a:avLst/>
-          </a:prstGeom>
-          <a:solidFill>
-            <a:srgbClr val="F47321"/>
-          </a:solidFill>
-          <a:ln>
-            <a:noFill/>
-          </a:ln>
-          <a:effectLst/>
-        </p:spPr>
-        <p:style>
-          <a:lnRef idx="1">
-            <a:schemeClr val="accent1"/>
-          </a:lnRef>
-          <a:fillRef idx="3">
-            <a:schemeClr val="accent1"/>
-          </a:fillRef>
-          <a:effectRef idx="2">
-            <a:schemeClr val="accent1"/>
-          </a:effectRef>
-          <a:fontRef idx="minor">
-            <a:schemeClr val="lt1"/>
-          </a:fontRef>
-        </p:style>
-        <p:txBody>
-          <a:bodyPr rtlCol="0" anchor="ctr"/>
-          <a:lstStyle/>
-          <a:p>
-            <a:pPr algn="ctr"/>
-          </a:p>
-        </p:txBody>
-      </p:sp>
-      <p:sp>
-        <p:nvSpPr>
-          <p:cNvPr id="19" name="TextBox 18"/>
-          <p:cNvSpPr txBox="1"/>
-          <p:nvPr/>
-        </p:nvSpPr>
-        <p:spPr>
-          <a:xfrm>
-            <a:off x="1325880" y="5632704"/>
-            <a:ext cx="9601200" cy="731520"/>
-          </a:xfrm>
-          <a:prstGeom prst="rect">
-            <a:avLst/>
-          </a:prstGeom>
-          <a:noFill/>
-        </p:spPr>
-        <p:txBody>
-          <a:bodyPr wrap="square" lIns="0" rIns="0" tIns="0" bIns="0">
-            <a:spAutoFit/>
-          </a:bodyPr>
-          <a:lstStyle/>
-          <a:p>
-            <a:pPr algn="l"/>
-            <a:r>
-              <a:rPr sz="2400" b="1" i="0">
-                <a:solidFill>
-                  <a:srgbClr val="16273D"/>
-                </a:solidFill>
-                <a:latin typeface="Arial"/>
-              </a:rPr>
-              <a:t>Kiffin's tempo in his old house</a:t>
-            </a:r>
-          </a:p>
-        </p:txBody>
-      </p:sp>
-      <p:sp>
-        <p:nvSpPr>
-          <p:cNvPr id="20" name="TextBox 19"/>
+          <p:cNvPr id="18" name="TextBox 17"/>
           <p:cNvSpPr txBox="1"/>
           <p:nvPr/>
         </p:nvSpPr>
@@ -23974,7 +22710,7 @@
                 </a:solidFill>
                 <a:latin typeface="Arial"/>
               </a:rPr>
-              <a:t>50% back · 28 portal adds</a:t>
+              <a:t>50% back</a:t>
             </a:r>
           </a:p>
         </p:txBody>
@@ -23987,7 +22723,7 @@
         </p:nvSpPr>
         <p:spPr>
           <a:xfrm>
-            <a:off x="914400" y="3291840"/>
+            <a:off x="914400" y="3383280"/>
             <a:ext cx="137160" cy="137160"/>
           </a:xfrm>
           <a:prstGeom prst="ellipse">
@@ -24031,7 +22767,7 @@
         </p:nvSpPr>
         <p:spPr>
           <a:xfrm>
-            <a:off x="1325880" y="3108960"/>
+            <a:off x="1325880" y="3200400"/>
             <a:ext cx="9601200" cy="731520"/>
           </a:xfrm>
           <a:prstGeom prst="rect">
@@ -24066,7 +22802,7 @@
         </p:nvSpPr>
         <p:spPr>
           <a:xfrm>
-            <a:off x="914400" y="4133088"/>
+            <a:off x="914400" y="4389120"/>
             <a:ext cx="137160" cy="137160"/>
           </a:xfrm>
           <a:prstGeom prst="ellipse">
@@ -24110,7 +22846,7 @@
         </p:nvSpPr>
         <p:spPr>
           <a:xfrm>
-            <a:off x="1325880" y="3950208"/>
+            <a:off x="1325880" y="4206240"/>
             <a:ext cx="9601200" cy="731520"/>
           </a:xfrm>
           <a:prstGeom prst="rect">
@@ -24145,7 +22881,7 @@
         </p:nvSpPr>
         <p:spPr>
           <a:xfrm>
-            <a:off x="914400" y="4974336"/>
+            <a:off x="914400" y="5394959"/>
             <a:ext cx="137160" cy="137160"/>
           </a:xfrm>
           <a:prstGeom prst="ellipse">
@@ -24189,7 +22925,7 @@
         </p:nvSpPr>
         <p:spPr>
           <a:xfrm>
-            <a:off x="1325880" y="4791456"/>
+            <a:off x="1325880" y="5212079"/>
             <a:ext cx="9601200" cy="731520"/>
           </a:xfrm>
           <a:prstGeom prst="rect">
@@ -24218,86 +22954,7 @@
       </p:sp>
       <p:sp>
         <p:nvSpPr>
-          <p:cNvPr id="18" name="Oval 17"/>
-          <p:cNvSpPr/>
-          <p:nvPr/>
-        </p:nvSpPr>
-        <p:spPr>
-          <a:xfrm>
-            <a:off x="914400" y="5815584"/>
-            <a:ext cx="137160" cy="137160"/>
-          </a:xfrm>
-          <a:prstGeom prst="ellipse">
-            <a:avLst/>
-          </a:prstGeom>
-          <a:solidFill>
-            <a:srgbClr val="F47321"/>
-          </a:solidFill>
-          <a:ln>
-            <a:noFill/>
-          </a:ln>
-          <a:effectLst/>
-        </p:spPr>
-        <p:style>
-          <a:lnRef idx="1">
-            <a:schemeClr val="accent1"/>
-          </a:lnRef>
-          <a:fillRef idx="3">
-            <a:schemeClr val="accent1"/>
-          </a:fillRef>
-          <a:effectRef idx="2">
-            <a:schemeClr val="accent1"/>
-          </a:effectRef>
-          <a:fontRef idx="minor">
-            <a:schemeClr val="lt1"/>
-          </a:fontRef>
-        </p:style>
-        <p:txBody>
-          <a:bodyPr rtlCol="0" anchor="ctr"/>
-          <a:lstStyle/>
-          <a:p>
-            <a:pPr algn="ctr"/>
-          </a:p>
-        </p:txBody>
-      </p:sp>
-      <p:sp>
-        <p:nvSpPr>
-          <p:cNvPr id="19" name="TextBox 18"/>
-          <p:cNvSpPr txBox="1"/>
-          <p:nvPr/>
-        </p:nvSpPr>
-        <p:spPr>
-          <a:xfrm>
-            <a:off x="1325880" y="5632704"/>
-            <a:ext cx="9601200" cy="731520"/>
-          </a:xfrm>
-          <a:prstGeom prst="rect">
-            <a:avLst/>
-          </a:prstGeom>
-          <a:noFill/>
-        </p:spPr>
-        <p:txBody>
-          <a:bodyPr wrap="square" lIns="0" rIns="0" tIns="0" bIns="0">
-            <a:spAutoFit/>
-          </a:bodyPr>
-          <a:lstStyle/>
-          <a:p>
-            <a:pPr algn="l"/>
-            <a:r>
-              <a:rPr sz="2400" b="1" i="0">
-                <a:solidFill>
-                  <a:srgbClr val="16273D"/>
-                </a:solidFill>
-                <a:latin typeface="Arial"/>
-              </a:rPr>
-              <a:t>Special teams edge</a:t>
-            </a:r>
-          </a:p>
-        </p:txBody>
-      </p:sp>
-      <p:sp>
-        <p:nvSpPr>
-          <p:cNvPr id="20" name="TextBox 19"/>
+          <p:cNvPr id="18" name="TextBox 17"/>
           <p:cNvSpPr txBox="1"/>
           <p:nvPr/>
         </p:nvSpPr>
@@ -32455,7 +31112,7 @@
         </p:nvSpPr>
         <p:spPr>
           <a:xfrm>
-            <a:off x="868680" y="2212848"/>
+            <a:off x="868680" y="2231136"/>
             <a:ext cx="128016" cy="128016"/>
           </a:xfrm>
           <a:prstGeom prst="ellipse">
@@ -32500,7 +31157,7 @@
         <p:spPr>
           <a:xfrm>
             <a:off x="1188720" y="2057400"/>
-            <a:ext cx="6217920" cy="731520"/>
+            <a:ext cx="6217920" cy="822960"/>
           </a:xfrm>
           <a:prstGeom prst="rect">
             <a:avLst/>
@@ -32515,7 +31172,7 @@
           <a:p>
             <a:pPr algn="l"/>
             <a:r>
-              <a:rPr sz="2100" b="1" i="0">
+              <a:rPr sz="2400" b="1" i="0">
                 <a:solidFill>
                   <a:srgbClr val="16273D"/>
                 </a:solidFill>
@@ -32528,250 +31185,13 @@
       </p:sp>
       <p:sp>
         <p:nvSpPr>
-          <p:cNvPr id="10" name="Oval 9"/>
+          <p:cNvPr id="10" name="Rounded Rectangle 9"/>
           <p:cNvSpPr/>
           <p:nvPr/>
         </p:nvSpPr>
         <p:spPr>
           <a:xfrm>
-            <a:off x="868680" y="2926080"/>
-            <a:ext cx="128016" cy="128016"/>
-          </a:xfrm>
-          <a:prstGeom prst="ellipse">
-            <a:avLst/>
-          </a:prstGeom>
-          <a:solidFill>
-            <a:srgbClr val="F47321"/>
-          </a:solidFill>
-          <a:ln>
-            <a:noFill/>
-          </a:ln>
-          <a:effectLst/>
-        </p:spPr>
-        <p:style>
-          <a:lnRef idx="1">
-            <a:schemeClr val="accent1"/>
-          </a:lnRef>
-          <a:fillRef idx="3">
-            <a:schemeClr val="accent1"/>
-          </a:fillRef>
-          <a:effectRef idx="2">
-            <a:schemeClr val="accent1"/>
-          </a:effectRef>
-          <a:fontRef idx="minor">
-            <a:schemeClr val="lt1"/>
-          </a:fontRef>
-        </p:style>
-        <p:txBody>
-          <a:bodyPr rtlCol="0" anchor="ctr"/>
-          <a:lstStyle/>
-          <a:p>
-            <a:pPr algn="ctr"/>
-          </a:p>
-        </p:txBody>
-      </p:sp>
-      <p:sp>
-        <p:nvSpPr>
-          <p:cNvPr id="11" name="TextBox 10"/>
-          <p:cNvSpPr txBox="1"/>
-          <p:nvPr/>
-        </p:nvSpPr>
-        <p:spPr>
-          <a:xfrm>
-            <a:off x="1188720" y="2770632"/>
-            <a:ext cx="6217920" cy="731520"/>
-          </a:xfrm>
-          <a:prstGeom prst="rect">
-            <a:avLst/>
-          </a:prstGeom>
-          <a:noFill/>
-        </p:spPr>
-        <p:txBody>
-          <a:bodyPr wrap="square" lIns="0" rIns="0" tIns="0" bIns="0">
-            <a:spAutoFit/>
-          </a:bodyPr>
-          <a:lstStyle/>
-          <a:p>
-            <a:pPr algn="l"/>
-            <a:r>
-              <a:rPr sz="2100" b="1" i="0">
-                <a:solidFill>
-                  <a:srgbClr val="16273D"/>
-                </a:solidFill>
-                <a:latin typeface="Arial"/>
-              </a:rPr>
-              <a:t>Fritz's year three</a:t>
-            </a:r>
-          </a:p>
-        </p:txBody>
-      </p:sp>
-      <p:sp>
-        <p:nvSpPr>
-          <p:cNvPr id="12" name="Oval 11"/>
-          <p:cNvSpPr/>
-          <p:nvPr/>
-        </p:nvSpPr>
-        <p:spPr>
-          <a:xfrm>
-            <a:off x="868680" y="3639312"/>
-            <a:ext cx="128016" cy="128016"/>
-          </a:xfrm>
-          <a:prstGeom prst="ellipse">
-            <a:avLst/>
-          </a:prstGeom>
-          <a:solidFill>
-            <a:srgbClr val="F47321"/>
-          </a:solidFill>
-          <a:ln>
-            <a:noFill/>
-          </a:ln>
-          <a:effectLst/>
-        </p:spPr>
-        <p:style>
-          <a:lnRef idx="1">
-            <a:schemeClr val="accent1"/>
-          </a:lnRef>
-          <a:fillRef idx="3">
-            <a:schemeClr val="accent1"/>
-          </a:fillRef>
-          <a:effectRef idx="2">
-            <a:schemeClr val="accent1"/>
-          </a:effectRef>
-          <a:fontRef idx="minor">
-            <a:schemeClr val="lt1"/>
-          </a:fontRef>
-        </p:style>
-        <p:txBody>
-          <a:bodyPr rtlCol="0" anchor="ctr"/>
-          <a:lstStyle/>
-          <a:p>
-            <a:pPr algn="ctr"/>
-          </a:p>
-        </p:txBody>
-      </p:sp>
-      <p:sp>
-        <p:nvSpPr>
-          <p:cNvPr id="13" name="TextBox 12"/>
-          <p:cNvSpPr txBox="1"/>
-          <p:nvPr/>
-        </p:nvSpPr>
-        <p:spPr>
-          <a:xfrm>
-            <a:off x="1188720" y="3483864"/>
-            <a:ext cx="6217920" cy="731520"/>
-          </a:xfrm>
-          <a:prstGeom prst="rect">
-            <a:avLst/>
-          </a:prstGeom>
-          <a:noFill/>
-        </p:spPr>
-        <p:txBody>
-          <a:bodyPr wrap="square" lIns="0" rIns="0" tIns="0" bIns="0">
-            <a:spAutoFit/>
-          </a:bodyPr>
-          <a:lstStyle/>
-          <a:p>
-            <a:pPr algn="l"/>
-            <a:r>
-              <a:rPr sz="2100" b="1" i="0">
-                <a:solidFill>
-                  <a:srgbClr val="16273D"/>
-                </a:solidFill>
-                <a:latin typeface="Arial"/>
-              </a:rPr>
-              <a:t>Hammond after the scare in Corvallis</a:t>
-            </a:r>
-          </a:p>
-        </p:txBody>
-      </p:sp>
-      <p:sp>
-        <p:nvSpPr>
-          <p:cNvPr id="14" name="Oval 13"/>
-          <p:cNvSpPr/>
-          <p:nvPr/>
-        </p:nvSpPr>
-        <p:spPr>
-          <a:xfrm>
-            <a:off x="868680" y="4352544"/>
-            <a:ext cx="128016" cy="128016"/>
-          </a:xfrm>
-          <a:prstGeom prst="ellipse">
-            <a:avLst/>
-          </a:prstGeom>
-          <a:solidFill>
-            <a:srgbClr val="F47321"/>
-          </a:solidFill>
-          <a:ln>
-            <a:noFill/>
-          </a:ln>
-          <a:effectLst/>
-        </p:spPr>
-        <p:style>
-          <a:lnRef idx="1">
-            <a:schemeClr val="accent1"/>
-          </a:lnRef>
-          <a:fillRef idx="3">
-            <a:schemeClr val="accent1"/>
-          </a:fillRef>
-          <a:effectRef idx="2">
-            <a:schemeClr val="accent1"/>
-          </a:effectRef>
-          <a:fontRef idx="minor">
-            <a:schemeClr val="lt1"/>
-          </a:fontRef>
-        </p:style>
-        <p:txBody>
-          <a:bodyPr rtlCol="0" anchor="ctr"/>
-          <a:lstStyle/>
-          <a:p>
-            <a:pPr algn="ctr"/>
-          </a:p>
-        </p:txBody>
-      </p:sp>
-      <p:sp>
-        <p:nvSpPr>
-          <p:cNvPr id="15" name="TextBox 14"/>
-          <p:cNvSpPr txBox="1"/>
-          <p:nvPr/>
-        </p:nvSpPr>
-        <p:spPr>
-          <a:xfrm>
-            <a:off x="1188720" y="4197096"/>
-            <a:ext cx="6217920" cy="731520"/>
-          </a:xfrm>
-          <a:prstGeom prst="rect">
-            <a:avLst/>
-          </a:prstGeom>
-          <a:noFill/>
-        </p:spPr>
-        <p:txBody>
-          <a:bodyPr wrap="square" lIns="0" rIns="0" tIns="0" bIns="0">
-            <a:spAutoFit/>
-          </a:bodyPr>
-          <a:lstStyle/>
-          <a:p>
-            <a:pPr algn="l"/>
-            <a:r>
-              <a:rPr sz="2100" b="1" i="0">
-                <a:solidFill>
-                  <a:srgbClr val="16273D"/>
-                </a:solidFill>
-                <a:latin typeface="Arial"/>
-              </a:rPr>
-              <a:t>Four straight for Tech in the series</a:t>
-            </a:r>
-          </a:p>
-        </p:txBody>
-      </p:sp>
-      <p:sp>
-        <p:nvSpPr>
-          <p:cNvPr id="16" name="Rounded Rectangle 15"/>
-          <p:cNvSpPr/>
-          <p:nvPr/>
-        </p:nvSpPr>
-        <p:spPr>
-          <a:xfrm>
-            <a:off x="822960" y="5047488"/>
+            <a:off x="822960" y="4754880"/>
             <a:ext cx="6583680" cy="960120"/>
           </a:xfrm>
           <a:prstGeom prst="roundRect">
@@ -32809,13 +31229,13 @@
       </p:sp>
       <p:sp>
         <p:nvSpPr>
-          <p:cNvPr id="17" name="TextBox 16"/>
-          <p:cNvSpPr txBox="1"/>
-          <p:nvPr/>
-        </p:nvSpPr>
-        <p:spPr>
-          <a:xfrm>
-            <a:off x="1051560" y="5276088"/>
+          <p:cNvPr id="11" name="TextBox 10"/>
+          <p:cNvSpPr txBox="1"/>
+          <p:nvPr/>
+        </p:nvSpPr>
+        <p:spPr>
+          <a:xfrm>
+            <a:off x="1051560" y="4983480"/>
             <a:ext cx="6126480" cy="502920"/>
           </a:xfrm>
           <a:prstGeom prst="rect">
@@ -32844,7 +31264,7 @@
       </p:sp>
       <p:sp>
         <p:nvSpPr>
-          <p:cNvPr id="18" name="Rounded Rectangle 17"/>
+          <p:cNvPr id="12" name="Rounded Rectangle 11"/>
           <p:cNvSpPr/>
           <p:nvPr/>
         </p:nvSpPr>
@@ -32888,7 +31308,7 @@
       </p:sp>
       <p:sp>
         <p:nvSpPr>
-          <p:cNvPr id="19" name="TextBox 18"/>
+          <p:cNvPr id="13" name="TextBox 12"/>
           <p:cNvSpPr txBox="1"/>
           <p:nvPr/>
         </p:nvSpPr>
@@ -32923,7 +31343,7 @@
       </p:sp>
       <p:sp>
         <p:nvSpPr>
-          <p:cNvPr id="20" name="TextBox 19"/>
+          <p:cNvPr id="14" name="TextBox 13"/>
           <p:cNvSpPr txBox="1"/>
           <p:nvPr/>
         </p:nvSpPr>
@@ -32958,7 +31378,7 @@
       </p:sp>
       <p:sp>
         <p:nvSpPr>
-          <p:cNvPr id="21" name="TextBox 20"/>
+          <p:cNvPr id="15" name="TextBox 14"/>
           <p:cNvSpPr txBox="1"/>
           <p:nvPr/>
         </p:nvSpPr>
@@ -32993,7 +31413,7 @@
       </p:sp>
       <p:sp>
         <p:nvSpPr>
-          <p:cNvPr id="22" name="TextBox 21"/>
+          <p:cNvPr id="16" name="TextBox 15"/>
           <p:cNvSpPr txBox="1"/>
           <p:nvPr/>
         </p:nvSpPr>
@@ -33028,7 +31448,7 @@
       </p:sp>
       <p:sp>
         <p:nvSpPr>
-          <p:cNvPr id="23" name="TextBox 22"/>
+          <p:cNvPr id="17" name="TextBox 16"/>
           <p:cNvSpPr txBox="1"/>
           <p:nvPr/>
         </p:nvSpPr>
@@ -33063,7 +31483,7 @@
       </p:sp>
       <p:sp>
         <p:nvSpPr>
-          <p:cNvPr id="24" name="TextBox 23"/>
+          <p:cNvPr id="18" name="TextBox 17"/>
           <p:cNvSpPr txBox="1"/>
           <p:nvPr/>
         </p:nvSpPr>
@@ -33098,7 +31518,7 @@
       </p:sp>
       <p:sp>
         <p:nvSpPr>
-          <p:cNvPr id="25" name="TextBox 24"/>
+          <p:cNvPr id="19" name="TextBox 18"/>
           <p:cNvSpPr txBox="1"/>
           <p:nvPr/>
         </p:nvSpPr>
@@ -33133,7 +31553,7 @@
       </p:sp>
       <p:sp>
         <p:nvSpPr>
-          <p:cNvPr id="26" name="TextBox 25"/>
+          <p:cNvPr id="20" name="TextBox 19"/>
           <p:cNvSpPr txBox="1"/>
           <p:nvPr/>
         </p:nvSpPr>
@@ -33168,7 +31588,7 @@
       </p:sp>
       <p:sp>
         <p:nvSpPr>
-          <p:cNvPr id="27" name="Rounded Rectangle 26"/>
+          <p:cNvPr id="21" name="Rounded Rectangle 20"/>
           <p:cNvSpPr/>
           <p:nvPr/>
         </p:nvSpPr>
@@ -33212,7 +31632,7 @@
       </p:sp>
       <p:sp>
         <p:nvSpPr>
-          <p:cNvPr id="28" name="Rounded Rectangle 27"/>
+          <p:cNvPr id="22" name="Rounded Rectangle 21"/>
           <p:cNvSpPr/>
           <p:nvPr/>
         </p:nvSpPr>
@@ -33256,7 +31676,7 @@
       </p:sp>
       <p:sp>
         <p:nvSpPr>
-          <p:cNvPr id="29" name="TextBox 28"/>
+          <p:cNvPr id="23" name="TextBox 22"/>
           <p:cNvSpPr txBox="1"/>
           <p:nvPr/>
         </p:nvSpPr>
@@ -33291,7 +31711,7 @@
       </p:sp>
       <p:sp>
         <p:nvSpPr>
-          <p:cNvPr id="30" name="TextBox 29"/>
+          <p:cNvPr id="24" name="TextBox 23"/>
           <p:cNvSpPr txBox="1"/>
           <p:nvPr/>
         </p:nvSpPr>
@@ -33326,7 +31746,7 @@
       </p:sp>
       <p:sp>
         <p:nvSpPr>
-          <p:cNvPr id="31" name="TextBox 30"/>
+          <p:cNvPr id="25" name="TextBox 24"/>
           <p:cNvSpPr txBox="1"/>
           <p:nvPr/>
         </p:nvSpPr>
@@ -33588,7 +32008,7 @@
                 </a:solidFill>
                 <a:latin typeface="Arial"/>
               </a:rPr>
-              <a:t>Fritz, year 3 · the year-three pattern</a:t>
+              <a:t>Fritz, year 3</a:t>
             </a:r>
           </a:p>
         </p:txBody>
@@ -33728,7 +32148,7 @@
                 </a:solidFill>
                 <a:latin typeface="Arial"/>
               </a:rPr>
-              <a:t>81% back · 18 portal adds</a:t>
+              <a:t>81% back</a:t>
             </a:r>
           </a:p>
         </p:txBody>
@@ -33741,7 +32161,7 @@
         </p:nvSpPr>
         <p:spPr>
           <a:xfrm>
-            <a:off x="914400" y="3291840"/>
+            <a:off x="914400" y="3383280"/>
             <a:ext cx="137160" cy="137160"/>
           </a:xfrm>
           <a:prstGeom prst="ellipse">
@@ -33785,7 +32205,7 @@
         </p:nvSpPr>
         <p:spPr>
           <a:xfrm>
-            <a:off x="1325880" y="3108960"/>
+            <a:off x="1325880" y="3200400"/>
             <a:ext cx="9601200" cy="731520"/>
           </a:xfrm>
           <a:prstGeom prst="rect">
@@ -33820,7 +32240,7 @@
         </p:nvSpPr>
         <p:spPr>
           <a:xfrm>
-            <a:off x="914400" y="4133088"/>
+            <a:off x="914400" y="4389120"/>
             <a:ext cx="137160" cy="137160"/>
           </a:xfrm>
           <a:prstGeom prst="ellipse">
@@ -33864,7 +32284,7 @@
         </p:nvSpPr>
         <p:spPr>
           <a:xfrm>
-            <a:off x="1325880" y="3950208"/>
+            <a:off x="1325880" y="4206240"/>
             <a:ext cx="9601200" cy="731520"/>
           </a:xfrm>
           <a:prstGeom prst="rect">
@@ -33899,7 +32319,7 @@
         </p:nvSpPr>
         <p:spPr>
           <a:xfrm>
-            <a:off x="914400" y="4974336"/>
+            <a:off x="914400" y="5394959"/>
             <a:ext cx="137160" cy="137160"/>
           </a:xfrm>
           <a:prstGeom prst="ellipse">
@@ -33943,7 +32363,7 @@
         </p:nvSpPr>
         <p:spPr>
           <a:xfrm>
-            <a:off x="1325880" y="4791456"/>
+            <a:off x="1325880" y="5212079"/>
             <a:ext cx="9601200" cy="731520"/>
           </a:xfrm>
           <a:prstGeom prst="rect">
@@ -33972,86 +32392,7 @@
       </p:sp>
       <p:sp>
         <p:nvSpPr>
-          <p:cNvPr id="18" name="Oval 17"/>
-          <p:cNvSpPr/>
-          <p:nvPr/>
-        </p:nvSpPr>
-        <p:spPr>
-          <a:xfrm>
-            <a:off x="914400" y="5815584"/>
-            <a:ext cx="137160" cy="137160"/>
-          </a:xfrm>
-          <a:prstGeom prst="ellipse">
-            <a:avLst/>
-          </a:prstGeom>
-          <a:solidFill>
-            <a:srgbClr val="F47321"/>
-          </a:solidFill>
-          <a:ln>
-            <a:noFill/>
-          </a:ln>
-          <a:effectLst/>
-        </p:spPr>
-        <p:style>
-          <a:lnRef idx="1">
-            <a:schemeClr val="accent1"/>
-          </a:lnRef>
-          <a:fillRef idx="3">
-            <a:schemeClr val="accent1"/>
-          </a:fillRef>
-          <a:effectRef idx="2">
-            <a:schemeClr val="accent1"/>
-          </a:effectRef>
-          <a:fontRef idx="minor">
-            <a:schemeClr val="lt1"/>
-          </a:fontRef>
-        </p:style>
-        <p:txBody>
-          <a:bodyPr rtlCol="0" anchor="ctr"/>
-          <a:lstStyle/>
-          <a:p>
-            <a:pPr algn="ctr"/>
-          </a:p>
-        </p:txBody>
-      </p:sp>
-      <p:sp>
-        <p:nvSpPr>
-          <p:cNvPr id="19" name="TextBox 18"/>
-          <p:cNvSpPr txBox="1"/>
-          <p:nvPr/>
-        </p:nvSpPr>
-        <p:spPr>
-          <a:xfrm>
-            <a:off x="1325880" y="5632704"/>
-            <a:ext cx="9601200" cy="731520"/>
-          </a:xfrm>
-          <a:prstGeom prst="rect">
-            <a:avLst/>
-          </a:prstGeom>
-          <a:noFill/>
-        </p:spPr>
-        <p:txBody>
-          <a:bodyPr wrap="square" lIns="0" rIns="0" tIns="0" bIns="0">
-            <a:spAutoFit/>
-          </a:bodyPr>
-          <a:lstStyle/>
-          <a:p>
-            <a:pPr algn="l"/>
-            <a:r>
-              <a:rPr sz="2400" b="1" i="0">
-                <a:solidFill>
-                  <a:srgbClr val="16273D"/>
-                </a:solidFill>
-                <a:latin typeface="Arial"/>
-              </a:rPr>
-              <a:t>Win the trenches</a:t>
-            </a:r>
-          </a:p>
-        </p:txBody>
-      </p:sp>
-      <p:sp>
-        <p:nvSpPr>
-          <p:cNvPr id="20" name="TextBox 19"/>
+          <p:cNvPr id="18" name="TextBox 17"/>
           <p:cNvSpPr txBox="1"/>
           <p:nvPr/>
         </p:nvSpPr>
@@ -34453,7 +32794,7 @@
                 </a:solidFill>
                 <a:latin typeface="Arial"/>
               </a:rPr>
-              <a:t>53% back · portal-built defense</a:t>
+              <a:t>53% back</a:t>
             </a:r>
           </a:p>
         </p:txBody>
@@ -34466,7 +32807,7 @@
         </p:nvSpPr>
         <p:spPr>
           <a:xfrm>
-            <a:off x="914400" y="3291840"/>
+            <a:off x="914400" y="3383280"/>
             <a:ext cx="137160" cy="137160"/>
           </a:xfrm>
           <a:prstGeom prst="ellipse">
@@ -34510,7 +32851,7 @@
         </p:nvSpPr>
         <p:spPr>
           <a:xfrm>
-            <a:off x="1325880" y="3108960"/>
+            <a:off x="1325880" y="3200400"/>
             <a:ext cx="9601200" cy="731520"/>
           </a:xfrm>
           <a:prstGeom prst="rect">
@@ -34545,7 +32886,7 @@
         </p:nvSpPr>
         <p:spPr>
           <a:xfrm>
-            <a:off x="914400" y="4133088"/>
+            <a:off x="914400" y="4389120"/>
             <a:ext cx="137160" cy="137160"/>
           </a:xfrm>
           <a:prstGeom prst="ellipse">
@@ -34589,7 +32930,7 @@
         </p:nvSpPr>
         <p:spPr>
           <a:xfrm>
-            <a:off x="1325880" y="3950208"/>
+            <a:off x="1325880" y="4206240"/>
             <a:ext cx="9601200" cy="731520"/>
           </a:xfrm>
           <a:prstGeom prst="rect">
@@ -34624,7 +32965,7 @@
         </p:nvSpPr>
         <p:spPr>
           <a:xfrm>
-            <a:off x="914400" y="4974336"/>
+            <a:off x="914400" y="5394959"/>
             <a:ext cx="137160" cy="137160"/>
           </a:xfrm>
           <a:prstGeom prst="ellipse">
@@ -34668,7 +33009,7 @@
         </p:nvSpPr>
         <p:spPr>
           <a:xfrm>
-            <a:off x="1325880" y="4791456"/>
+            <a:off x="1325880" y="5212079"/>
             <a:ext cx="9601200" cy="731520"/>
           </a:xfrm>
           <a:prstGeom prst="rect">
@@ -34697,86 +33038,7 @@
       </p:sp>
       <p:sp>
         <p:nvSpPr>
-          <p:cNvPr id="18" name="Oval 17"/>
-          <p:cNvSpPr/>
-          <p:nvPr/>
-        </p:nvSpPr>
-        <p:spPr>
-          <a:xfrm>
-            <a:off x="914400" y="5815584"/>
-            <a:ext cx="137160" cy="137160"/>
-          </a:xfrm>
-          <a:prstGeom prst="ellipse">
-            <a:avLst/>
-          </a:prstGeom>
-          <a:solidFill>
-            <a:srgbClr val="F47321"/>
-          </a:solidFill>
-          <a:ln>
-            <a:noFill/>
-          </a:ln>
-          <a:effectLst/>
-        </p:spPr>
-        <p:style>
-          <a:lnRef idx="1">
-            <a:schemeClr val="accent1"/>
-          </a:lnRef>
-          <a:fillRef idx="3">
-            <a:schemeClr val="accent1"/>
-          </a:fillRef>
-          <a:effectRef idx="2">
-            <a:schemeClr val="accent1"/>
-          </a:effectRef>
-          <a:fontRef idx="minor">
-            <a:schemeClr val="lt1"/>
-          </a:fontRef>
-        </p:style>
-        <p:txBody>
-          <a:bodyPr rtlCol="0" anchor="ctr"/>
-          <a:lstStyle/>
-          <a:p>
-            <a:pPr algn="ctr"/>
-          </a:p>
-        </p:txBody>
-      </p:sp>
-      <p:sp>
-        <p:nvSpPr>
-          <p:cNvPr id="19" name="TextBox 18"/>
-          <p:cNvSpPr txBox="1"/>
-          <p:nvPr/>
-        </p:nvSpPr>
-        <p:spPr>
-          <a:xfrm>
-            <a:off x="1325880" y="5632704"/>
-            <a:ext cx="9601200" cy="731520"/>
-          </a:xfrm>
-          <a:prstGeom prst="rect">
-            <a:avLst/>
-          </a:prstGeom>
-          <a:noFill/>
-        </p:spPr>
-        <p:txBody>
-          <a:bodyPr wrap="square" lIns="0" rIns="0" tIns="0" bIns="0">
-            <a:spAutoFit/>
-          </a:bodyPr>
-          <a:lstStyle/>
-          <a:p>
-            <a:pPr algn="l"/>
-            <a:r>
-              <a:rPr sz="2400" b="1" i="0">
-                <a:solidFill>
-                  <a:srgbClr val="16273D"/>
-                </a:solidFill>
-                <a:latin typeface="Arial"/>
-              </a:rPr>
-              <a:t>Finish drives</a:t>
-            </a:r>
-          </a:p>
-        </p:txBody>
-      </p:sp>
-      <p:sp>
-        <p:nvSpPr>
-          <p:cNvPr id="20" name="TextBox 19"/>
+          <p:cNvPr id="18" name="TextBox 17"/>
           <p:cNvSpPr txBox="1"/>
           <p:nvPr/>
         </p:nvSpPr>
@@ -35031,7 +33293,7 @@
         </p:nvSpPr>
         <p:spPr>
           <a:xfrm>
-            <a:off x="868680" y="2212848"/>
+            <a:off x="868680" y="2231136"/>
             <a:ext cx="128016" cy="128016"/>
           </a:xfrm>
           <a:prstGeom prst="ellipse">
@@ -35076,7 +33338,7 @@
         <p:spPr>
           <a:xfrm>
             <a:off x="1188720" y="2057400"/>
-            <a:ext cx="6217920" cy="731520"/>
+            <a:ext cx="6217920" cy="822960"/>
           </a:xfrm>
           <a:prstGeom prst="rect">
             <a:avLst/>
@@ -35091,7 +33353,7 @@
           <a:p>
             <a:pPr algn="l"/>
             <a:r>
-              <a:rPr sz="2100" b="1" i="0">
+              <a:rPr sz="2400" b="1" i="0">
                 <a:solidFill>
                   <a:srgbClr val="16273D"/>
                 </a:solidFill>
@@ -35104,250 +33366,13 @@
       </p:sp>
       <p:sp>
         <p:nvSpPr>
-          <p:cNvPr id="10" name="Oval 9"/>
+          <p:cNvPr id="10" name="Rounded Rectangle 9"/>
           <p:cNvSpPr/>
           <p:nvPr/>
         </p:nvSpPr>
         <p:spPr>
           <a:xfrm>
-            <a:off x="868680" y="2926080"/>
-            <a:ext cx="128016" cy="128016"/>
-          </a:xfrm>
-          <a:prstGeom prst="ellipse">
-            <a:avLst/>
-          </a:prstGeom>
-          <a:solidFill>
-            <a:srgbClr val="F47321"/>
-          </a:solidFill>
-          <a:ln>
-            <a:noFill/>
-          </a:ln>
-          <a:effectLst/>
-        </p:spPr>
-        <p:style>
-          <a:lnRef idx="1">
-            <a:schemeClr val="accent1"/>
-          </a:lnRef>
-          <a:fillRef idx="3">
-            <a:schemeClr val="accent1"/>
-          </a:fillRef>
-          <a:effectRef idx="2">
-            <a:schemeClr val="accent1"/>
-          </a:effectRef>
-          <a:fontRef idx="minor">
-            <a:schemeClr val="lt1"/>
-          </a:fontRef>
-        </p:style>
-        <p:txBody>
-          <a:bodyPr rtlCol="0" anchor="ctr"/>
-          <a:lstStyle/>
-          <a:p>
-            <a:pPr algn="ctr"/>
-          </a:p>
-        </p:txBody>
-      </p:sp>
-      <p:sp>
-        <p:nvSpPr>
-          <p:cNvPr id="11" name="TextBox 10"/>
-          <p:cNvSpPr txBox="1"/>
-          <p:nvPr/>
-        </p:nvSpPr>
-        <p:spPr>
-          <a:xfrm>
-            <a:off x="1188720" y="2770632"/>
-            <a:ext cx="6217920" cy="731520"/>
-          </a:xfrm>
-          <a:prstGeom prst="rect">
-            <a:avLst/>
-          </a:prstGeom>
-          <a:noFill/>
-        </p:spPr>
-        <p:txBody>
-          <a:bodyPr wrap="square" lIns="0" rIns="0" tIns="0" bIns="0">
-            <a:spAutoFit/>
-          </a:bodyPr>
-          <a:lstStyle/>
-          <a:p>
-            <a:pPr algn="l"/>
-            <a:r>
-              <a:rPr sz="2100" b="1" i="0">
-                <a:solidFill>
-                  <a:srgbClr val="16273D"/>
-                </a:solidFill>
-                <a:latin typeface="Arial"/>
-              </a:rPr>
-              <a:t>Jennings, year three</a:t>
-            </a:r>
-          </a:p>
-        </p:txBody>
-      </p:sp>
-      <p:sp>
-        <p:nvSpPr>
-          <p:cNvPr id="12" name="Oval 11"/>
-          <p:cNvSpPr/>
-          <p:nvPr/>
-        </p:nvSpPr>
-        <p:spPr>
-          <a:xfrm>
-            <a:off x="868680" y="3639312"/>
-            <a:ext cx="128016" cy="128016"/>
-          </a:xfrm>
-          <a:prstGeom prst="ellipse">
-            <a:avLst/>
-          </a:prstGeom>
-          <a:solidFill>
-            <a:srgbClr val="F47321"/>
-          </a:solidFill>
-          <a:ln>
-            <a:noFill/>
-          </a:ln>
-          <a:effectLst/>
-        </p:spPr>
-        <p:style>
-          <a:lnRef idx="1">
-            <a:schemeClr val="accent1"/>
-          </a:lnRef>
-          <a:fillRef idx="3">
-            <a:schemeClr val="accent1"/>
-          </a:fillRef>
-          <a:effectRef idx="2">
-            <a:schemeClr val="accent1"/>
-          </a:effectRef>
-          <a:fontRef idx="minor">
-            <a:schemeClr val="lt1"/>
-          </a:fontRef>
-        </p:style>
-        <p:txBody>
-          <a:bodyPr rtlCol="0" anchor="ctr"/>
-          <a:lstStyle/>
-          <a:p>
-            <a:pPr algn="ctr"/>
-          </a:p>
-        </p:txBody>
-      </p:sp>
-      <p:sp>
-        <p:nvSpPr>
-          <p:cNvPr id="13" name="TextBox 12"/>
-          <p:cNvSpPr txBox="1"/>
-          <p:nvPr/>
-        </p:nvSpPr>
-        <p:spPr>
-          <a:xfrm>
-            <a:off x="1188720" y="3483864"/>
-            <a:ext cx="6217920" cy="731520"/>
-          </a:xfrm>
-          <a:prstGeom prst="rect">
-            <a:avLst/>
-          </a:prstGeom>
-          <a:noFill/>
-        </p:spPr>
-        <p:txBody>
-          <a:bodyPr wrap="square" lIns="0" rIns="0" tIns="0" bIns="0">
-            <a:spAutoFit/>
-          </a:bodyPr>
-          <a:lstStyle/>
-          <a:p>
-            <a:pPr algn="l"/>
-            <a:r>
-              <a:rPr sz="2100" b="1" i="0">
-                <a:solidFill>
-                  <a:srgbClr val="16273D"/>
-                </a:solidFill>
-                <a:latin typeface="Arial"/>
-              </a:rPr>
-              <a:t>Brohm's coin-flip problem</a:t>
-            </a:r>
-          </a:p>
-        </p:txBody>
-      </p:sp>
-      <p:sp>
-        <p:nvSpPr>
-          <p:cNvPr id="14" name="Oval 13"/>
-          <p:cNvSpPr/>
-          <p:nvPr/>
-        </p:nvSpPr>
-        <p:spPr>
-          <a:xfrm>
-            <a:off x="868680" y="4352544"/>
-            <a:ext cx="128016" cy="128016"/>
-          </a:xfrm>
-          <a:prstGeom prst="ellipse">
-            <a:avLst/>
-          </a:prstGeom>
-          <a:solidFill>
-            <a:srgbClr val="F47321"/>
-          </a:solidFill>
-          <a:ln>
-            <a:noFill/>
-          </a:ln>
-          <a:effectLst/>
-        </p:spPr>
-        <p:style>
-          <a:lnRef idx="1">
-            <a:schemeClr val="accent1"/>
-          </a:lnRef>
-          <a:fillRef idx="3">
-            <a:schemeClr val="accent1"/>
-          </a:fillRef>
-          <a:effectRef idx="2">
-            <a:schemeClr val="accent1"/>
-          </a:effectRef>
-          <a:fontRef idx="minor">
-            <a:schemeClr val="lt1"/>
-          </a:fontRef>
-        </p:style>
-        <p:txBody>
-          <a:bodyPr rtlCol="0" anchor="ctr"/>
-          <a:lstStyle/>
-          <a:p>
-            <a:pPr algn="ctr"/>
-          </a:p>
-        </p:txBody>
-      </p:sp>
-      <p:sp>
-        <p:nvSpPr>
-          <p:cNvPr id="15" name="TextBox 14"/>
-          <p:cNvSpPr txBox="1"/>
-          <p:nvPr/>
-        </p:nvSpPr>
-        <p:spPr>
-          <a:xfrm>
-            <a:off x="1188720" y="4197096"/>
-            <a:ext cx="6217920" cy="731520"/>
-          </a:xfrm>
-          <a:prstGeom prst="rect">
-            <a:avLst/>
-          </a:prstGeom>
-          <a:noFill/>
-        </p:spPr>
-        <p:txBody>
-          <a:bodyPr wrap="square" lIns="0" rIns="0" tIns="0" bIns="0">
-            <a:spAutoFit/>
-          </a:bodyPr>
-          <a:lstStyle/>
-          <a:p>
-            <a:pPr algn="l"/>
-            <a:r>
-              <a:rPr sz="2100" b="1" i="0">
-                <a:solidFill>
-                  <a:srgbClr val="16273D"/>
-                </a:solidFill>
-                <a:latin typeface="Arial"/>
-              </a:rPr>
-              <a:t>Both offenses score fast</a:t>
-            </a:r>
-          </a:p>
-        </p:txBody>
-      </p:sp>
-      <p:sp>
-        <p:nvSpPr>
-          <p:cNvPr id="16" name="Rounded Rectangle 15"/>
-          <p:cNvSpPr/>
-          <p:nvPr/>
-        </p:nvSpPr>
-        <p:spPr>
-          <a:xfrm>
-            <a:off x="822960" y="5047488"/>
+            <a:off x="822960" y="4754880"/>
             <a:ext cx="6583680" cy="960120"/>
           </a:xfrm>
           <a:prstGeom prst="roundRect">
@@ -35385,13 +33410,13 @@
       </p:sp>
       <p:sp>
         <p:nvSpPr>
-          <p:cNvPr id="17" name="TextBox 16"/>
-          <p:cNvSpPr txBox="1"/>
-          <p:nvPr/>
-        </p:nvSpPr>
-        <p:spPr>
-          <a:xfrm>
-            <a:off x="1051560" y="5276088"/>
+          <p:cNvPr id="11" name="TextBox 10"/>
+          <p:cNvSpPr txBox="1"/>
+          <p:nvPr/>
+        </p:nvSpPr>
+        <p:spPr>
+          <a:xfrm>
+            <a:off x="1051560" y="4983480"/>
             <a:ext cx="6126480" cy="502920"/>
           </a:xfrm>
           <a:prstGeom prst="rect">
@@ -35420,7 +33445,7 @@
       </p:sp>
       <p:sp>
         <p:nvSpPr>
-          <p:cNvPr id="18" name="Rounded Rectangle 17"/>
+          <p:cNvPr id="12" name="Rounded Rectangle 11"/>
           <p:cNvSpPr/>
           <p:nvPr/>
         </p:nvSpPr>
@@ -35464,7 +33489,7 @@
       </p:sp>
       <p:sp>
         <p:nvSpPr>
-          <p:cNvPr id="19" name="TextBox 18"/>
+          <p:cNvPr id="13" name="TextBox 12"/>
           <p:cNvSpPr txBox="1"/>
           <p:nvPr/>
         </p:nvSpPr>
@@ -35499,7 +33524,7 @@
       </p:sp>
       <p:sp>
         <p:nvSpPr>
-          <p:cNvPr id="20" name="TextBox 19"/>
+          <p:cNvPr id="14" name="TextBox 13"/>
           <p:cNvSpPr txBox="1"/>
           <p:nvPr/>
         </p:nvSpPr>
@@ -35534,7 +33559,7 @@
       </p:sp>
       <p:sp>
         <p:nvSpPr>
-          <p:cNvPr id="21" name="TextBox 20"/>
+          <p:cNvPr id="15" name="TextBox 14"/>
           <p:cNvSpPr txBox="1"/>
           <p:nvPr/>
         </p:nvSpPr>
@@ -35569,7 +33594,7 @@
       </p:sp>
       <p:sp>
         <p:nvSpPr>
-          <p:cNvPr id="22" name="TextBox 21"/>
+          <p:cNvPr id="16" name="TextBox 15"/>
           <p:cNvSpPr txBox="1"/>
           <p:nvPr/>
         </p:nvSpPr>
@@ -35604,7 +33629,7 @@
       </p:sp>
       <p:sp>
         <p:nvSpPr>
-          <p:cNvPr id="23" name="TextBox 22"/>
+          <p:cNvPr id="17" name="TextBox 16"/>
           <p:cNvSpPr txBox="1"/>
           <p:nvPr/>
         </p:nvSpPr>
@@ -35639,7 +33664,7 @@
       </p:sp>
       <p:sp>
         <p:nvSpPr>
-          <p:cNvPr id="24" name="TextBox 23"/>
+          <p:cNvPr id="18" name="TextBox 17"/>
           <p:cNvSpPr txBox="1"/>
           <p:nvPr/>
         </p:nvSpPr>
@@ -35674,7 +33699,7 @@
       </p:sp>
       <p:sp>
         <p:nvSpPr>
-          <p:cNvPr id="25" name="TextBox 24"/>
+          <p:cNvPr id="19" name="TextBox 18"/>
           <p:cNvSpPr txBox="1"/>
           <p:nvPr/>
         </p:nvSpPr>
@@ -35709,7 +33734,7 @@
       </p:sp>
       <p:sp>
         <p:nvSpPr>
-          <p:cNvPr id="26" name="TextBox 25"/>
+          <p:cNvPr id="20" name="TextBox 19"/>
           <p:cNvSpPr txBox="1"/>
           <p:nvPr/>
         </p:nvSpPr>
@@ -35744,7 +33769,7 @@
       </p:sp>
       <p:sp>
         <p:nvSpPr>
-          <p:cNvPr id="27" name="Rounded Rectangle 26"/>
+          <p:cNvPr id="21" name="Rounded Rectangle 20"/>
           <p:cNvSpPr/>
           <p:nvPr/>
         </p:nvSpPr>
@@ -35788,7 +33813,7 @@
       </p:sp>
       <p:sp>
         <p:nvSpPr>
-          <p:cNvPr id="28" name="Rounded Rectangle 27"/>
+          <p:cNvPr id="22" name="Rounded Rectangle 21"/>
           <p:cNvSpPr/>
           <p:nvPr/>
         </p:nvSpPr>
@@ -35832,7 +33857,7 @@
       </p:sp>
       <p:sp>
         <p:nvSpPr>
-          <p:cNvPr id="29" name="TextBox 28"/>
+          <p:cNvPr id="23" name="TextBox 22"/>
           <p:cNvSpPr txBox="1"/>
           <p:nvPr/>
         </p:nvSpPr>
@@ -35867,7 +33892,7 @@
       </p:sp>
       <p:sp>
         <p:nvSpPr>
-          <p:cNvPr id="30" name="TextBox 29"/>
+          <p:cNvPr id="24" name="TextBox 23"/>
           <p:cNvSpPr txBox="1"/>
           <p:nvPr/>
         </p:nvSpPr>
@@ -35902,7 +33927,7 @@
       </p:sp>
       <p:sp>
         <p:nvSpPr>
-          <p:cNvPr id="31" name="TextBox 30"/>
+          <p:cNvPr id="25" name="TextBox 24"/>
           <p:cNvSpPr txBox="1"/>
           <p:nvPr/>
         </p:nvSpPr>

</xml_diff>